<commit_message>
feat(course): complete course 2.0 lesson and slide revisions
</commit_message>
<xml_diff>
--- a/lessons/lesson-02/slides.pptx
+++ b/lessons/lesson-02/slides.pptx
@@ -2,41 +2,42 @@
 <file path=ppt/presentation.xml><?xml version="1.0" encoding="utf-8"?>
 <p:presentation xmlns:p="http://schemas.openxmlformats.org/presentationml/2006/main">
   <p:sldMasterIdLst>
-    <p:sldMasterId xmlns:r="http://schemas.openxmlformats.org/officeDocument/2006/relationships" id="2147483648" r:id="R65795c4c03134404"/>
+    <p:sldMasterId xmlns:r="http://schemas.openxmlformats.org/officeDocument/2006/relationships" id="2147483648" r:id="R068830980fe240f1"/>
   </p:sldMasterIdLst>
   <p:notesMasterIdLst>
-    <p:notesMasterId xmlns:r="http://schemas.openxmlformats.org/officeDocument/2006/relationships" r:id="Rc289f80d5ca549c1"/>
+    <p:notesMasterId xmlns:r="http://schemas.openxmlformats.org/officeDocument/2006/relationships" r:id="Rf3cdda48fc28424f"/>
   </p:notesMasterIdLst>
   <p:sldIdLst>
-    <p:sldId xmlns:r="http://schemas.openxmlformats.org/officeDocument/2006/relationships" id="256" r:id="R22369910395f4efc"/>
-    <p:sldId xmlns:r="http://schemas.openxmlformats.org/officeDocument/2006/relationships" id="257" r:id="R45ed823e92e1435c"/>
-    <p:sldId xmlns:r="http://schemas.openxmlformats.org/officeDocument/2006/relationships" id="258" r:id="Rce222f6df69648a6"/>
-    <p:sldId xmlns:r="http://schemas.openxmlformats.org/officeDocument/2006/relationships" id="259" r:id="R78e1135599bf49d5"/>
-    <p:sldId xmlns:r="http://schemas.openxmlformats.org/officeDocument/2006/relationships" id="260" r:id="Re372c68eed774af6"/>
-    <p:sldId xmlns:r="http://schemas.openxmlformats.org/officeDocument/2006/relationships" id="261" r:id="Re0ef017d789f47e0"/>
-    <p:sldId xmlns:r="http://schemas.openxmlformats.org/officeDocument/2006/relationships" id="262" r:id="Rd16694f2018a4775"/>
-    <p:sldId xmlns:r="http://schemas.openxmlformats.org/officeDocument/2006/relationships" id="263" r:id="R9834daa8ce474194"/>
-    <p:sldId xmlns:r="http://schemas.openxmlformats.org/officeDocument/2006/relationships" id="264" r:id="Raf8f87933a624f1e"/>
-    <p:sldId xmlns:r="http://schemas.openxmlformats.org/officeDocument/2006/relationships" id="265" r:id="R7b4245a7200e4e73"/>
-    <p:sldId xmlns:r="http://schemas.openxmlformats.org/officeDocument/2006/relationships" id="266" r:id="Raba17d9b870d44dd"/>
-    <p:sldId xmlns:r="http://schemas.openxmlformats.org/officeDocument/2006/relationships" id="267" r:id="R41a52aa1eb124811"/>
-    <p:sldId xmlns:r="http://schemas.openxmlformats.org/officeDocument/2006/relationships" id="268" r:id="R4d7b8bcc9c6140f3"/>
-    <p:sldId xmlns:r="http://schemas.openxmlformats.org/officeDocument/2006/relationships" id="269" r:id="R1e592c34fb5f4610"/>
-    <p:sldId xmlns:r="http://schemas.openxmlformats.org/officeDocument/2006/relationships" id="270" r:id="R556c02d38b294b36"/>
-    <p:sldId xmlns:r="http://schemas.openxmlformats.org/officeDocument/2006/relationships" id="271" r:id="Rada41cab0a994273"/>
-    <p:sldId xmlns:r="http://schemas.openxmlformats.org/officeDocument/2006/relationships" id="272" r:id="Rf6d1d4e317564530"/>
-    <p:sldId xmlns:r="http://schemas.openxmlformats.org/officeDocument/2006/relationships" id="273" r:id="R03887bf968624e1e"/>
-    <p:sldId xmlns:r="http://schemas.openxmlformats.org/officeDocument/2006/relationships" id="274" r:id="R4433ffd628024fc5"/>
-    <p:sldId xmlns:r="http://schemas.openxmlformats.org/officeDocument/2006/relationships" id="275" r:id="R6d692001a05f4e6a"/>
-    <p:sldId xmlns:r="http://schemas.openxmlformats.org/officeDocument/2006/relationships" id="276" r:id="Rfd278f639f6947c6"/>
-    <p:sldId xmlns:r="http://schemas.openxmlformats.org/officeDocument/2006/relationships" id="277" r:id="R9c65cf3b203e40a8"/>
-    <p:sldId xmlns:r="http://schemas.openxmlformats.org/officeDocument/2006/relationships" id="278" r:id="R4d6ad5b7c9df41c0"/>
-    <p:sldId xmlns:r="http://schemas.openxmlformats.org/officeDocument/2006/relationships" id="279" r:id="Rb5dce7c1c73b4607"/>
-    <p:sldId xmlns:r="http://schemas.openxmlformats.org/officeDocument/2006/relationships" id="280" r:id="R3f327c117bf747b4"/>
-    <p:sldId xmlns:r="http://schemas.openxmlformats.org/officeDocument/2006/relationships" id="281" r:id="R2e8357345ecf4769"/>
-    <p:sldId xmlns:r="http://schemas.openxmlformats.org/officeDocument/2006/relationships" id="282" r:id="Re6b8441fc72f431a"/>
-    <p:sldId xmlns:r="http://schemas.openxmlformats.org/officeDocument/2006/relationships" id="283" r:id="Rf796fdae1c424bbb"/>
-    <p:sldId xmlns:r="http://schemas.openxmlformats.org/officeDocument/2006/relationships" id="284" r:id="R1168044c865c4956"/>
+    <p:sldId xmlns:r="http://schemas.openxmlformats.org/officeDocument/2006/relationships" id="256" r:id="Rf2b3b8839dfb49eb"/>
+    <p:sldId xmlns:r="http://schemas.openxmlformats.org/officeDocument/2006/relationships" id="257" r:id="R51eb5871f411426a"/>
+    <p:sldId xmlns:r="http://schemas.openxmlformats.org/officeDocument/2006/relationships" id="258" r:id="R6ef488c0d87a4cbc"/>
+    <p:sldId xmlns:r="http://schemas.openxmlformats.org/officeDocument/2006/relationships" id="259" r:id="R6f3e53c359ef44ad"/>
+    <p:sldId xmlns:r="http://schemas.openxmlformats.org/officeDocument/2006/relationships" id="260" r:id="R6051a0fe5c784277"/>
+    <p:sldId xmlns:r="http://schemas.openxmlformats.org/officeDocument/2006/relationships" id="261" r:id="R1b77c52e06e8400d"/>
+    <p:sldId xmlns:r="http://schemas.openxmlformats.org/officeDocument/2006/relationships" id="262" r:id="R540681e95fe443f3"/>
+    <p:sldId xmlns:r="http://schemas.openxmlformats.org/officeDocument/2006/relationships" id="263" r:id="Recdc4d9bf16c4870"/>
+    <p:sldId xmlns:r="http://schemas.openxmlformats.org/officeDocument/2006/relationships" id="264" r:id="R91a681a6647249d2"/>
+    <p:sldId xmlns:r="http://schemas.openxmlformats.org/officeDocument/2006/relationships" id="265" r:id="Rfb9be642379b4a6d"/>
+    <p:sldId xmlns:r="http://schemas.openxmlformats.org/officeDocument/2006/relationships" id="266" r:id="R5da91e71add5433e"/>
+    <p:sldId xmlns:r="http://schemas.openxmlformats.org/officeDocument/2006/relationships" id="267" r:id="R6da38bb2043e48e9"/>
+    <p:sldId xmlns:r="http://schemas.openxmlformats.org/officeDocument/2006/relationships" id="268" r:id="R9fea5010248644b9"/>
+    <p:sldId xmlns:r="http://schemas.openxmlformats.org/officeDocument/2006/relationships" id="269" r:id="R88fea31754c24446"/>
+    <p:sldId xmlns:r="http://schemas.openxmlformats.org/officeDocument/2006/relationships" id="270" r:id="R07bd90b2e06848d1"/>
+    <p:sldId xmlns:r="http://schemas.openxmlformats.org/officeDocument/2006/relationships" id="271" r:id="R3ef233260cc840be"/>
+    <p:sldId xmlns:r="http://schemas.openxmlformats.org/officeDocument/2006/relationships" id="272" r:id="Re4f87da605eb456a"/>
+    <p:sldId xmlns:r="http://schemas.openxmlformats.org/officeDocument/2006/relationships" id="273" r:id="R6fb9c8fe5d93412e"/>
+    <p:sldId xmlns:r="http://schemas.openxmlformats.org/officeDocument/2006/relationships" id="274" r:id="R44185beb948c40a9"/>
+    <p:sldId xmlns:r="http://schemas.openxmlformats.org/officeDocument/2006/relationships" id="275" r:id="R99a2b84bd37f4e7c"/>
+    <p:sldId xmlns:r="http://schemas.openxmlformats.org/officeDocument/2006/relationships" id="276" r:id="R2495a40ba4dd4d2b"/>
+    <p:sldId xmlns:r="http://schemas.openxmlformats.org/officeDocument/2006/relationships" id="277" r:id="R7f4e2b5eecd74de1"/>
+    <p:sldId xmlns:r="http://schemas.openxmlformats.org/officeDocument/2006/relationships" id="278" r:id="R317accd3725b4755"/>
+    <p:sldId xmlns:r="http://schemas.openxmlformats.org/officeDocument/2006/relationships" id="279" r:id="R962f639b66764ed6"/>
+    <p:sldId xmlns:r="http://schemas.openxmlformats.org/officeDocument/2006/relationships" id="280" r:id="R10713b582da34716"/>
+    <p:sldId xmlns:r="http://schemas.openxmlformats.org/officeDocument/2006/relationships" id="281" r:id="R04935fdabeb940cb"/>
+    <p:sldId xmlns:r="http://schemas.openxmlformats.org/officeDocument/2006/relationships" id="282" r:id="Re189d0d5d9574502"/>
+    <p:sldId xmlns:r="http://schemas.openxmlformats.org/officeDocument/2006/relationships" id="283" r:id="Rab3f101d68504ec5"/>
+    <p:sldId xmlns:r="http://schemas.openxmlformats.org/officeDocument/2006/relationships" id="284" r:id="Rb43216080170430a"/>
+    <p:sldId xmlns:r="http://schemas.openxmlformats.org/officeDocument/2006/relationships" id="285" r:id="Rc337c843dd404cc9"/>
   </p:sldIdLst>
   <p:sldSz cx="12192000" cy="6858000"/>
   <p:notesSz cx="6858000" cy="9144000"/>
@@ -416,7 +417,7 @@
           <a:lstStyle xmlns:a="http://schemas.openxmlformats.org/drawingml/2006/main"/>
           <a:p xmlns:a="http://schemas.openxmlformats.org/drawingml/2006/main">
             <a:r>
-              <a:t>本课把科研伦理原则转成 Agent 可执行、研究者可检查的边界。</a:t>
+              <a:t>本讲聚焦“科研伦理、Agent 权限、研究工件与追踪”。封面只保留正式课名，课堂问题从下一页展开。</a:t>
             </a:r>
           </a:p>
           <a:p xmlns:a="http://schemas.openxmlformats.org/drawingml/2006/main">
@@ -431,7 +432,12 @@
           </a:p>
           <a:p xmlns:a="http://schemas.openxmlformats.org/drawingml/2006/main">
             <a:r>
-              <a:t>- course/syllabus.md</a:t>
+              <a:t>- /Users/bright/Projects/courses/graduate/course/syllabus.md</a:t>
+            </a:r>
+          </a:p>
+          <a:p xmlns:a="http://schemas.openxmlformats.org/drawingml/2006/main">
+            <a:r>
+              <a:t>- /Users/bright/Projects/courses/graduate/lessons/lesson-02/slides.md</a:t>
             </a:r>
           </a:p>
           <a:p xmlns:a="http://schemas.openxmlformats.org/drawingml/2006/main">
@@ -2321,7 +2327,7 @@
           <a:lstStyle xmlns:a="http://schemas.openxmlformats.org/drawingml/2006/main"/>
           <a:p xmlns:a="http://schemas.openxmlformats.org/drawingml/2006/main">
             <a:r>
-              <a:t>明确形成性任务与正式提交的区别；第 3 课联网检索会带来新来源、新条款和新记录。</a:t>
+              <a:t>回收本讲核心概念及其关系。本页不新增任务；请学生用边界句检查自己的项目工件。</a:t>
             </a:r>
           </a:p>
           <a:p xmlns:a="http://schemas.openxmlformats.org/drawingml/2006/main">
@@ -2336,17 +2342,17 @@
           </a:p>
           <a:p xmlns:a="http://schemas.openxmlformats.org/drawingml/2006/main">
             <a:r>
-              <a:t>- course/reading-list.md</a:t>
-            </a:r>
-          </a:p>
-          <a:p xmlns:a="http://schemas.openxmlformats.org/drawingml/2006/main">
-            <a:r>
-              <a:t>- course/assignments.md</a:t>
-            </a:r>
-          </a:p>
-          <a:p xmlns:a="http://schemas.openxmlformats.org/drawingml/2006/main">
-            <a:r>
-              <a:t>- course/syllabus.md</a:t>
+              <a:t>- /Users/bright/Projects/courses/graduate/course/syllabus.md</a:t>
+            </a:r>
+          </a:p>
+          <a:p xmlns:a="http://schemas.openxmlformats.org/drawingml/2006/main">
+            <a:r>
+              <a:t>- /Users/bright/Projects/courses/graduate/lessons/lesson-02/handout.md</a:t>
+            </a:r>
+          </a:p>
+          <a:p xmlns:a="http://schemas.openxmlformats.org/drawingml/2006/main">
+            <a:r>
+              <a:t>- /Users/bright/Projects/courses/graduate/lessons/lesson-02/slides.md</a:t>
             </a:r>
           </a:p>
           <a:p xmlns:a="http://schemas.openxmlformats.org/drawingml/2006/main">
@@ -2437,6 +2443,106 @@
           <a:p xmlns:a="http://schemas.openxmlformats.org/drawingml/2006/main">
             <a:r>
               <a:t>- Fictional classroom case; not formal peer review.</a:t>
+            </a:r>
+          </a:p>
+          <a:p xmlns:a="http://schemas.openxmlformats.org/drawingml/2006/main">
+            <a:r>
+              <a:t>[/Sources]</a:t>
+            </a:r>
+          </a:p>
+        </p:txBody>
+      </p:sp>
+      <p:sp>
+        <p:nvSpPr>
+          <p:cNvPr id="4" name="Slide Number Placeholder 3"/>
+          <p:cNvSpPr>
+            <a:spLocks xmlns:a="http://schemas.openxmlformats.org/drawingml/2006/main" noGrp="1"/>
+          </p:cNvSpPr>
+          <p:nvPr>
+            <p:ph type="sldNum" idx="5"/>
+          </p:nvPr>
+        </p:nvSpPr>
+        <p:spPr/>
+        <p:txBody>
+          <a:bodyPr xmlns:a="http://schemas.openxmlformats.org/drawingml/2006/main"/>
+          <a:lstStyle xmlns:a="http://schemas.openxmlformats.org/drawingml/2006/main"/>
+          <a:p xmlns:a="http://schemas.openxmlformats.org/drawingml/2006/main"/>
+        </p:txBody>
+      </p:sp>
+    </p:spTree>
+  </p:cSld>
+  <p:clrMapOvr>
+    <a:masterClrMapping xmlns:a="http://schemas.openxmlformats.org/drawingml/2006/main"/>
+  </p:clrMapOvr>
+</p:notes>
+</file>
+
+<file path=ppt/notesSlides/notesSlide30.xml><?xml version="1.0" encoding="utf-8"?>
+<p:notes xmlns:p="http://schemas.openxmlformats.org/presentationml/2006/main">
+  <p:cSld>
+    <p:spTree>
+      <p:nvGrpSpPr>
+        <p:cNvPr id="1" name=""/>
+        <p:cNvGrpSpPr/>
+        <p:nvPr/>
+      </p:nvGrpSpPr>
+      <p:grpSpPr>
+        <a:xfrm xmlns:a="http://schemas.openxmlformats.org/drawingml/2006/main"/>
+      </p:grpSpPr>
+      <p:sp>
+        <p:nvSpPr>
+          <p:cNvPr id="2" name="Slide Image Placeholder 1"/>
+          <p:cNvSpPr>
+            <a:spLocks xmlns:a="http://schemas.openxmlformats.org/drawingml/2006/main" noGrp="1"/>
+          </p:cNvSpPr>
+          <p:nvPr>
+            <p:ph type="sldImg" idx="0"/>
+          </p:nvPr>
+        </p:nvSpPr>
+        <p:spPr/>
+      </p:sp>
+      <p:sp>
+        <p:nvSpPr>
+          <p:cNvPr id="3" name="Notes Placeholder 2"/>
+          <p:cNvSpPr>
+            <a:spLocks xmlns:a="http://schemas.openxmlformats.org/drawingml/2006/main" noGrp="1"/>
+          </p:cNvSpPr>
+          <p:nvPr>
+            <p:ph type="body" idx="1"/>
+          </p:nvPr>
+        </p:nvSpPr>
+        <p:spPr/>
+        <p:txBody>
+          <a:bodyPr xmlns:a="http://schemas.openxmlformats.org/drawingml/2006/main"/>
+          <a:lstStyle xmlns:a="http://schemas.openxmlformats.org/drawingml/2006/main"/>
+          <a:p xmlns:a="http://schemas.openxmlformats.org/drawingml/2006/main">
+            <a:r>
+              <a:t>明确形成性任务与正式提交的区别；第 3 课联网检索会带来新来源、新条款和新记录。</a:t>
+            </a:r>
+          </a:p>
+          <a:p xmlns:a="http://schemas.openxmlformats.org/drawingml/2006/main">
+            <a:r>
+              <a:t/>
+            </a:r>
+          </a:p>
+          <a:p xmlns:a="http://schemas.openxmlformats.org/drawingml/2006/main">
+            <a:r>
+              <a:t>[Sources]</a:t>
+            </a:r>
+          </a:p>
+          <a:p xmlns:a="http://schemas.openxmlformats.org/drawingml/2006/main">
+            <a:r>
+              <a:t>- course/reading-list.md</a:t>
+            </a:r>
+          </a:p>
+          <a:p xmlns:a="http://schemas.openxmlformats.org/drawingml/2006/main">
+            <a:r>
+              <a:t>- course/assignments.md</a:t>
+            </a:r>
+          </a:p>
+          <a:p xmlns:a="http://schemas.openxmlformats.org/drawingml/2006/main">
+            <a:r>
+              <a:t>- course/syllabus.md</a:t>
             </a:r>
           </a:p>
           <a:p xmlns:a="http://schemas.openxmlformats.org/drawingml/2006/main">
@@ -3047,7 +3153,7 @@
           <p:nvPr/>
         </p:nvPicPr>
         <p:blipFill>
-          <a:blip xmlns:r="http://schemas.openxmlformats.org/officeDocument/2006/relationships" xmlns:a="http://schemas.openxmlformats.org/drawingml/2006/main" r:embed="R64d6fad5e9914002">
+          <a:blip xmlns:r="http://schemas.openxmlformats.org/officeDocument/2006/relationships" xmlns:a="http://schemas.openxmlformats.org/drawingml/2006/main" r:embed="R481bf945937d445b">
             <a:duotone>
               <a:prstClr val="black"/>
               <a:schemeClr val="accent1">
@@ -3225,7 +3331,7 @@
           <p:nvPr/>
         </p:nvPicPr>
         <p:blipFill rotWithShape="1">
-          <a:blip xmlns:r="http://schemas.openxmlformats.org/officeDocument/2006/relationships" xmlns:a="http://schemas.openxmlformats.org/drawingml/2006/main" r:embed="R72f41fc7d9fa44ae"/>
+          <a:blip xmlns:r="http://schemas.openxmlformats.org/officeDocument/2006/relationships" xmlns:a="http://schemas.openxmlformats.org/drawingml/2006/main" r:embed="R2019aea01fd94a22"/>
           <a:srcRect xmlns:a="http://schemas.openxmlformats.org/drawingml/2006/main" l="74359" t="0" r="1346" b="0"/>
           <a:stretch xmlns:a="http://schemas.openxmlformats.org/drawingml/2006/main"/>
         </p:blipFill>
@@ -3248,7 +3354,7 @@
           <p:nvPr/>
         </p:nvPicPr>
         <p:blipFill rotWithShape="1">
-          <a:blip xmlns:r="http://schemas.openxmlformats.org/officeDocument/2006/relationships" xmlns:a="http://schemas.openxmlformats.org/drawingml/2006/main" r:embed="R4f25eb1c36734126">
+          <a:blip xmlns:r="http://schemas.openxmlformats.org/officeDocument/2006/relationships" xmlns:a="http://schemas.openxmlformats.org/drawingml/2006/main" r:embed="Rc6fb71d5348444e4">
             <a:alphaModFix amt="35000"/>
           </a:blip>
           <a:srcRect xmlns:a="http://schemas.openxmlformats.org/drawingml/2006/main" l="0" t="9831" r="0" b="36385"/>
@@ -3510,7 +3616,7 @@
           <p:nvPr/>
         </p:nvPicPr>
         <p:blipFill>
-          <a:blip xmlns:r="http://schemas.openxmlformats.org/officeDocument/2006/relationships" xmlns:a="http://schemas.openxmlformats.org/drawingml/2006/main" r:embed="R9358b3cfbe264efa"/>
+          <a:blip xmlns:r="http://schemas.openxmlformats.org/officeDocument/2006/relationships" xmlns:a="http://schemas.openxmlformats.org/drawingml/2006/main" r:embed="R583006c0760c40e6"/>
           <a:srcRect xmlns:a="http://schemas.openxmlformats.org/drawingml/2006/main" l="0" t="0" r="54251" b="0"/>
           <a:stretch xmlns:a="http://schemas.openxmlformats.org/drawingml/2006/main"/>
         </p:blipFill>
@@ -3767,7 +3873,7 @@
           <p:nvPr/>
         </p:nvPicPr>
         <p:blipFill rotWithShape="1">
-          <a:blip xmlns:r="http://schemas.openxmlformats.org/officeDocument/2006/relationships" xmlns:a="http://schemas.openxmlformats.org/drawingml/2006/main" r:embed="R714d2ed00b43488a"/>
+          <a:blip xmlns:r="http://schemas.openxmlformats.org/officeDocument/2006/relationships" xmlns:a="http://schemas.openxmlformats.org/drawingml/2006/main" r:embed="R3497b6c19a5b4fe4"/>
           <a:srcRect xmlns:a="http://schemas.openxmlformats.org/drawingml/2006/main" l="0" t="0" r="1346" b="0"/>
           <a:stretch xmlns:a="http://schemas.openxmlformats.org/drawingml/2006/main"/>
         </p:blipFill>
@@ -3950,7 +4056,7 @@
           <p:nvPr/>
         </p:nvPicPr>
         <p:blipFill>
-          <a:blip xmlns:r="http://schemas.openxmlformats.org/officeDocument/2006/relationships" xmlns:a="http://schemas.openxmlformats.org/drawingml/2006/main" r:embed="R83a1e1caae6a44d1"/>
+          <a:blip xmlns:r="http://schemas.openxmlformats.org/officeDocument/2006/relationships" xmlns:a="http://schemas.openxmlformats.org/drawingml/2006/main" r:embed="R8cec242a94fa43d4"/>
           <a:stretch xmlns:a="http://schemas.openxmlformats.org/drawingml/2006/main">
             <a:fillRect l="0" t="0" r="0" b="0"/>
           </a:stretch>
@@ -4046,7 +4152,7 @@
           <p:nvPr/>
         </p:nvPicPr>
         <p:blipFill>
-          <a:blip xmlns:r="http://schemas.openxmlformats.org/officeDocument/2006/relationships" xmlns:a="http://schemas.openxmlformats.org/drawingml/2006/main" r:embed="R8fb1c529db0b462f">
+          <a:blip xmlns:r="http://schemas.openxmlformats.org/officeDocument/2006/relationships" xmlns:a="http://schemas.openxmlformats.org/drawingml/2006/main" r:embed="Rb57dd853fe314e50">
             <a:duotone>
               <a:prstClr val="black"/>
               <a:schemeClr val="accent1">
@@ -4213,7 +4319,7 @@
           <p:nvPr/>
         </p:nvPicPr>
         <p:blipFill rotWithShape="1">
-          <a:blip xmlns:r="http://schemas.openxmlformats.org/officeDocument/2006/relationships" xmlns:a="http://schemas.openxmlformats.org/drawingml/2006/main" r:embed="Rd7c89d07f6664346">
+          <a:blip xmlns:r="http://schemas.openxmlformats.org/officeDocument/2006/relationships" xmlns:a="http://schemas.openxmlformats.org/drawingml/2006/main" r:embed="R167f5a931e094484">
             <a:alphaModFix amt="20000"/>
             <a:duotone>
               <a:schemeClr val="accent4">
@@ -4311,10 +4417,10 @@
   </p:cSld>
   <p:clrMap bg1="lt1" tx1="dk1" bg2="lt2" tx2="dk2" accent1="accent1" accent2="accent2" accent3="accent3" accent4="accent4" accent5="accent5" accent6="accent6" hlink="hlink" folHlink="folHlink"/>
   <p:sldLayoutIdLst>
-    <p:sldLayoutId xmlns:r="http://schemas.openxmlformats.org/officeDocument/2006/relationships" id="2147483649" r:id="R5c27e78f0d98446b"/>
-    <p:sldLayoutId xmlns:r="http://schemas.openxmlformats.org/officeDocument/2006/relationships" id="2147483650" r:id="Rbbc6dec2a0d14954"/>
-    <p:sldLayoutId xmlns:r="http://schemas.openxmlformats.org/officeDocument/2006/relationships" id="2147483651" r:id="R99c52669d97a4011"/>
-    <p:sldLayoutId xmlns:r="http://schemas.openxmlformats.org/officeDocument/2006/relationships" id="2147483652" r:id="Rdead2840a444471c"/>
+    <p:sldLayoutId xmlns:r="http://schemas.openxmlformats.org/officeDocument/2006/relationships" id="2147483649" r:id="Rc156b4cbe8fc4638"/>
+    <p:sldLayoutId xmlns:r="http://schemas.openxmlformats.org/officeDocument/2006/relationships" id="2147483650" r:id="Rdd9d5b3e9ecc4113"/>
+    <p:sldLayoutId xmlns:r="http://schemas.openxmlformats.org/officeDocument/2006/relationships" id="2147483651" r:id="R8529098853b546de"/>
+    <p:sldLayoutId xmlns:r="http://schemas.openxmlformats.org/officeDocument/2006/relationships" id="2147483652" r:id="R8140065edc274286"/>
   </p:sldLayoutIdLst>
   <p:hf hdr="0" ftr="0" dt="0"/>
   <p:txStyles>
@@ -4847,96 +4953,6 @@
       </p:grpSpPr>
       <p:sp>
         <p:nvSpPr>
-          <p:cNvPr id="3" name="内容占位符 2">
-            <a:extLst xmlns:a="http://schemas.openxmlformats.org/drawingml/2006/main">
-              <a:ext uri="{FF2B5EF4-FFF2-40B4-BE49-F238E27FC236}">
-                <a16:creationId xmlns:a16="http://schemas.microsoft.com/office/drawing/2014/main" id="{D1D30E0E-D2D5-4C08-A919-2A1C2D5A8D02}"/>
-              </a:ext>
-            </a:extLst>
-          </p:cNvPr>
-          <p:cNvSpPr>
-            <a:spLocks xmlns:a="http://schemas.openxmlformats.org/drawingml/2006/main" noGrp="1"/>
-          </p:cNvSpPr>
-          <p:nvPr>
-            <p:ph idx="10"/>
-          </p:nvPr>
-        </p:nvSpPr>
-        <p:spPr>
-          <a:xfrm xmlns:a="http://schemas.openxmlformats.org/drawingml/2006/main">
-            <a:off x="1619250" y="3790950"/>
-            <a:ext cx="8953500" cy="1657350"/>
-          </a:xfrm>
-        </p:spPr>
-        <p:txBody>
-          <a:bodyPr xmlns:a="http://schemas.openxmlformats.org/drawingml/2006/main" lIns="0" tIns="0" rIns="0" bIns="0" anchor="ctr"/>
-          <a:lstStyle xmlns:a="http://schemas.openxmlformats.org/drawingml/2006/main"/>
-          <a:p xmlns:a="http://schemas.openxmlformats.org/drawingml/2006/main">
-            <a:pPr algn="ctr">
-              <a:lnSpc>
-                <a:spcPct val="130000"/>
-              </a:lnSpc>
-              <a:buNone/>
-            </a:pPr>
-            <a:r>
-              <a:rPr sz="1800" b="1">
-                <a:solidFill>
-                  <a:srgbClr val="18354E"/>
-                </a:solidFill>
-                <a:latin typeface="Microsoft YaHei"/>
-                <a:ea typeface="Microsoft YaHei"/>
-                <a:cs typeface="Microsoft YaHei"/>
-              </a:rPr>
-              <a:t>原则  →  风险判断  →  权限  →  人工确认  →  记录</a:t>
-            </a:r>
-            <a:endParaRPr>
-              <a:latin typeface="+mn-ea"/>
-              <a:ea typeface="+mn-ea"/>
-              <a:cs typeface="+mn-ea"/>
-            </a:endParaRPr>
-          </a:p>
-          <a:p xmlns:a="http://schemas.openxmlformats.org/drawingml/2006/main">
-            <a:r>
-              <a:rPr>
-                <a:latin typeface="+mn-ea"/>
-                <a:ea typeface="+mn-ea"/>
-                <a:cs typeface="+mn-ea"/>
-              </a:rPr>
-              <a:t/>
-            </a:r>
-            <a:endParaRPr>
-              <a:latin typeface="+mn-ea"/>
-              <a:ea typeface="+mn-ea"/>
-              <a:cs typeface="+mn-ea"/>
-            </a:endParaRPr>
-          </a:p>
-          <a:p xmlns:a="http://schemas.openxmlformats.org/drawingml/2006/main">
-            <a:pPr algn="ctr">
-              <a:lnSpc>
-                <a:spcPct val="130000"/>
-              </a:lnSpc>
-              <a:buNone/>
-            </a:pPr>
-            <a:r>
-              <a:rPr sz="1800" b="1">
-                <a:solidFill>
-                  <a:srgbClr val="18354E"/>
-                </a:solidFill>
-                <a:latin typeface="Microsoft YaHei"/>
-                <a:ea typeface="Microsoft YaHei"/>
-                <a:cs typeface="Microsoft YaHei"/>
-              </a:rPr>
-              <a:t>效率不能替研究者决定哪些边界可以突破</a:t>
-            </a:r>
-            <a:endParaRPr>
-              <a:latin typeface="+mn-ea"/>
-              <a:ea typeface="+mn-ea"/>
-              <a:cs typeface="+mn-ea"/>
-            </a:endParaRPr>
-          </a:p>
-        </p:txBody>
-      </p:sp>
-      <p:sp>
-        <p:nvSpPr>
           <p:cNvPr id="2" name="矩形 11">
             <a:extLst xmlns:a="http://schemas.openxmlformats.org/drawingml/2006/main">
               <a:ext uri="{FF2B5EF4-FFF2-40B4-BE49-F238E27FC236}">
@@ -4951,27 +4967,27 @@
         </p:nvSpPr>
         <p:spPr>
           <a:xfrm xmlns:a="http://schemas.openxmlformats.org/drawingml/2006/main">
-            <a:off x="1714500" y="1524000"/>
-            <a:ext cx="8763000" cy="1657350"/>
-          </a:xfrm>
-          <a:prstGeom xmlns:a="http://schemas.openxmlformats.org/drawingml/2006/main" prst="rect">
-            <a:avLst/>
-          </a:prstGeom>
-        </p:spPr>
-        <p:txBody>
-          <a:bodyPr xmlns:a="http://schemas.openxmlformats.org/drawingml/2006/main" lIns="0" tIns="0" rIns="0" bIns="0" anchor="ctr">
+            <a:off x="1143000" y="1790700"/>
+            <a:ext cx="9906000" cy="1524000"/>
+          </a:xfrm>
+          <a:prstGeom xmlns:a="http://schemas.openxmlformats.org/drawingml/2006/main" prst="rect">
+            <a:avLst/>
+          </a:prstGeom>
+        </p:spPr>
+        <p:txBody>
+          <a:bodyPr xmlns:a="http://schemas.openxmlformats.org/drawingml/2006/main" lIns="76200" tIns="38100" rIns="76200" bIns="38100" anchor="ctr">
             <a:spAutoFit/>
           </a:bodyPr>
           <a:lstStyle xmlns:a="http://schemas.openxmlformats.org/drawingml/2006/main"/>
           <a:p xmlns:a="http://schemas.openxmlformats.org/drawingml/2006/main">
             <a:pPr algn="ctr">
               <a:lnSpc>
-                <a:spcPct val="150000"/>
+                <a:spcPct val="112000"/>
               </a:lnSpc>
               <a:buNone/>
             </a:pPr>
             <a:r>
-              <a:rPr sz="2850" b="1">
+              <a:rPr sz="3150" b="1">
                 <a:solidFill>
                   <a:srgbClr val="C8161E"/>
                 </a:solidFill>
@@ -4979,7 +4995,7 @@
                 <a:ea typeface="Microsoft YaHei"/>
                 <a:cs typeface="Microsoft YaHei"/>
               </a:rPr>
-              <a:t>科研伦理、Agent 权限、</a:t>
+              <a:t>第2讲 科研伦理、Agent 权限、研究工件与追踪</a:t>
             </a:r>
             <a:endParaRPr sz="4000" b="1" kern="0" spc="20">
               <a:solidFill>
@@ -4989,25 +5005,6 @@
               <a:ea typeface="Arial"/>
               <a:cs typeface="Arial"/>
             </a:endParaRPr>
-          </a:p>
-          <a:p xmlns:a="http://schemas.openxmlformats.org/drawingml/2006/main">
-            <a:pPr algn="ctr">
-              <a:lnSpc>
-                <a:spcPct val="150000"/>
-              </a:lnSpc>
-              <a:buNone/>
-            </a:pPr>
-            <a:r>
-              <a:rPr sz="2850" b="1">
-                <a:solidFill>
-                  <a:srgbClr val="C8161E"/>
-                </a:solidFill>
-                <a:latin typeface="Microsoft YaHei"/>
-                <a:ea typeface="Microsoft YaHei"/>
-                <a:cs typeface="Microsoft YaHei"/>
-              </a:rPr>
-              <a:t>研究工件与追踪</a:t>
-            </a:r>
           </a:p>
         </p:txBody>
       </p:sp>
@@ -5059,7 +5056,9 @@
           <a:bodyPr xmlns:a="http://schemas.openxmlformats.org/drawingml/2006/main" lIns="76200" tIns="0" rIns="76200" bIns="0" anchor="ctr"/>
           <a:lstStyle xmlns:a="http://schemas.openxmlformats.org/drawingml/2006/main"/>
           <a:p xmlns:a="http://schemas.openxmlformats.org/drawingml/2006/main">
-            <a:pPr algn="l"/>
+            <a:pPr algn="l">
+              <a:buNone/>
+            </a:pPr>
             <a:r>
               <a:rPr sz="2250" b="1">
                 <a:solidFill>
@@ -5138,6 +5137,7 @@
           <a:lstStyle xmlns:a="http://schemas.openxmlformats.org/drawingml/2006/main"/>
           <a:p xmlns:a="http://schemas.openxmlformats.org/drawingml/2006/main">
             <a:pPr algn="ctr">
+              <a:buNone/>
               <a:defRPr sz="1650" b="1">
                 <a:solidFill>
                   <a:srgbClr val="A86C12"/>
@@ -5255,6 +5255,7 @@
           <a:lstStyle xmlns:a="http://schemas.openxmlformats.org/drawingml/2006/main"/>
           <a:p xmlns:a="http://schemas.openxmlformats.org/drawingml/2006/main">
             <a:pPr algn="ctr">
+              <a:buNone/>
               <a:defRPr sz="1875" b="1">
                 <a:solidFill>
                   <a:srgbClr val="2F638A"/>
@@ -5310,6 +5311,7 @@
           <a:lstStyle xmlns:a="http://schemas.openxmlformats.org/drawingml/2006/main"/>
           <a:p xmlns:a="http://schemas.openxmlformats.org/drawingml/2006/main">
             <a:pPr algn="ctr">
+              <a:buNone/>
               <a:defRPr sz="1875" b="1">
                 <a:solidFill>
                   <a:srgbClr val="C8161E"/>
@@ -5365,6 +5367,7 @@
           <a:lstStyle xmlns:a="http://schemas.openxmlformats.org/drawingml/2006/main"/>
           <a:p xmlns:a="http://schemas.openxmlformats.org/drawingml/2006/main">
             <a:pPr algn="ctr">
+              <a:buNone/>
               <a:defRPr sz="1875" b="1">
                 <a:solidFill>
                   <a:srgbClr val="263746"/>
@@ -5420,6 +5423,7 @@
           <a:lstStyle xmlns:a="http://schemas.openxmlformats.org/drawingml/2006/main"/>
           <a:p xmlns:a="http://schemas.openxmlformats.org/drawingml/2006/main">
             <a:pPr algn="ctr">
+              <a:buNone/>
               <a:defRPr sz="1875" b="1">
                 <a:solidFill>
                   <a:srgbClr val="263746"/>
@@ -5475,6 +5479,7 @@
           <a:lstStyle xmlns:a="http://schemas.openxmlformats.org/drawingml/2006/main"/>
           <a:p xmlns:a="http://schemas.openxmlformats.org/drawingml/2006/main">
             <a:pPr algn="ctr">
+              <a:buNone/>
               <a:defRPr sz="1800" b="1">
                 <a:solidFill>
                   <a:srgbClr val="C8161E"/>
@@ -5528,6 +5533,7 @@
           <a:lstStyle xmlns:a="http://schemas.openxmlformats.org/drawingml/2006/main"/>
           <a:p xmlns:a="http://schemas.openxmlformats.org/drawingml/2006/main">
             <a:pPr algn="ctr">
+              <a:buNone/>
               <a:defRPr sz="1650" b="1">
                 <a:solidFill>
                   <a:srgbClr val="18354E"/>
@@ -5596,7 +5602,9 @@
           <a:bodyPr xmlns:a="http://schemas.openxmlformats.org/drawingml/2006/main" lIns="76200" tIns="0" rIns="76200" bIns="0" anchor="ctr"/>
           <a:lstStyle xmlns:a="http://schemas.openxmlformats.org/drawingml/2006/main"/>
           <a:p xmlns:a="http://schemas.openxmlformats.org/drawingml/2006/main">
-            <a:pPr algn="l"/>
+            <a:pPr algn="l">
+              <a:buNone/>
+            </a:pPr>
             <a:r>
               <a:rPr sz="2250" b="1">
                 <a:solidFill>
@@ -5706,6 +5714,7 @@
           <a:lstStyle xmlns:a="http://schemas.openxmlformats.org/drawingml/2006/main"/>
           <a:p xmlns:a="http://schemas.openxmlformats.org/drawingml/2006/main">
             <a:pPr algn="ctr">
+              <a:buNone/>
               <a:defRPr sz="1725" b="1">
                 <a:solidFill>
                   <a:srgbClr val="2F638A"/>
@@ -5761,6 +5770,7 @@
           <a:lstStyle xmlns:a="http://schemas.openxmlformats.org/drawingml/2006/main"/>
           <a:p xmlns:a="http://schemas.openxmlformats.org/drawingml/2006/main">
             <a:pPr algn="ctr">
+              <a:buNone/>
               <a:defRPr sz="1725" b="1">
                 <a:solidFill>
                   <a:srgbClr val="C8161E"/>
@@ -5816,6 +5826,7 @@
           <a:lstStyle xmlns:a="http://schemas.openxmlformats.org/drawingml/2006/main"/>
           <a:p xmlns:a="http://schemas.openxmlformats.org/drawingml/2006/main">
             <a:pPr algn="ctr">
+              <a:buNone/>
               <a:defRPr sz="1725" b="1">
                 <a:solidFill>
                   <a:srgbClr val="C8161E"/>
@@ -5871,6 +5882,7 @@
           <a:lstStyle xmlns:a="http://schemas.openxmlformats.org/drawingml/2006/main"/>
           <a:p xmlns:a="http://schemas.openxmlformats.org/drawingml/2006/main">
             <a:pPr algn="ctr">
+              <a:buNone/>
               <a:defRPr sz="1725" b="1">
                 <a:solidFill>
                   <a:srgbClr val="A86C12"/>
@@ -5926,6 +5938,7 @@
           <a:lstStyle xmlns:a="http://schemas.openxmlformats.org/drawingml/2006/main"/>
           <a:p xmlns:a="http://schemas.openxmlformats.org/drawingml/2006/main">
             <a:pPr algn="ctr">
+              <a:buNone/>
               <a:defRPr sz="1725" b="1">
                 <a:solidFill>
                   <a:srgbClr val="28745A"/>
@@ -6012,6 +6025,7 @@
           <a:lstStyle xmlns:a="http://schemas.openxmlformats.org/drawingml/2006/main"/>
           <a:p xmlns:a="http://schemas.openxmlformats.org/drawingml/2006/main">
             <a:pPr algn="ctr">
+              <a:buNone/>
               <a:defRPr sz="1800" b="1">
                 <a:solidFill>
                   <a:srgbClr val="C8161E"/>
@@ -6065,6 +6079,7 @@
           <a:lstStyle xmlns:a="http://schemas.openxmlformats.org/drawingml/2006/main"/>
           <a:p xmlns:a="http://schemas.openxmlformats.org/drawingml/2006/main">
             <a:pPr algn="ctr">
+              <a:buNone/>
               <a:defRPr sz="4050" b="1">
                 <a:solidFill>
                   <a:srgbClr val="C8161E"/>
@@ -6118,6 +6133,7 @@
           <a:lstStyle xmlns:a="http://schemas.openxmlformats.org/drawingml/2006/main"/>
           <a:p xmlns:a="http://schemas.openxmlformats.org/drawingml/2006/main">
             <a:pPr algn="ctr">
+              <a:buNone/>
               <a:defRPr sz="1875" b="1">
                 <a:solidFill>
                   <a:srgbClr val="18354E"/>
@@ -6186,7 +6202,9 @@
           <a:bodyPr xmlns:a="http://schemas.openxmlformats.org/drawingml/2006/main" lIns="76200" tIns="0" rIns="76200" bIns="0" anchor="ctr"/>
           <a:lstStyle xmlns:a="http://schemas.openxmlformats.org/drawingml/2006/main"/>
           <a:p xmlns:a="http://schemas.openxmlformats.org/drawingml/2006/main">
-            <a:pPr algn="l"/>
+            <a:pPr algn="l">
+              <a:buNone/>
+            </a:pPr>
             <a:r>
               <a:rPr sz="2250" b="1">
                 <a:solidFill>
@@ -6325,6 +6343,7 @@
           <a:lstStyle xmlns:a="http://schemas.openxmlformats.org/drawingml/2006/main"/>
           <a:p xmlns:a="http://schemas.openxmlformats.org/drawingml/2006/main">
             <a:pPr algn="ctr">
+              <a:buNone/>
               <a:defRPr sz="1725" b="1">
                 <a:solidFill>
                   <a:srgbClr val="263746"/>
@@ -6380,6 +6399,7 @@
           <a:lstStyle xmlns:a="http://schemas.openxmlformats.org/drawingml/2006/main"/>
           <a:p xmlns:a="http://schemas.openxmlformats.org/drawingml/2006/main">
             <a:pPr algn="ctr">
+              <a:buNone/>
               <a:defRPr sz="1500" b="1">
                 <a:solidFill>
                   <a:srgbClr val="667684"/>
@@ -6464,6 +6484,7 @@
           <a:lstStyle xmlns:a="http://schemas.openxmlformats.org/drawingml/2006/main"/>
           <a:p xmlns:a="http://schemas.openxmlformats.org/drawingml/2006/main">
             <a:pPr algn="ctr">
+              <a:buNone/>
               <a:defRPr sz="1725" b="1">
                 <a:solidFill>
                   <a:srgbClr val="263746"/>
@@ -6519,6 +6540,7 @@
           <a:lstStyle xmlns:a="http://schemas.openxmlformats.org/drawingml/2006/main"/>
           <a:p xmlns:a="http://schemas.openxmlformats.org/drawingml/2006/main">
             <a:pPr algn="ctr">
+              <a:buNone/>
               <a:defRPr sz="1500" b="1">
                 <a:solidFill>
                   <a:srgbClr val="667684"/>
@@ -6603,6 +6625,7 @@
           <a:lstStyle xmlns:a="http://schemas.openxmlformats.org/drawingml/2006/main"/>
           <a:p xmlns:a="http://schemas.openxmlformats.org/drawingml/2006/main">
             <a:pPr algn="ctr">
+              <a:buNone/>
               <a:defRPr sz="1725" b="1">
                 <a:solidFill>
                   <a:srgbClr val="263746"/>
@@ -6658,6 +6681,7 @@
           <a:lstStyle xmlns:a="http://schemas.openxmlformats.org/drawingml/2006/main"/>
           <a:p xmlns:a="http://schemas.openxmlformats.org/drawingml/2006/main">
             <a:pPr algn="ctr">
+              <a:buNone/>
               <a:defRPr sz="1500" b="1">
                 <a:solidFill>
                   <a:srgbClr val="667684"/>
@@ -6742,6 +6766,7 @@
           <a:lstStyle xmlns:a="http://schemas.openxmlformats.org/drawingml/2006/main"/>
           <a:p xmlns:a="http://schemas.openxmlformats.org/drawingml/2006/main">
             <a:pPr algn="ctr">
+              <a:buNone/>
               <a:defRPr sz="1725" b="1">
                 <a:solidFill>
                   <a:srgbClr val="C8161E"/>
@@ -6797,6 +6822,7 @@
           <a:lstStyle xmlns:a="http://schemas.openxmlformats.org/drawingml/2006/main"/>
           <a:p xmlns:a="http://schemas.openxmlformats.org/drawingml/2006/main">
             <a:pPr algn="ctr">
+              <a:buNone/>
               <a:defRPr sz="1500" b="1">
                 <a:solidFill>
                   <a:srgbClr val="C8161E"/>
@@ -6881,6 +6907,7 @@
           <a:lstStyle xmlns:a="http://schemas.openxmlformats.org/drawingml/2006/main"/>
           <a:p xmlns:a="http://schemas.openxmlformats.org/drawingml/2006/main">
             <a:pPr algn="ctr">
+              <a:buNone/>
               <a:defRPr sz="1725" b="1">
                 <a:solidFill>
                   <a:srgbClr val="263746"/>
@@ -6936,6 +6963,7 @@
           <a:lstStyle xmlns:a="http://schemas.openxmlformats.org/drawingml/2006/main"/>
           <a:p xmlns:a="http://schemas.openxmlformats.org/drawingml/2006/main">
             <a:pPr algn="ctr">
+              <a:buNone/>
               <a:defRPr sz="1500" b="1">
                 <a:solidFill>
                   <a:srgbClr val="667684"/>
@@ -6989,6 +7017,7 @@
           <a:lstStyle xmlns:a="http://schemas.openxmlformats.org/drawingml/2006/main"/>
           <a:p xmlns:a="http://schemas.openxmlformats.org/drawingml/2006/main">
             <a:pPr algn="ctr">
+              <a:buNone/>
               <a:defRPr sz="2025" b="1">
                 <a:solidFill>
                   <a:srgbClr val="C8161E"/>
@@ -7057,7 +7086,9 @@
           <a:bodyPr xmlns:a="http://schemas.openxmlformats.org/drawingml/2006/main" lIns="76200" tIns="0" rIns="76200" bIns="0" anchor="ctr"/>
           <a:lstStyle xmlns:a="http://schemas.openxmlformats.org/drawingml/2006/main"/>
           <a:p xmlns:a="http://schemas.openxmlformats.org/drawingml/2006/main">
-            <a:pPr algn="l"/>
+            <a:pPr algn="l">
+              <a:buNone/>
+            </a:pPr>
             <a:r>
               <a:rPr sz="2250" b="1">
                 <a:solidFill>
@@ -7136,6 +7167,7 @@
           <a:lstStyle xmlns:a="http://schemas.openxmlformats.org/drawingml/2006/main"/>
           <a:p xmlns:a="http://schemas.openxmlformats.org/drawingml/2006/main">
             <a:pPr algn="ctr">
+              <a:buNone/>
               <a:defRPr sz="2400" b="1">
                 <a:solidFill>
                   <a:srgbClr val="FFFFFF"/>
@@ -7191,6 +7223,7 @@
           <a:lstStyle xmlns:a="http://schemas.openxmlformats.org/drawingml/2006/main"/>
           <a:p xmlns:a="http://schemas.openxmlformats.org/drawingml/2006/main">
             <a:pPr algn="ctr">
+              <a:buNone/>
               <a:defRPr sz="1650" b="1">
                 <a:solidFill>
                   <a:srgbClr val="263746"/>
@@ -7246,6 +7279,7 @@
           <a:lstStyle xmlns:a="http://schemas.openxmlformats.org/drawingml/2006/main"/>
           <a:p xmlns:a="http://schemas.openxmlformats.org/drawingml/2006/main">
             <a:pPr algn="ctr">
+              <a:buNone/>
               <a:defRPr sz="1650" b="1">
                 <a:solidFill>
                   <a:srgbClr val="263746"/>
@@ -7301,6 +7335,7 @@
           <a:lstStyle xmlns:a="http://schemas.openxmlformats.org/drawingml/2006/main"/>
           <a:p xmlns:a="http://schemas.openxmlformats.org/drawingml/2006/main">
             <a:pPr algn="ctr">
+              <a:buNone/>
               <a:defRPr sz="1650" b="1">
                 <a:solidFill>
                   <a:srgbClr val="263746"/>
@@ -7356,6 +7391,7 @@
           <a:lstStyle xmlns:a="http://schemas.openxmlformats.org/drawingml/2006/main"/>
           <a:p xmlns:a="http://schemas.openxmlformats.org/drawingml/2006/main">
             <a:pPr algn="ctr">
+              <a:buNone/>
               <a:defRPr sz="1650" b="1">
                 <a:solidFill>
                   <a:srgbClr val="263746"/>
@@ -7411,6 +7447,7 @@
           <a:lstStyle xmlns:a="http://schemas.openxmlformats.org/drawingml/2006/main"/>
           <a:p xmlns:a="http://schemas.openxmlformats.org/drawingml/2006/main">
             <a:pPr algn="ctr">
+              <a:buNone/>
               <a:defRPr sz="1650" b="1">
                 <a:solidFill>
                   <a:srgbClr val="C8161E"/>
@@ -7466,6 +7503,7 @@
           <a:lstStyle xmlns:a="http://schemas.openxmlformats.org/drawingml/2006/main"/>
           <a:p xmlns:a="http://schemas.openxmlformats.org/drawingml/2006/main">
             <a:pPr algn="ctr">
+              <a:buNone/>
               <a:defRPr sz="1650" b="1">
                 <a:solidFill>
                   <a:srgbClr val="C8161E"/>
@@ -7521,6 +7559,7 @@
           <a:lstStyle xmlns:a="http://schemas.openxmlformats.org/drawingml/2006/main"/>
           <a:p xmlns:a="http://schemas.openxmlformats.org/drawingml/2006/main">
             <a:pPr algn="ctr">
+              <a:buNone/>
               <a:defRPr sz="1500" b="1">
                 <a:solidFill>
                   <a:srgbClr val="18354E"/>
@@ -7541,6 +7580,7 @@
           </a:p>
           <a:p xmlns:a="http://schemas.openxmlformats.org/drawingml/2006/main">
             <a:pPr algn="ctr">
+              <a:buNone/>
               <a:defRPr sz="1500" b="1">
                 <a:solidFill>
                   <a:srgbClr val="18354E"/>
@@ -7596,6 +7636,7 @@
           <a:lstStyle xmlns:a="http://schemas.openxmlformats.org/drawingml/2006/main"/>
           <a:p xmlns:a="http://schemas.openxmlformats.org/drawingml/2006/main">
             <a:pPr algn="ctr">
+              <a:buNone/>
               <a:defRPr sz="1500" b="1">
                 <a:solidFill>
                   <a:srgbClr val="18354E"/>
@@ -7616,6 +7657,7 @@
           </a:p>
           <a:p xmlns:a="http://schemas.openxmlformats.org/drawingml/2006/main">
             <a:pPr algn="ctr">
+              <a:buNone/>
               <a:defRPr sz="1500" b="1">
                 <a:solidFill>
                   <a:srgbClr val="18354E"/>
@@ -7671,6 +7713,7 @@
           <a:lstStyle xmlns:a="http://schemas.openxmlformats.org/drawingml/2006/main"/>
           <a:p xmlns:a="http://schemas.openxmlformats.org/drawingml/2006/main">
             <a:pPr algn="ctr">
+              <a:buNone/>
               <a:defRPr sz="1500" b="1">
                 <a:solidFill>
                   <a:srgbClr val="18354E"/>
@@ -7691,6 +7734,7 @@
           </a:p>
           <a:p xmlns:a="http://schemas.openxmlformats.org/drawingml/2006/main">
             <a:pPr algn="ctr">
+              <a:buNone/>
               <a:defRPr sz="1500" b="1">
                 <a:solidFill>
                   <a:srgbClr val="18354E"/>
@@ -7746,6 +7790,7 @@
           <a:lstStyle xmlns:a="http://schemas.openxmlformats.org/drawingml/2006/main"/>
           <a:p xmlns:a="http://schemas.openxmlformats.org/drawingml/2006/main">
             <a:pPr algn="ctr">
+              <a:buNone/>
               <a:defRPr sz="1500" b="1">
                 <a:solidFill>
                   <a:srgbClr val="C8161E"/>
@@ -7766,6 +7811,7 @@
           </a:p>
           <a:p xmlns:a="http://schemas.openxmlformats.org/drawingml/2006/main">
             <a:pPr algn="ctr">
+              <a:buNone/>
               <a:defRPr sz="1500" b="1">
                 <a:solidFill>
                   <a:srgbClr val="C8161E"/>
@@ -7834,7 +7880,9 @@
           <a:bodyPr xmlns:a="http://schemas.openxmlformats.org/drawingml/2006/main" lIns="76200" tIns="0" rIns="76200" bIns="0" anchor="ctr"/>
           <a:lstStyle xmlns:a="http://schemas.openxmlformats.org/drawingml/2006/main"/>
           <a:p xmlns:a="http://schemas.openxmlformats.org/drawingml/2006/main">
-            <a:pPr algn="l"/>
+            <a:pPr algn="l">
+              <a:buNone/>
+            </a:pPr>
             <a:r>
               <a:rPr sz="2250" b="1">
                 <a:solidFill>
@@ -7913,6 +7961,7 @@
           <a:lstStyle xmlns:a="http://schemas.openxmlformats.org/drawingml/2006/main"/>
           <a:p xmlns:a="http://schemas.openxmlformats.org/drawingml/2006/main">
             <a:pPr algn="ctr">
+              <a:buNone/>
               <a:defRPr sz="2100" b="1">
                 <a:solidFill>
                   <a:srgbClr val="667684"/>
@@ -7968,6 +8017,7 @@
           <a:lstStyle xmlns:a="http://schemas.openxmlformats.org/drawingml/2006/main"/>
           <a:p xmlns:a="http://schemas.openxmlformats.org/drawingml/2006/main">
             <a:pPr algn="ctr">
+              <a:buNone/>
               <a:defRPr sz="2175" b="1">
                 <a:solidFill>
                   <a:srgbClr val="C8161E"/>
@@ -8021,6 +8071,7 @@
           <a:lstStyle xmlns:a="http://schemas.openxmlformats.org/drawingml/2006/main"/>
           <a:p xmlns:a="http://schemas.openxmlformats.org/drawingml/2006/main">
             <a:pPr algn="ctr">
+              <a:buNone/>
               <a:defRPr sz="3900" b="1">
                 <a:solidFill>
                   <a:srgbClr val="C8161E"/>
@@ -8074,6 +8125,7 @@
           <a:lstStyle xmlns:a="http://schemas.openxmlformats.org/drawingml/2006/main"/>
           <a:p xmlns:a="http://schemas.openxmlformats.org/drawingml/2006/main">
             <a:pPr algn="ctr">
+              <a:buNone/>
               <a:defRPr sz="1950" b="1">
                 <a:solidFill>
                   <a:srgbClr val="18354E"/>
@@ -8129,6 +8181,7 @@
           <a:lstStyle xmlns:a="http://schemas.openxmlformats.org/drawingml/2006/main"/>
           <a:p xmlns:a="http://schemas.openxmlformats.org/drawingml/2006/main">
             <a:pPr algn="ctr">
+              <a:buNone/>
               <a:defRPr sz="1875" b="1">
                 <a:solidFill>
                   <a:srgbClr val="28745A"/>
@@ -8149,6 +8202,7 @@
           </a:p>
           <a:p xmlns:a="http://schemas.openxmlformats.org/drawingml/2006/main">
             <a:pPr algn="ctr">
+              <a:buNone/>
               <a:defRPr sz="1875" b="1">
                 <a:solidFill>
                   <a:srgbClr val="28745A"/>
@@ -8285,6 +8339,7 @@
           <a:lstStyle xmlns:a="http://schemas.openxmlformats.org/drawingml/2006/main"/>
           <a:p xmlns:a="http://schemas.openxmlformats.org/drawingml/2006/main">
             <a:pPr algn="ctr">
+              <a:buNone/>
               <a:defRPr sz="1650" b="1">
                 <a:solidFill>
                   <a:srgbClr val="C8161E"/>
@@ -8353,7 +8408,9 @@
           <a:bodyPr xmlns:a="http://schemas.openxmlformats.org/drawingml/2006/main" lIns="76200" tIns="0" rIns="76200" bIns="0" anchor="ctr"/>
           <a:lstStyle xmlns:a="http://schemas.openxmlformats.org/drawingml/2006/main"/>
           <a:p xmlns:a="http://schemas.openxmlformats.org/drawingml/2006/main">
-            <a:pPr algn="l"/>
+            <a:pPr algn="l">
+              <a:buNone/>
+            </a:pPr>
             <a:r>
               <a:rPr sz="2250" b="1">
                 <a:solidFill>
@@ -8570,6 +8627,7 @@
           <a:lstStyle xmlns:a="http://schemas.openxmlformats.org/drawingml/2006/main"/>
           <a:p xmlns:a="http://schemas.openxmlformats.org/drawingml/2006/main">
             <a:pPr algn="ctr">
+              <a:buNone/>
               <a:defRPr sz="1650" b="1">
                 <a:solidFill>
                   <a:srgbClr val="18354E"/>
@@ -8625,6 +8683,7 @@
           <a:lstStyle xmlns:a="http://schemas.openxmlformats.org/drawingml/2006/main"/>
           <a:p xmlns:a="http://schemas.openxmlformats.org/drawingml/2006/main">
             <a:pPr algn="ctr">
+              <a:buNone/>
               <a:defRPr sz="1650" b="1">
                 <a:solidFill>
                   <a:srgbClr val="18354E"/>
@@ -8680,6 +8739,7 @@
           <a:lstStyle xmlns:a="http://schemas.openxmlformats.org/drawingml/2006/main"/>
           <a:p xmlns:a="http://schemas.openxmlformats.org/drawingml/2006/main">
             <a:pPr algn="ctr">
+              <a:buNone/>
               <a:defRPr sz="1650" b="1">
                 <a:solidFill>
                   <a:srgbClr val="18354E"/>
@@ -8735,6 +8795,7 @@
           <a:lstStyle xmlns:a="http://schemas.openxmlformats.org/drawingml/2006/main"/>
           <a:p xmlns:a="http://schemas.openxmlformats.org/drawingml/2006/main">
             <a:pPr algn="ctr">
+              <a:buNone/>
               <a:defRPr sz="1650" b="1">
                 <a:solidFill>
                   <a:srgbClr val="18354E"/>
@@ -8790,6 +8851,7 @@
           <a:lstStyle xmlns:a="http://schemas.openxmlformats.org/drawingml/2006/main"/>
           <a:p xmlns:a="http://schemas.openxmlformats.org/drawingml/2006/main">
             <a:pPr algn="ctr">
+              <a:buNone/>
               <a:defRPr sz="1650" b="1">
                 <a:solidFill>
                   <a:srgbClr val="C8161E"/>
@@ -8858,7 +8920,9 @@
           <a:bodyPr xmlns:a="http://schemas.openxmlformats.org/drawingml/2006/main" lIns="76200" tIns="0" rIns="76200" bIns="0" anchor="ctr"/>
           <a:lstStyle xmlns:a="http://schemas.openxmlformats.org/drawingml/2006/main"/>
           <a:p xmlns:a="http://schemas.openxmlformats.org/drawingml/2006/main">
-            <a:pPr algn="l"/>
+            <a:pPr algn="l">
+              <a:buNone/>
+            </a:pPr>
             <a:r>
               <a:rPr sz="2250" b="1">
                 <a:solidFill>
@@ -8935,6 +8999,7 @@
           <a:lstStyle xmlns:a="http://schemas.openxmlformats.org/drawingml/2006/main"/>
           <a:p xmlns:a="http://schemas.openxmlformats.org/drawingml/2006/main">
             <a:pPr algn="ctr">
+              <a:buNone/>
               <a:defRPr sz="2100" b="1">
                 <a:solidFill>
                   <a:srgbClr val="18354E"/>
@@ -8990,6 +9055,7 @@
           <a:lstStyle xmlns:a="http://schemas.openxmlformats.org/drawingml/2006/main"/>
           <a:p xmlns:a="http://schemas.openxmlformats.org/drawingml/2006/main">
             <a:pPr algn="ctr">
+              <a:buNone/>
               <a:defRPr sz="1800" b="1">
                 <a:solidFill>
                   <a:srgbClr val="263746"/>
@@ -9043,6 +9109,7 @@
           <a:lstStyle xmlns:a="http://schemas.openxmlformats.org/drawingml/2006/main"/>
           <a:p xmlns:a="http://schemas.openxmlformats.org/drawingml/2006/main">
             <a:pPr algn="ctr">
+              <a:buNone/>
               <a:defRPr sz="2100" b="1">
                 <a:solidFill>
                   <a:srgbClr val="28745A"/>
@@ -9098,6 +9165,7 @@
           <a:lstStyle xmlns:a="http://schemas.openxmlformats.org/drawingml/2006/main"/>
           <a:p xmlns:a="http://schemas.openxmlformats.org/drawingml/2006/main">
             <a:pPr algn="ctr">
+              <a:buNone/>
               <a:defRPr sz="1800" b="1">
                 <a:solidFill>
                   <a:srgbClr val="263746"/>
@@ -9151,6 +9219,7 @@
           <a:lstStyle xmlns:a="http://schemas.openxmlformats.org/drawingml/2006/main"/>
           <a:p xmlns:a="http://schemas.openxmlformats.org/drawingml/2006/main">
             <a:pPr algn="ctr">
+              <a:buNone/>
               <a:defRPr sz="2100" b="1">
                 <a:solidFill>
                   <a:srgbClr val="A86C12"/>
@@ -9206,6 +9275,7 @@
           <a:lstStyle xmlns:a="http://schemas.openxmlformats.org/drawingml/2006/main"/>
           <a:p xmlns:a="http://schemas.openxmlformats.org/drawingml/2006/main">
             <a:pPr algn="ctr">
+              <a:buNone/>
               <a:defRPr sz="1800" b="1">
                 <a:solidFill>
                   <a:srgbClr val="263746"/>
@@ -9259,6 +9329,7 @@
           <a:lstStyle xmlns:a="http://schemas.openxmlformats.org/drawingml/2006/main"/>
           <a:p xmlns:a="http://schemas.openxmlformats.org/drawingml/2006/main">
             <a:pPr algn="ctr">
+              <a:buNone/>
               <a:defRPr sz="2100" b="1">
                 <a:solidFill>
                   <a:srgbClr val="C8161E"/>
@@ -9314,6 +9385,7 @@
           <a:lstStyle xmlns:a="http://schemas.openxmlformats.org/drawingml/2006/main"/>
           <a:p xmlns:a="http://schemas.openxmlformats.org/drawingml/2006/main">
             <a:pPr algn="ctr">
+              <a:buNone/>
               <a:defRPr sz="1800" b="1">
                 <a:solidFill>
                   <a:srgbClr val="263746"/>
@@ -9400,6 +9472,7 @@
           <a:lstStyle xmlns:a="http://schemas.openxmlformats.org/drawingml/2006/main"/>
           <a:p xmlns:a="http://schemas.openxmlformats.org/drawingml/2006/main">
             <a:pPr algn="ctr">
+              <a:buNone/>
               <a:defRPr sz="2550" b="1">
                 <a:solidFill>
                   <a:srgbClr val="FFFFFF"/>
@@ -9453,6 +9526,7 @@
           <a:lstStyle xmlns:a="http://schemas.openxmlformats.org/drawingml/2006/main"/>
           <a:p xmlns:a="http://schemas.openxmlformats.org/drawingml/2006/main">
             <a:pPr algn="ctr">
+              <a:buNone/>
               <a:defRPr sz="1650" b="1">
                 <a:solidFill>
                   <a:srgbClr val="C8161E"/>
@@ -9521,7 +9595,9 @@
           <a:bodyPr xmlns:a="http://schemas.openxmlformats.org/drawingml/2006/main" lIns="76200" tIns="0" rIns="76200" bIns="0" anchor="ctr"/>
           <a:lstStyle xmlns:a="http://schemas.openxmlformats.org/drawingml/2006/main"/>
           <a:p xmlns:a="http://schemas.openxmlformats.org/drawingml/2006/main">
-            <a:pPr algn="l"/>
+            <a:pPr algn="l">
+              <a:buNone/>
+            </a:pPr>
             <a:r>
               <a:rPr sz="2250" b="1">
                 <a:solidFill>
@@ -9600,6 +9676,7 @@
           <a:lstStyle xmlns:a="http://schemas.openxmlformats.org/drawingml/2006/main"/>
           <a:p xmlns:a="http://schemas.openxmlformats.org/drawingml/2006/main">
             <a:pPr algn="ctr">
+              <a:buNone/>
               <a:defRPr sz="1425" b="1">
                 <a:solidFill>
                   <a:srgbClr val="FFFFFF"/>
@@ -9655,6 +9732,7 @@
           <a:lstStyle xmlns:a="http://schemas.openxmlformats.org/drawingml/2006/main"/>
           <a:p xmlns:a="http://schemas.openxmlformats.org/drawingml/2006/main">
             <a:pPr algn="ctr">
+              <a:buNone/>
               <a:defRPr sz="1425" b="1">
                 <a:solidFill>
                   <a:srgbClr val="FFFFFF"/>
@@ -9710,6 +9788,7 @@
           <a:lstStyle xmlns:a="http://schemas.openxmlformats.org/drawingml/2006/main"/>
           <a:p xmlns:a="http://schemas.openxmlformats.org/drawingml/2006/main">
             <a:pPr algn="ctr">
+              <a:buNone/>
               <a:defRPr sz="1425" b="1">
                 <a:solidFill>
                   <a:srgbClr val="FFFFFF"/>
@@ -9765,6 +9844,7 @@
           <a:lstStyle xmlns:a="http://schemas.openxmlformats.org/drawingml/2006/main"/>
           <a:p xmlns:a="http://schemas.openxmlformats.org/drawingml/2006/main">
             <a:pPr algn="ctr">
+              <a:buNone/>
               <a:defRPr sz="1425" b="1">
                 <a:solidFill>
                   <a:srgbClr val="FFFFFF"/>
@@ -9820,6 +9900,7 @@
           <a:lstStyle xmlns:a="http://schemas.openxmlformats.org/drawingml/2006/main"/>
           <a:p xmlns:a="http://schemas.openxmlformats.org/drawingml/2006/main">
             <a:pPr algn="ctr">
+              <a:buNone/>
               <a:defRPr sz="1425" b="1">
                 <a:solidFill>
                   <a:srgbClr val="FFFFFF"/>
@@ -9875,6 +9956,7 @@
           <a:lstStyle xmlns:a="http://schemas.openxmlformats.org/drawingml/2006/main"/>
           <a:p xmlns:a="http://schemas.openxmlformats.org/drawingml/2006/main">
             <a:pPr algn="ctr">
+              <a:buNone/>
               <a:defRPr sz="1425" b="1">
                 <a:solidFill>
                   <a:srgbClr val="FFFFFF"/>
@@ -10721,6 +10803,7 @@
           <a:lstStyle xmlns:a="http://schemas.openxmlformats.org/drawingml/2006/main"/>
           <a:p xmlns:a="http://schemas.openxmlformats.org/drawingml/2006/main">
             <a:pPr algn="ctr">
+              <a:buNone/>
               <a:defRPr sz="1575" b="1">
                 <a:solidFill>
                   <a:srgbClr val="FFFFFF"/>
@@ -10741,6 +10824,7 @@
           </a:p>
           <a:p xmlns:a="http://schemas.openxmlformats.org/drawingml/2006/main">
             <a:pPr algn="ctr">
+              <a:buNone/>
               <a:defRPr sz="1575" b="1">
                 <a:solidFill>
                   <a:srgbClr val="FFFFFF"/>
@@ -10809,7 +10893,9 @@
           <a:bodyPr xmlns:a="http://schemas.openxmlformats.org/drawingml/2006/main" lIns="76200" tIns="0" rIns="76200" bIns="0" anchor="ctr"/>
           <a:lstStyle xmlns:a="http://schemas.openxmlformats.org/drawingml/2006/main"/>
           <a:p xmlns:a="http://schemas.openxmlformats.org/drawingml/2006/main">
-            <a:pPr algn="l"/>
+            <a:pPr algn="l">
+              <a:buNone/>
+            </a:pPr>
             <a:r>
               <a:rPr sz="2250" b="1">
                 <a:solidFill>
@@ -10888,6 +10974,7 @@
           <a:lstStyle xmlns:a="http://schemas.openxmlformats.org/drawingml/2006/main"/>
           <a:p xmlns:a="http://schemas.openxmlformats.org/drawingml/2006/main">
             <a:pPr algn="ctr">
+              <a:buNone/>
               <a:defRPr sz="2325" b="1">
                 <a:solidFill>
                   <a:srgbClr val="18354E"/>
@@ -10941,6 +11028,7 @@
           <a:lstStyle xmlns:a="http://schemas.openxmlformats.org/drawingml/2006/main"/>
           <a:p xmlns:a="http://schemas.openxmlformats.org/drawingml/2006/main">
             <a:pPr algn="ctr">
+              <a:buNone/>
               <a:defRPr sz="2100" b="1">
                 <a:solidFill>
                   <a:srgbClr val="667684"/>
@@ -10996,6 +11084,7 @@
           <a:lstStyle xmlns:a="http://schemas.openxmlformats.org/drawingml/2006/main"/>
           <a:p xmlns:a="http://schemas.openxmlformats.org/drawingml/2006/main">
             <a:pPr algn="ctr">
+              <a:buNone/>
               <a:defRPr sz="2325" b="1">
                 <a:solidFill>
                   <a:srgbClr val="C8161E"/>
@@ -11049,6 +11138,7 @@
           <a:lstStyle xmlns:a="http://schemas.openxmlformats.org/drawingml/2006/main"/>
           <a:p xmlns:a="http://schemas.openxmlformats.org/drawingml/2006/main">
             <a:pPr algn="ctr">
+              <a:buNone/>
               <a:defRPr sz="1650" b="1">
                 <a:solidFill>
                   <a:srgbClr val="263746"/>
@@ -11102,6 +11192,7 @@
           <a:lstStyle xmlns:a="http://schemas.openxmlformats.org/drawingml/2006/main"/>
           <a:p xmlns:a="http://schemas.openxmlformats.org/drawingml/2006/main">
             <a:pPr algn="ctr">
+              <a:buNone/>
               <a:defRPr sz="1800" b="1">
                 <a:solidFill>
                   <a:srgbClr val="C8161E"/>
@@ -11170,7 +11261,9 @@
           <a:bodyPr xmlns:a="http://schemas.openxmlformats.org/drawingml/2006/main" lIns="76200" tIns="0" rIns="76200" bIns="0" anchor="ctr"/>
           <a:lstStyle xmlns:a="http://schemas.openxmlformats.org/drawingml/2006/main"/>
           <a:p xmlns:a="http://schemas.openxmlformats.org/drawingml/2006/main">
-            <a:pPr algn="l"/>
+            <a:pPr algn="l">
+              <a:buNone/>
+            </a:pPr>
             <a:r>
               <a:rPr sz="2250" b="1">
                 <a:solidFill>
@@ -11247,6 +11340,7 @@
           <a:lstStyle xmlns:a="http://schemas.openxmlformats.org/drawingml/2006/main"/>
           <a:p xmlns:a="http://schemas.openxmlformats.org/drawingml/2006/main">
             <a:pPr algn="ctr">
+              <a:buNone/>
               <a:defRPr sz="2100" b="1">
                 <a:solidFill>
                   <a:srgbClr val="C8161E"/>
@@ -11300,6 +11394,7 @@
           <a:lstStyle xmlns:a="http://schemas.openxmlformats.org/drawingml/2006/main"/>
           <a:p xmlns:a="http://schemas.openxmlformats.org/drawingml/2006/main">
             <a:pPr algn="ctr">
+              <a:buNone/>
               <a:defRPr sz="2100" b="1">
                 <a:solidFill>
                   <a:srgbClr val="28745A"/>
@@ -11471,6 +11566,7 @@
           <a:lstStyle xmlns:a="http://schemas.openxmlformats.org/drawingml/2006/main"/>
           <a:p xmlns:a="http://schemas.openxmlformats.org/drawingml/2006/main">
             <a:pPr algn="ctr">
+              <a:buNone/>
               <a:defRPr sz="2025" b="1">
                 <a:solidFill>
                   <a:srgbClr val="C8161E"/>
@@ -11539,7 +11635,9 @@
           <a:bodyPr xmlns:a="http://schemas.openxmlformats.org/drawingml/2006/main" lIns="76200" tIns="0" rIns="76200" bIns="0" anchor="ctr"/>
           <a:lstStyle xmlns:a="http://schemas.openxmlformats.org/drawingml/2006/main"/>
           <a:p xmlns:a="http://schemas.openxmlformats.org/drawingml/2006/main">
-            <a:pPr algn="l"/>
+            <a:pPr algn="l">
+              <a:buNone/>
+            </a:pPr>
             <a:r>
               <a:rPr sz="2250" b="1">
                 <a:solidFill>
@@ -11618,6 +11716,7 @@
           <a:lstStyle xmlns:a="http://schemas.openxmlformats.org/drawingml/2006/main"/>
           <a:p xmlns:a="http://schemas.openxmlformats.org/drawingml/2006/main">
             <a:pPr algn="ctr">
+              <a:buNone/>
               <a:defRPr sz="2175" b="1">
                 <a:solidFill>
                   <a:srgbClr val="FFFFFF"/>
@@ -11673,6 +11772,7 @@
           <a:lstStyle xmlns:a="http://schemas.openxmlformats.org/drawingml/2006/main"/>
           <a:p xmlns:a="http://schemas.openxmlformats.org/drawingml/2006/main">
             <a:pPr algn="ctr">
+              <a:buNone/>
               <a:defRPr sz="1800" b="1">
                 <a:solidFill>
                   <a:srgbClr val="263746"/>
@@ -11728,6 +11828,7 @@
           <a:lstStyle xmlns:a="http://schemas.openxmlformats.org/drawingml/2006/main"/>
           <a:p xmlns:a="http://schemas.openxmlformats.org/drawingml/2006/main">
             <a:pPr algn="ctr">
+              <a:buNone/>
               <a:defRPr sz="1800" b="1">
                 <a:solidFill>
                   <a:srgbClr val="263746"/>
@@ -11783,6 +11884,7 @@
           <a:lstStyle xmlns:a="http://schemas.openxmlformats.org/drawingml/2006/main"/>
           <a:p xmlns:a="http://schemas.openxmlformats.org/drawingml/2006/main">
             <a:pPr algn="ctr">
+              <a:buNone/>
               <a:defRPr sz="1800" b="1">
                 <a:solidFill>
                   <a:srgbClr val="263746"/>
@@ -11838,6 +11940,7 @@
           <a:lstStyle xmlns:a="http://schemas.openxmlformats.org/drawingml/2006/main"/>
           <a:p xmlns:a="http://schemas.openxmlformats.org/drawingml/2006/main">
             <a:pPr algn="ctr">
+              <a:buNone/>
               <a:defRPr sz="1800" b="1">
                 <a:solidFill>
                   <a:srgbClr val="C8161E"/>
@@ -11906,7 +12009,9 @@
           <a:bodyPr xmlns:a="http://schemas.openxmlformats.org/drawingml/2006/main" lIns="76200" tIns="0" rIns="76200" bIns="0" anchor="ctr"/>
           <a:lstStyle xmlns:a="http://schemas.openxmlformats.org/drawingml/2006/main"/>
           <a:p xmlns:a="http://schemas.openxmlformats.org/drawingml/2006/main">
-            <a:pPr algn="l"/>
+            <a:pPr algn="l">
+              <a:buNone/>
+            </a:pPr>
             <a:r>
               <a:rPr sz="2250" b="1">
                 <a:solidFill>
@@ -11985,6 +12090,7 @@
           <a:lstStyle xmlns:a="http://schemas.openxmlformats.org/drawingml/2006/main"/>
           <a:p xmlns:a="http://schemas.openxmlformats.org/drawingml/2006/main">
             <a:pPr algn="ctr">
+              <a:buNone/>
               <a:defRPr sz="2700" b="1">
                 <a:solidFill>
                   <a:srgbClr val="18354E"/>
@@ -12038,6 +12144,7 @@
           <a:lstStyle xmlns:a="http://schemas.openxmlformats.org/drawingml/2006/main"/>
           <a:p xmlns:a="http://schemas.openxmlformats.org/drawingml/2006/main">
             <a:pPr algn="ctr">
+              <a:buNone/>
               <a:defRPr sz="1650" b="0">
                 <a:solidFill>
                   <a:srgbClr val="667684"/>
@@ -12122,6 +12229,7 @@
           <a:lstStyle xmlns:a="http://schemas.openxmlformats.org/drawingml/2006/main"/>
           <a:p xmlns:a="http://schemas.openxmlformats.org/drawingml/2006/main">
             <a:pPr algn="ctr">
+              <a:buNone/>
               <a:defRPr sz="2100" b="1">
                 <a:solidFill>
                   <a:srgbClr val="667684"/>
@@ -12175,6 +12283,7 @@
           <a:lstStyle xmlns:a="http://schemas.openxmlformats.org/drawingml/2006/main"/>
           <a:p xmlns:a="http://schemas.openxmlformats.org/drawingml/2006/main">
             <a:pPr algn="ctr">
+              <a:buNone/>
               <a:defRPr sz="1575" b="1">
                 <a:solidFill>
                   <a:srgbClr val="667684"/>
@@ -12230,6 +12339,7 @@
           <a:lstStyle xmlns:a="http://schemas.openxmlformats.org/drawingml/2006/main"/>
           <a:p xmlns:a="http://schemas.openxmlformats.org/drawingml/2006/main">
             <a:pPr algn="ctr">
+              <a:buNone/>
               <a:defRPr sz="1425" b="1">
                 <a:solidFill>
                   <a:srgbClr val="263746"/>
@@ -12283,6 +12393,7 @@
           <a:lstStyle xmlns:a="http://schemas.openxmlformats.org/drawingml/2006/main"/>
           <a:p xmlns:a="http://schemas.openxmlformats.org/drawingml/2006/main">
             <a:pPr algn="ctr">
+              <a:buNone/>
               <a:defRPr sz="2100" b="1">
                 <a:solidFill>
                   <a:srgbClr val="667684"/>
@@ -12336,6 +12447,7 @@
           <a:lstStyle xmlns:a="http://schemas.openxmlformats.org/drawingml/2006/main"/>
           <a:p xmlns:a="http://schemas.openxmlformats.org/drawingml/2006/main">
             <a:pPr algn="ctr">
+              <a:buNone/>
               <a:defRPr sz="1575" b="1">
                 <a:solidFill>
                   <a:srgbClr val="2F638A"/>
@@ -12391,6 +12503,7 @@
           <a:lstStyle xmlns:a="http://schemas.openxmlformats.org/drawingml/2006/main"/>
           <a:p xmlns:a="http://schemas.openxmlformats.org/drawingml/2006/main">
             <a:pPr algn="ctr">
+              <a:buNone/>
               <a:defRPr sz="1425" b="1">
                 <a:solidFill>
                   <a:srgbClr val="263746"/>
@@ -12444,6 +12557,7 @@
           <a:lstStyle xmlns:a="http://schemas.openxmlformats.org/drawingml/2006/main"/>
           <a:p xmlns:a="http://schemas.openxmlformats.org/drawingml/2006/main">
             <a:pPr algn="ctr">
+              <a:buNone/>
               <a:defRPr sz="2100" b="1">
                 <a:solidFill>
                   <a:srgbClr val="667684"/>
@@ -12497,6 +12611,7 @@
           <a:lstStyle xmlns:a="http://schemas.openxmlformats.org/drawingml/2006/main"/>
           <a:p xmlns:a="http://schemas.openxmlformats.org/drawingml/2006/main">
             <a:pPr algn="ctr">
+              <a:buNone/>
               <a:defRPr sz="1575" b="1">
                 <a:solidFill>
                   <a:srgbClr val="28745A"/>
@@ -12552,6 +12667,7 @@
           <a:lstStyle xmlns:a="http://schemas.openxmlformats.org/drawingml/2006/main"/>
           <a:p xmlns:a="http://schemas.openxmlformats.org/drawingml/2006/main">
             <a:pPr algn="ctr">
+              <a:buNone/>
               <a:defRPr sz="1425" b="1">
                 <a:solidFill>
                   <a:srgbClr val="263746"/>
@@ -12605,6 +12721,7 @@
           <a:lstStyle xmlns:a="http://schemas.openxmlformats.org/drawingml/2006/main"/>
           <a:p xmlns:a="http://schemas.openxmlformats.org/drawingml/2006/main">
             <a:pPr algn="ctr">
+              <a:buNone/>
               <a:defRPr sz="1575" b="1">
                 <a:solidFill>
                   <a:srgbClr val="C8161E"/>
@@ -12660,6 +12777,7 @@
           <a:lstStyle xmlns:a="http://schemas.openxmlformats.org/drawingml/2006/main"/>
           <a:p xmlns:a="http://schemas.openxmlformats.org/drawingml/2006/main">
             <a:pPr algn="ctr">
+              <a:buNone/>
               <a:defRPr sz="1425" b="1">
                 <a:solidFill>
                   <a:srgbClr val="263746"/>
@@ -12744,6 +12862,7 @@
           <a:lstStyle xmlns:a="http://schemas.openxmlformats.org/drawingml/2006/main"/>
           <a:p xmlns:a="http://schemas.openxmlformats.org/drawingml/2006/main">
             <a:pPr algn="ctr">
+              <a:buNone/>
               <a:defRPr sz="1500" b="1">
                 <a:solidFill>
                   <a:srgbClr val="C8161E"/>
@@ -12797,6 +12916,7 @@
           <a:lstStyle xmlns:a="http://schemas.openxmlformats.org/drawingml/2006/main"/>
           <a:p xmlns:a="http://schemas.openxmlformats.org/drawingml/2006/main">
             <a:pPr algn="ctr">
+              <a:buNone/>
               <a:defRPr sz="1650" b="1">
                 <a:solidFill>
                   <a:srgbClr val="C8161E"/>
@@ -12865,7 +12985,9 @@
           <a:bodyPr xmlns:a="http://schemas.openxmlformats.org/drawingml/2006/main" lIns="76200" tIns="0" rIns="76200" bIns="0" anchor="ctr"/>
           <a:lstStyle xmlns:a="http://schemas.openxmlformats.org/drawingml/2006/main"/>
           <a:p xmlns:a="http://schemas.openxmlformats.org/drawingml/2006/main">
-            <a:pPr algn="l"/>
+            <a:pPr algn="l">
+              <a:buNone/>
+            </a:pPr>
             <a:r>
               <a:rPr sz="2250" b="1">
                 <a:solidFill>
@@ -12975,6 +13097,7 @@
           <a:lstStyle xmlns:a="http://schemas.openxmlformats.org/drawingml/2006/main"/>
           <a:p xmlns:a="http://schemas.openxmlformats.org/drawingml/2006/main">
             <a:pPr algn="ctr">
+              <a:buNone/>
               <a:defRPr sz="2325" b="1">
                 <a:solidFill>
                   <a:srgbClr val="2F638A"/>
@@ -13030,6 +13153,7 @@
           <a:lstStyle xmlns:a="http://schemas.openxmlformats.org/drawingml/2006/main"/>
           <a:p xmlns:a="http://schemas.openxmlformats.org/drawingml/2006/main">
             <a:pPr algn="ctr">
+              <a:buNone/>
               <a:defRPr sz="2325" b="1">
                 <a:solidFill>
                   <a:srgbClr val="28745A"/>
@@ -13085,6 +13209,7 @@
           <a:lstStyle xmlns:a="http://schemas.openxmlformats.org/drawingml/2006/main"/>
           <a:p xmlns:a="http://schemas.openxmlformats.org/drawingml/2006/main">
             <a:pPr algn="ctr">
+              <a:buNone/>
               <a:defRPr sz="1575" b="1">
                 <a:solidFill>
                   <a:srgbClr val="263746"/>
@@ -13140,6 +13265,7 @@
           <a:lstStyle xmlns:a="http://schemas.openxmlformats.org/drawingml/2006/main"/>
           <a:p xmlns:a="http://schemas.openxmlformats.org/drawingml/2006/main">
             <a:pPr algn="ctr">
+              <a:buNone/>
               <a:defRPr sz="1575" b="1">
                 <a:solidFill>
                   <a:srgbClr val="263746"/>
@@ -13195,6 +13321,7 @@
           <a:lstStyle xmlns:a="http://schemas.openxmlformats.org/drawingml/2006/main"/>
           <a:p xmlns:a="http://schemas.openxmlformats.org/drawingml/2006/main">
             <a:pPr algn="ctr">
+              <a:buNone/>
               <a:defRPr sz="1575" b="1">
                 <a:solidFill>
                   <a:srgbClr val="263746"/>
@@ -13250,6 +13377,7 @@
           <a:lstStyle xmlns:a="http://schemas.openxmlformats.org/drawingml/2006/main"/>
           <a:p xmlns:a="http://schemas.openxmlformats.org/drawingml/2006/main">
             <a:pPr algn="ctr">
+              <a:buNone/>
               <a:defRPr sz="1575" b="1">
                 <a:solidFill>
                   <a:srgbClr val="263746"/>
@@ -13305,6 +13433,7 @@
           <a:lstStyle xmlns:a="http://schemas.openxmlformats.org/drawingml/2006/main"/>
           <a:p xmlns:a="http://schemas.openxmlformats.org/drawingml/2006/main">
             <a:pPr algn="ctr">
+              <a:buNone/>
               <a:defRPr sz="1575" b="1">
                 <a:solidFill>
                   <a:srgbClr val="C8161E"/>
@@ -13360,6 +13489,7 @@
           <a:lstStyle xmlns:a="http://schemas.openxmlformats.org/drawingml/2006/main"/>
           <a:p xmlns:a="http://schemas.openxmlformats.org/drawingml/2006/main">
             <a:pPr algn="ctr">
+              <a:buNone/>
               <a:defRPr sz="1575" b="1">
                 <a:solidFill>
                   <a:srgbClr val="C8161E"/>
@@ -13413,6 +13543,7 @@
           <a:lstStyle xmlns:a="http://schemas.openxmlformats.org/drawingml/2006/main"/>
           <a:p xmlns:a="http://schemas.openxmlformats.org/drawingml/2006/main">
             <a:pPr algn="ctr">
+              <a:buNone/>
               <a:defRPr sz="1575" b="1">
                 <a:solidFill>
                   <a:srgbClr val="C8161E"/>
@@ -13481,7 +13612,9 @@
           <a:bodyPr xmlns:a="http://schemas.openxmlformats.org/drawingml/2006/main" lIns="76200" tIns="0" rIns="76200" bIns="0" anchor="ctr"/>
           <a:lstStyle xmlns:a="http://schemas.openxmlformats.org/drawingml/2006/main"/>
           <a:p xmlns:a="http://schemas.openxmlformats.org/drawingml/2006/main">
-            <a:pPr algn="l"/>
+            <a:pPr algn="l">
+              <a:buNone/>
+            </a:pPr>
             <a:r>
               <a:rPr sz="2250" b="1">
                 <a:solidFill>
@@ -13560,6 +13693,7 @@
           <a:lstStyle xmlns:a="http://schemas.openxmlformats.org/drawingml/2006/main"/>
           <a:p xmlns:a="http://schemas.openxmlformats.org/drawingml/2006/main">
             <a:pPr algn="ctr">
+              <a:buNone/>
               <a:defRPr sz="1575" b="1">
                 <a:solidFill>
                   <a:srgbClr val="FFFFFF"/>
@@ -13615,6 +13749,7 @@
           <a:lstStyle xmlns:a="http://schemas.openxmlformats.org/drawingml/2006/main"/>
           <a:p xmlns:a="http://schemas.openxmlformats.org/drawingml/2006/main">
             <a:pPr algn="ctr">
+              <a:buNone/>
               <a:defRPr sz="1575" b="1">
                 <a:solidFill>
                   <a:srgbClr val="FFFFFF"/>
@@ -13670,6 +13805,7 @@
           <a:lstStyle xmlns:a="http://schemas.openxmlformats.org/drawingml/2006/main"/>
           <a:p xmlns:a="http://schemas.openxmlformats.org/drawingml/2006/main">
             <a:pPr algn="ctr">
+              <a:buNone/>
               <a:defRPr sz="1575" b="1">
                 <a:solidFill>
                   <a:srgbClr val="FFFFFF"/>
@@ -13725,6 +13861,7 @@
           <a:lstStyle xmlns:a="http://schemas.openxmlformats.org/drawingml/2006/main"/>
           <a:p xmlns:a="http://schemas.openxmlformats.org/drawingml/2006/main">
             <a:pPr algn="ctr">
+              <a:buNone/>
               <a:defRPr sz="1575" b="1">
                 <a:solidFill>
                   <a:srgbClr val="FFFFFF"/>
@@ -13780,6 +13917,7 @@
           <a:lstStyle xmlns:a="http://schemas.openxmlformats.org/drawingml/2006/main"/>
           <a:p xmlns:a="http://schemas.openxmlformats.org/drawingml/2006/main">
             <a:pPr algn="ctr">
+              <a:buNone/>
               <a:defRPr sz="1575" b="1">
                 <a:solidFill>
                   <a:srgbClr val="FFFFFF"/>
@@ -13837,6 +13975,7 @@
           <a:lstStyle xmlns:a="http://schemas.openxmlformats.org/drawingml/2006/main"/>
           <a:p xmlns:a="http://schemas.openxmlformats.org/drawingml/2006/main">
             <a:pPr algn="ctr">
+              <a:buNone/>
               <a:defRPr sz="1575" b="1">
                 <a:solidFill>
                   <a:srgbClr val="263746"/>
@@ -13894,6 +14033,7 @@
           <a:lstStyle xmlns:a="http://schemas.openxmlformats.org/drawingml/2006/main"/>
           <a:p xmlns:a="http://schemas.openxmlformats.org/drawingml/2006/main">
             <a:pPr algn="ctr">
+              <a:buNone/>
               <a:defRPr sz="1575" b="0">
                 <a:solidFill>
                   <a:srgbClr val="263746"/>
@@ -13951,6 +14091,7 @@
           <a:lstStyle xmlns:a="http://schemas.openxmlformats.org/drawingml/2006/main"/>
           <a:p xmlns:a="http://schemas.openxmlformats.org/drawingml/2006/main">
             <a:pPr algn="ctr">
+              <a:buNone/>
               <a:defRPr sz="1575" b="0">
                 <a:solidFill>
                   <a:srgbClr val="263746"/>
@@ -14008,6 +14149,7 @@
           <a:lstStyle xmlns:a="http://schemas.openxmlformats.org/drawingml/2006/main"/>
           <a:p xmlns:a="http://schemas.openxmlformats.org/drawingml/2006/main">
             <a:pPr algn="ctr">
+              <a:buNone/>
               <a:defRPr sz="1575" b="1">
                 <a:solidFill>
                   <a:srgbClr val="C8161E"/>
@@ -14065,6 +14207,7 @@
           <a:lstStyle xmlns:a="http://schemas.openxmlformats.org/drawingml/2006/main"/>
           <a:p xmlns:a="http://schemas.openxmlformats.org/drawingml/2006/main">
             <a:pPr algn="ctr">
+              <a:buNone/>
               <a:defRPr sz="1575" b="1">
                 <a:solidFill>
                   <a:srgbClr val="C8161E"/>
@@ -14122,6 +14265,7 @@
           <a:lstStyle xmlns:a="http://schemas.openxmlformats.org/drawingml/2006/main"/>
           <a:p xmlns:a="http://schemas.openxmlformats.org/drawingml/2006/main">
             <a:pPr algn="ctr">
+              <a:buNone/>
               <a:defRPr sz="1575" b="1">
                 <a:solidFill>
                   <a:srgbClr val="263746"/>
@@ -14179,6 +14323,7 @@
           <a:lstStyle xmlns:a="http://schemas.openxmlformats.org/drawingml/2006/main"/>
           <a:p xmlns:a="http://schemas.openxmlformats.org/drawingml/2006/main">
             <a:pPr algn="ctr">
+              <a:buNone/>
               <a:defRPr sz="1575" b="0">
                 <a:solidFill>
                   <a:srgbClr val="263746"/>
@@ -14236,6 +14381,7 @@
           <a:lstStyle xmlns:a="http://schemas.openxmlformats.org/drawingml/2006/main"/>
           <a:p xmlns:a="http://schemas.openxmlformats.org/drawingml/2006/main">
             <a:pPr algn="ctr">
+              <a:buNone/>
               <a:defRPr sz="1575" b="0">
                 <a:solidFill>
                   <a:srgbClr val="263746"/>
@@ -14293,6 +14439,7 @@
           <a:lstStyle xmlns:a="http://schemas.openxmlformats.org/drawingml/2006/main"/>
           <a:p xmlns:a="http://schemas.openxmlformats.org/drawingml/2006/main">
             <a:pPr algn="ctr">
+              <a:buNone/>
               <a:defRPr sz="1575" b="1">
                 <a:solidFill>
                   <a:srgbClr val="C8161E"/>
@@ -14350,6 +14497,7 @@
           <a:lstStyle xmlns:a="http://schemas.openxmlformats.org/drawingml/2006/main"/>
           <a:p xmlns:a="http://schemas.openxmlformats.org/drawingml/2006/main">
             <a:pPr algn="ctr">
+              <a:buNone/>
               <a:defRPr sz="1575" b="1">
                 <a:solidFill>
                   <a:srgbClr val="C8161E"/>
@@ -14403,6 +14551,7 @@
           <a:lstStyle xmlns:a="http://schemas.openxmlformats.org/drawingml/2006/main"/>
           <a:p xmlns:a="http://schemas.openxmlformats.org/drawingml/2006/main">
             <a:pPr algn="ctr">
+              <a:buNone/>
               <a:defRPr sz="1725" b="1">
                 <a:solidFill>
                   <a:srgbClr val="18354E"/>
@@ -14471,7 +14620,9 @@
           <a:bodyPr xmlns:a="http://schemas.openxmlformats.org/drawingml/2006/main" lIns="76200" tIns="0" rIns="76200" bIns="0" anchor="ctr"/>
           <a:lstStyle xmlns:a="http://schemas.openxmlformats.org/drawingml/2006/main"/>
           <a:p xmlns:a="http://schemas.openxmlformats.org/drawingml/2006/main">
-            <a:pPr algn="l"/>
+            <a:pPr algn="l">
+              <a:buNone/>
+            </a:pPr>
             <a:r>
               <a:rPr sz="2250" b="1">
                 <a:solidFill>
@@ -14548,6 +14699,7 @@
           <a:lstStyle xmlns:a="http://schemas.openxmlformats.org/drawingml/2006/main"/>
           <a:p xmlns:a="http://schemas.openxmlformats.org/drawingml/2006/main">
             <a:pPr algn="l">
+              <a:buNone/>
               <a:defRPr sz="1800" b="1">
                 <a:solidFill>
                   <a:srgbClr val="28745A"/>
@@ -14756,6 +14908,7 @@
           <a:lstStyle xmlns:a="http://schemas.openxmlformats.org/drawingml/2006/main"/>
           <a:p xmlns:a="http://schemas.openxmlformats.org/drawingml/2006/main">
             <a:pPr algn="l">
+              <a:buNone/>
               <a:defRPr sz="1800" b="1">
                 <a:solidFill>
                   <a:srgbClr val="C8161E"/>
@@ -14811,6 +14964,7 @@
           <a:lstStyle xmlns:a="http://schemas.openxmlformats.org/drawingml/2006/main"/>
           <a:p xmlns:a="http://schemas.openxmlformats.org/drawingml/2006/main">
             <a:pPr algn="ctr">
+              <a:buNone/>
               <a:defRPr sz="2025" b="1">
                 <a:solidFill>
                   <a:srgbClr val="C8161E"/>
@@ -14864,6 +15018,7 @@
           <a:lstStyle xmlns:a="http://schemas.openxmlformats.org/drawingml/2006/main"/>
           <a:p xmlns:a="http://schemas.openxmlformats.org/drawingml/2006/main">
             <a:pPr algn="ctr">
+              <a:buNone/>
               <a:defRPr sz="1650" b="1">
                 <a:solidFill>
                   <a:srgbClr val="C8161E"/>
@@ -14932,7 +15087,9 @@
           <a:bodyPr xmlns:a="http://schemas.openxmlformats.org/drawingml/2006/main" lIns="76200" tIns="0" rIns="76200" bIns="0" anchor="ctr"/>
           <a:lstStyle xmlns:a="http://schemas.openxmlformats.org/drawingml/2006/main"/>
           <a:p xmlns:a="http://schemas.openxmlformats.org/drawingml/2006/main">
-            <a:pPr algn="l"/>
+            <a:pPr algn="l">
+              <a:buNone/>
+            </a:pPr>
             <a:r>
               <a:rPr sz="2250" b="1">
                 <a:solidFill>
@@ -15009,6 +15166,7 @@
           <a:lstStyle xmlns:a="http://schemas.openxmlformats.org/drawingml/2006/main"/>
           <a:p xmlns:a="http://schemas.openxmlformats.org/drawingml/2006/main">
             <a:pPr algn="l">
+              <a:buNone/>
               <a:defRPr sz="1500" b="1">
                 <a:solidFill>
                   <a:srgbClr val="C8161E"/>
@@ -15145,6 +15303,7 @@
           <a:lstStyle xmlns:a="http://schemas.openxmlformats.org/drawingml/2006/main"/>
           <a:p xmlns:a="http://schemas.openxmlformats.org/drawingml/2006/main">
             <a:pPr algn="ctr">
+              <a:buNone/>
               <a:defRPr sz="3600" b="1">
                 <a:solidFill>
                   <a:srgbClr val="C8161E"/>
@@ -15200,6 +15359,7 @@
           <a:lstStyle xmlns:a="http://schemas.openxmlformats.org/drawingml/2006/main"/>
           <a:p xmlns:a="http://schemas.openxmlformats.org/drawingml/2006/main">
             <a:pPr algn="ctr">
+              <a:buNone/>
               <a:defRPr sz="1650" b="1">
                 <a:solidFill>
                   <a:srgbClr val="263746"/>
@@ -15255,6 +15415,7 @@
           <a:lstStyle xmlns:a="http://schemas.openxmlformats.org/drawingml/2006/main"/>
           <a:p xmlns:a="http://schemas.openxmlformats.org/drawingml/2006/main">
             <a:pPr algn="ctr">
+              <a:buNone/>
               <a:defRPr sz="1650" b="1">
                 <a:solidFill>
                   <a:srgbClr val="C8161E"/>
@@ -15310,6 +15471,7 @@
           <a:lstStyle xmlns:a="http://schemas.openxmlformats.org/drawingml/2006/main"/>
           <a:p xmlns:a="http://schemas.openxmlformats.org/drawingml/2006/main">
             <a:pPr algn="ctr">
+              <a:buNone/>
               <a:defRPr sz="1650" b="1">
                 <a:solidFill>
                   <a:srgbClr val="263746"/>
@@ -15363,6 +15525,7 @@
           <a:lstStyle xmlns:a="http://schemas.openxmlformats.org/drawingml/2006/main"/>
           <a:p xmlns:a="http://schemas.openxmlformats.org/drawingml/2006/main">
             <a:pPr algn="ctr">
+              <a:buNone/>
               <a:defRPr sz="1650" b="1">
                 <a:solidFill>
                   <a:srgbClr val="C8161E"/>
@@ -15431,7 +15594,9 @@
           <a:bodyPr xmlns:a="http://schemas.openxmlformats.org/drawingml/2006/main" lIns="76200" tIns="0" rIns="76200" bIns="0" anchor="ctr"/>
           <a:lstStyle xmlns:a="http://schemas.openxmlformats.org/drawingml/2006/main"/>
           <a:p xmlns:a="http://schemas.openxmlformats.org/drawingml/2006/main">
-            <a:pPr algn="l"/>
+            <a:pPr algn="l">
+              <a:buNone/>
+            </a:pPr>
             <a:r>
               <a:rPr sz="2250" b="1">
                 <a:solidFill>
@@ -15508,6 +15673,7 @@
           <a:lstStyle xmlns:a="http://schemas.openxmlformats.org/drawingml/2006/main"/>
           <a:p xmlns:a="http://schemas.openxmlformats.org/drawingml/2006/main">
             <a:pPr algn="l">
+              <a:buNone/>
               <a:defRPr sz="1275" b="1">
                 <a:solidFill>
                   <a:srgbClr val="C8161E"/>
@@ -15802,6 +15968,7 @@
           <a:lstStyle xmlns:a="http://schemas.openxmlformats.org/drawingml/2006/main"/>
           <a:p xmlns:a="http://schemas.openxmlformats.org/drawingml/2006/main">
             <a:pPr algn="ctr">
+              <a:buNone/>
               <a:defRPr sz="1425" b="1">
                 <a:solidFill>
                   <a:srgbClr val="18354E"/>
@@ -15822,6 +15989,7 @@
           </a:p>
           <a:p xmlns:a="http://schemas.openxmlformats.org/drawingml/2006/main">
             <a:pPr algn="ctr">
+              <a:buNone/>
               <a:defRPr sz="1425" b="1">
                 <a:solidFill>
                   <a:srgbClr val="18354E"/>
@@ -15877,6 +16045,7 @@
           <a:lstStyle xmlns:a="http://schemas.openxmlformats.org/drawingml/2006/main"/>
           <a:p xmlns:a="http://schemas.openxmlformats.org/drawingml/2006/main">
             <a:pPr algn="ctr">
+              <a:buNone/>
               <a:defRPr sz="1425" b="1">
                 <a:solidFill>
                   <a:srgbClr val="18354E"/>
@@ -15897,6 +16066,7 @@
           </a:p>
           <a:p xmlns:a="http://schemas.openxmlformats.org/drawingml/2006/main">
             <a:pPr algn="ctr">
+              <a:buNone/>
               <a:defRPr sz="1425" b="1">
                 <a:solidFill>
                   <a:srgbClr val="18354E"/>
@@ -15952,6 +16122,7 @@
           <a:lstStyle xmlns:a="http://schemas.openxmlformats.org/drawingml/2006/main"/>
           <a:p xmlns:a="http://schemas.openxmlformats.org/drawingml/2006/main">
             <a:pPr algn="ctr">
+              <a:buNone/>
               <a:defRPr sz="1425" b="1">
                 <a:solidFill>
                   <a:srgbClr val="18354E"/>
@@ -15972,6 +16143,7 @@
           </a:p>
           <a:p xmlns:a="http://schemas.openxmlformats.org/drawingml/2006/main">
             <a:pPr algn="ctr">
+              <a:buNone/>
               <a:defRPr sz="1425" b="1">
                 <a:solidFill>
                   <a:srgbClr val="18354E"/>
@@ -16027,6 +16199,7 @@
           <a:lstStyle xmlns:a="http://schemas.openxmlformats.org/drawingml/2006/main"/>
           <a:p xmlns:a="http://schemas.openxmlformats.org/drawingml/2006/main">
             <a:pPr algn="ctr">
+              <a:buNone/>
               <a:defRPr sz="1425" b="1">
                 <a:solidFill>
                   <a:srgbClr val="C8161E"/>
@@ -16047,6 +16220,7 @@
           </a:p>
           <a:p xmlns:a="http://schemas.openxmlformats.org/drawingml/2006/main">
             <a:pPr algn="ctr">
+              <a:buNone/>
               <a:defRPr sz="1425" b="1">
                 <a:solidFill>
                   <a:srgbClr val="C8161E"/>
@@ -16115,7 +16289,9 @@
           <a:bodyPr xmlns:a="http://schemas.openxmlformats.org/drawingml/2006/main" lIns="76200" tIns="0" rIns="76200" bIns="0" anchor="ctr"/>
           <a:lstStyle xmlns:a="http://schemas.openxmlformats.org/drawingml/2006/main"/>
           <a:p xmlns:a="http://schemas.openxmlformats.org/drawingml/2006/main">
-            <a:pPr algn="l"/>
+            <a:pPr algn="l">
+              <a:buNone/>
+            </a:pPr>
             <a:r>
               <a:rPr sz="2250" b="1">
                 <a:solidFill>
@@ -16192,6 +16368,7 @@
           <a:lstStyle xmlns:a="http://schemas.openxmlformats.org/drawingml/2006/main"/>
           <a:p xmlns:a="http://schemas.openxmlformats.org/drawingml/2006/main">
             <a:pPr algn="l">
+              <a:buNone/>
               <a:defRPr sz="1575" b="1">
                 <a:solidFill>
                   <a:srgbClr val="C8161E"/>
@@ -16412,6 +16589,7 @@
           <a:lstStyle xmlns:a="http://schemas.openxmlformats.org/drawingml/2006/main"/>
           <a:p xmlns:a="http://schemas.openxmlformats.org/drawingml/2006/main">
             <a:pPr algn="l">
+              <a:buNone/>
               <a:defRPr sz="1575" b="1">
                 <a:solidFill>
                   <a:srgbClr val="28745A"/>
@@ -16627,6 +16805,7 @@
           <a:lstStyle xmlns:a="http://schemas.openxmlformats.org/drawingml/2006/main"/>
           <a:p xmlns:a="http://schemas.openxmlformats.org/drawingml/2006/main">
             <a:pPr algn="ctr">
+              <a:buNone/>
               <a:defRPr sz="1800" b="1">
                 <a:solidFill>
                   <a:srgbClr val="C8161E"/>
@@ -16695,7 +16874,9 @@
           <a:bodyPr xmlns:a="http://schemas.openxmlformats.org/drawingml/2006/main" lIns="76200" tIns="0" rIns="76200" bIns="0" anchor="ctr"/>
           <a:lstStyle xmlns:a="http://schemas.openxmlformats.org/drawingml/2006/main"/>
           <a:p xmlns:a="http://schemas.openxmlformats.org/drawingml/2006/main">
-            <a:pPr algn="l"/>
+            <a:pPr algn="l">
+              <a:buNone/>
+            </a:pPr>
             <a:r>
               <a:rPr sz="2250" b="1">
                 <a:solidFill>
@@ -16772,6 +16953,7 @@
           <a:lstStyle xmlns:a="http://schemas.openxmlformats.org/drawingml/2006/main"/>
           <a:p xmlns:a="http://schemas.openxmlformats.org/drawingml/2006/main">
             <a:pPr algn="r">
+              <a:buNone/>
               <a:defRPr sz="1350" b="1">
                 <a:solidFill>
                   <a:srgbClr val="C8161E"/>
@@ -16825,6 +17007,7 @@
           <a:lstStyle xmlns:a="http://schemas.openxmlformats.org/drawingml/2006/main"/>
           <a:p xmlns:a="http://schemas.openxmlformats.org/drawingml/2006/main">
             <a:pPr algn="ctr">
+              <a:buNone/>
               <a:defRPr sz="1950" b="1">
                 <a:solidFill>
                   <a:srgbClr val="18354E"/>
@@ -16878,6 +17061,7 @@
           <a:lstStyle xmlns:a="http://schemas.openxmlformats.org/drawingml/2006/main"/>
           <a:p xmlns:a="http://schemas.openxmlformats.org/drawingml/2006/main">
             <a:pPr algn="l">
+              <a:buNone/>
               <a:defRPr sz="1875" b="1">
                 <a:solidFill>
                   <a:srgbClr val="263746"/>
@@ -16931,6 +17115,7 @@
           <a:lstStyle xmlns:a="http://schemas.openxmlformats.org/drawingml/2006/main"/>
           <a:p xmlns:a="http://schemas.openxmlformats.org/drawingml/2006/main">
             <a:pPr algn="ctr">
+              <a:buNone/>
               <a:defRPr sz="1950" b="1">
                 <a:solidFill>
                   <a:srgbClr val="18354E"/>
@@ -16984,6 +17169,7 @@
           <a:lstStyle xmlns:a="http://schemas.openxmlformats.org/drawingml/2006/main"/>
           <a:p xmlns:a="http://schemas.openxmlformats.org/drawingml/2006/main">
             <a:pPr algn="l">
+              <a:buNone/>
               <a:defRPr sz="1875" b="1">
                 <a:solidFill>
                   <a:srgbClr val="263746"/>
@@ -17037,6 +17223,7 @@
           <a:lstStyle xmlns:a="http://schemas.openxmlformats.org/drawingml/2006/main"/>
           <a:p xmlns:a="http://schemas.openxmlformats.org/drawingml/2006/main">
             <a:pPr algn="ctr">
+              <a:buNone/>
               <a:defRPr sz="1950" b="1">
                 <a:solidFill>
                   <a:srgbClr val="18354E"/>
@@ -17090,6 +17277,7 @@
           <a:lstStyle xmlns:a="http://schemas.openxmlformats.org/drawingml/2006/main"/>
           <a:p xmlns:a="http://schemas.openxmlformats.org/drawingml/2006/main">
             <a:pPr algn="l">
+              <a:buNone/>
               <a:defRPr sz="1875" b="1">
                 <a:solidFill>
                   <a:srgbClr val="263746"/>
@@ -17143,6 +17331,7 @@
           <a:lstStyle xmlns:a="http://schemas.openxmlformats.org/drawingml/2006/main"/>
           <a:p xmlns:a="http://schemas.openxmlformats.org/drawingml/2006/main">
             <a:pPr algn="ctr">
+              <a:buNone/>
               <a:defRPr sz="1950" b="1">
                 <a:solidFill>
                   <a:srgbClr val="C8161E"/>
@@ -17196,6 +17385,7 @@
           <a:lstStyle xmlns:a="http://schemas.openxmlformats.org/drawingml/2006/main"/>
           <a:p xmlns:a="http://schemas.openxmlformats.org/drawingml/2006/main">
             <a:pPr algn="l">
+              <a:buNone/>
               <a:defRPr sz="1875" b="1">
                 <a:solidFill>
                   <a:srgbClr val="263746"/>
@@ -17249,6 +17439,7 @@
           <a:lstStyle xmlns:a="http://schemas.openxmlformats.org/drawingml/2006/main"/>
           <a:p xmlns:a="http://schemas.openxmlformats.org/drawingml/2006/main">
             <a:pPr algn="ctr">
+              <a:buNone/>
               <a:defRPr sz="1950" b="1">
                 <a:solidFill>
                   <a:srgbClr val="C8161E"/>
@@ -17302,6 +17493,7 @@
           <a:lstStyle xmlns:a="http://schemas.openxmlformats.org/drawingml/2006/main"/>
           <a:p xmlns:a="http://schemas.openxmlformats.org/drawingml/2006/main">
             <a:pPr algn="l">
+              <a:buNone/>
               <a:defRPr sz="1875" b="1">
                 <a:solidFill>
                   <a:srgbClr val="263746"/>
@@ -17357,6 +17549,7 @@
           <a:lstStyle xmlns:a="http://schemas.openxmlformats.org/drawingml/2006/main"/>
           <a:p xmlns:a="http://schemas.openxmlformats.org/drawingml/2006/main">
             <a:pPr algn="ctr">
+              <a:buNone/>
               <a:defRPr sz="1650" b="1">
                 <a:solidFill>
                   <a:srgbClr val="C8161E"/>
@@ -17519,6 +17712,7 @@
           <a:lstStyle xmlns:a="http://schemas.openxmlformats.org/drawingml/2006/main"/>
           <a:p xmlns:a="http://schemas.openxmlformats.org/drawingml/2006/main">
             <a:pPr algn="ctr">
+              <a:buNone/>
               <a:defRPr sz="1500" b="1">
                 <a:solidFill>
                   <a:srgbClr val="C8161E"/>
@@ -17587,7 +17781,9 @@
           <a:bodyPr xmlns:a="http://schemas.openxmlformats.org/drawingml/2006/main" lIns="76200" tIns="0" rIns="76200" bIns="0" anchor="ctr"/>
           <a:lstStyle xmlns:a="http://schemas.openxmlformats.org/drawingml/2006/main"/>
           <a:p xmlns:a="http://schemas.openxmlformats.org/drawingml/2006/main">
-            <a:pPr algn="l"/>
+            <a:pPr algn="l">
+              <a:buNone/>
+            </a:pPr>
             <a:r>
               <a:rPr sz="2250" b="1">
                 <a:solidFill>
@@ -17664,6 +17860,7 @@
           <a:lstStyle xmlns:a="http://schemas.openxmlformats.org/drawingml/2006/main"/>
           <a:p xmlns:a="http://schemas.openxmlformats.org/drawingml/2006/main">
             <a:pPr algn="l">
+              <a:buNone/>
               <a:defRPr sz="1650" b="1">
                 <a:solidFill>
                   <a:srgbClr val="C8161E"/>
@@ -17717,6 +17914,7 @@
           <a:lstStyle xmlns:a="http://schemas.openxmlformats.org/drawingml/2006/main"/>
           <a:p xmlns:a="http://schemas.openxmlformats.org/drawingml/2006/main">
             <a:pPr algn="ctr">
+              <a:buNone/>
               <a:defRPr sz="2250" b="1">
                 <a:solidFill>
                   <a:srgbClr val="18354E"/>
@@ -17772,6 +17970,7 @@
           <a:lstStyle xmlns:a="http://schemas.openxmlformats.org/drawingml/2006/main"/>
           <a:p xmlns:a="http://schemas.openxmlformats.org/drawingml/2006/main">
             <a:pPr algn="l">
+              <a:buNone/>
               <a:defRPr sz="2025" b="1">
                 <a:solidFill>
                   <a:srgbClr val="263746"/>
@@ -17825,6 +18024,7 @@
           <a:lstStyle xmlns:a="http://schemas.openxmlformats.org/drawingml/2006/main"/>
           <a:p xmlns:a="http://schemas.openxmlformats.org/drawingml/2006/main">
             <a:pPr algn="ctr">
+              <a:buNone/>
               <a:defRPr sz="2250" b="1">
                 <a:solidFill>
                   <a:srgbClr val="18354E"/>
@@ -17880,6 +18080,7 @@
           <a:lstStyle xmlns:a="http://schemas.openxmlformats.org/drawingml/2006/main"/>
           <a:p xmlns:a="http://schemas.openxmlformats.org/drawingml/2006/main">
             <a:pPr algn="l">
+              <a:buNone/>
               <a:defRPr sz="2025" b="1">
                 <a:solidFill>
                   <a:srgbClr val="263746"/>
@@ -17933,6 +18134,7 @@
           <a:lstStyle xmlns:a="http://schemas.openxmlformats.org/drawingml/2006/main"/>
           <a:p xmlns:a="http://schemas.openxmlformats.org/drawingml/2006/main">
             <a:pPr algn="ctr">
+              <a:buNone/>
               <a:defRPr sz="2250" b="1">
                 <a:solidFill>
                   <a:srgbClr val="C8161E"/>
@@ -17988,6 +18190,7 @@
           <a:lstStyle xmlns:a="http://schemas.openxmlformats.org/drawingml/2006/main"/>
           <a:p xmlns:a="http://schemas.openxmlformats.org/drawingml/2006/main">
             <a:pPr algn="l">
+              <a:buNone/>
               <a:defRPr sz="2025" b="1">
                 <a:solidFill>
                   <a:srgbClr val="263746"/>
@@ -18041,6 +18244,7 @@
           <a:lstStyle xmlns:a="http://schemas.openxmlformats.org/drawingml/2006/main"/>
           <a:p xmlns:a="http://schemas.openxmlformats.org/drawingml/2006/main">
             <a:pPr algn="ctr">
+              <a:buNone/>
               <a:defRPr sz="1800" b="1">
                 <a:solidFill>
                   <a:srgbClr val="C8161E"/>
@@ -18106,10 +18310,15 @@
           </a:xfrm>
         </p:spPr>
         <p:txBody>
-          <a:bodyPr xmlns:a="http://schemas.openxmlformats.org/drawingml/2006/main" lIns="76200" tIns="0" rIns="76200" bIns="0" anchor="ctr"/>
-          <a:lstStyle xmlns:a="http://schemas.openxmlformats.org/drawingml/2006/main"/>
-          <a:p xmlns:a="http://schemas.openxmlformats.org/drawingml/2006/main">
-            <a:pPr algn="l"/>
+          <a:bodyPr xmlns:a="http://schemas.openxmlformats.org/drawingml/2006/main" lIns="76200" tIns="38100" rIns="76200" bIns="38100" anchor="ctr"/>
+          <a:lstStyle xmlns:a="http://schemas.openxmlformats.org/drawingml/2006/main"/>
+          <a:p xmlns:a="http://schemas.openxmlformats.org/drawingml/2006/main">
+            <a:pPr algn="l">
+              <a:lnSpc>
+                <a:spcPct val="112000"/>
+              </a:lnSpc>
+              <a:buNone/>
+            </a:pPr>
             <a:r>
               <a:rPr sz="2250" b="1">
                 <a:solidFill>
@@ -18119,7 +18328,7 @@
                 <a:ea typeface="Microsoft YaHei"/>
                 <a:cs typeface="Microsoft YaHei"/>
               </a:rPr>
-              <a:t>课后继续推进，第 3 课带着边界开始检索</a:t>
+              <a:t>本讲知识点总结</a:t>
             </a:r>
             <a:endParaRPr/>
           </a:p>
@@ -18155,78 +18364,88 @@
       </p:sp>
       <p:sp>
         <p:nvSpPr>
-          <p:cNvPr id="6" name="p29-t-0">
-            <a:extLst xmlns:a="http://schemas.openxmlformats.org/drawingml/2006/main">
-              <a:ext uri="{FF2B5EF4-FFF2-40B4-BE49-F238E27FC236}">
-                <a16:creationId xmlns:a16="http://schemas.microsoft.com/office/drawing/2014/main" id="{CB834982-0E3C-4464-AB3E-632423A72EDC}"/>
-              </a:ext>
-            </a:extLst>
-          </p:cNvPr>
-          <p:cNvSpPr>
-            <a:spLocks xmlns:a="http://schemas.openxmlformats.org/drawingml/2006/main" noGrp="1"/>
-          </p:cNvSpPr>
-          <p:nvPr/>
-        </p:nvSpPr>
-        <p:spPr>
-          <a:xfrm xmlns:a="http://schemas.openxmlformats.org/drawingml/2006/main">
-            <a:off x="666750" y="1219200"/>
-            <a:ext cx="5143500" cy="514350"/>
-          </a:xfrm>
-          <a:prstGeom xmlns:a="http://schemas.openxmlformats.org/drawingml/2006/main" prst="rect">
-            <a:avLst/>
-          </a:prstGeom>
-          <a:noFill xmlns:a="http://schemas.openxmlformats.org/drawingml/2006/main"/>
-          <a:ln xmlns:a="http://schemas.openxmlformats.org/drawingml/2006/main" w="0">
-            <a:noFill/>
-            <a:prstDash val="solid"/>
-          </a:ln>
-        </p:spPr>
-        <p:txBody>
-          <a:bodyPr xmlns:a="http://schemas.openxmlformats.org/drawingml/2006/main" lIns="76200" tIns="38100" rIns="76200" bIns="38100" anchor="ctr"/>
-          <a:lstStyle xmlns:a="http://schemas.openxmlformats.org/drawingml/2006/main"/>
-          <a:p xmlns:a="http://schemas.openxmlformats.org/drawingml/2006/main">
-            <a:pPr algn="ctr">
-              <a:defRPr sz="1650" b="1">
-                <a:solidFill>
-                  <a:srgbClr val="2F638A"/>
-                </a:solidFill>
-              </a:defRPr>
-            </a:pPr>
-            <a:r>
-              <a:rPr sz="1650" b="1">
-                <a:solidFill>
-                  <a:srgbClr val="2F638A"/>
-                </a:solidFill>
-                <a:latin typeface="Microsoft YaHei"/>
-                <a:ea typeface="Microsoft YaHei"/>
-                <a:cs typeface="Microsoft YaHei"/>
-              </a:rPr>
-              <a:t>必读｜约 15 分钟</a:t>
-            </a:r>
-          </a:p>
-        </p:txBody>
-      </p:sp>
-      <p:sp>
-        <p:nvSpPr>
-          <p:cNvPr id="7" name="p29-b-0">
-            <a:extLst xmlns:a="http://schemas.openxmlformats.org/drawingml/2006/main">
-              <a:ext uri="{FF2B5EF4-FFF2-40B4-BE49-F238E27FC236}">
-                <a16:creationId xmlns:a16="http://schemas.microsoft.com/office/drawing/2014/main" id="{49F23FBB-F6B7-492D-ABD7-96FE6F834431}"/>
-              </a:ext>
-            </a:extLst>
-          </p:cNvPr>
-          <p:cNvSpPr>
-            <a:spLocks xmlns:a="http://schemas.openxmlformats.org/drawingml/2006/main" noGrp="1"/>
-          </p:cNvSpPr>
-          <p:nvPr/>
-        </p:nvSpPr>
-        <p:spPr>
-          <a:xfrm xmlns:a="http://schemas.openxmlformats.org/drawingml/2006/main">
-            <a:off x="666750" y="1809750"/>
-            <a:ext cx="5143500" cy="1009650"/>
-          </a:xfrm>
-          <a:prstGeom xmlns:a="http://schemas.openxmlformats.org/drawingml/2006/main" prst="rect">
-            <a:avLst/>
+          <p:cNvPr id="6" name="summary-02-number-0">
+            <a:extLst xmlns:a="http://schemas.openxmlformats.org/drawingml/2006/main">
+              <a:ext uri="{FF2B5EF4-FFF2-40B4-BE49-F238E27FC236}">
+                <a16:creationId xmlns:a16="http://schemas.microsoft.com/office/drawing/2014/main" id="{B4150BC2-3168-4098-A488-42087F1625DD}"/>
+              </a:ext>
+            </a:extLst>
+          </p:cNvPr>
+          <p:cNvSpPr>
+            <a:spLocks xmlns:a="http://schemas.openxmlformats.org/drawingml/2006/main" noGrp="1"/>
+          </p:cNvSpPr>
+          <p:nvPr/>
+        </p:nvSpPr>
+        <p:spPr>
+          <a:xfrm xmlns:a="http://schemas.openxmlformats.org/drawingml/2006/main">
+            <a:off x="457200" y="1219200"/>
+            <a:ext cx="476250" cy="476250"/>
+          </a:xfrm>
+          <a:prstGeom xmlns:a="http://schemas.openxmlformats.org/drawingml/2006/main" prst="roundRect">
+            <a:avLst>
+              <a:gd name="adj" fmla="val 16000"/>
+            </a:avLst>
+          </a:prstGeom>
+          <a:solidFill xmlns:a="http://schemas.openxmlformats.org/drawingml/2006/main">
+            <a:srgbClr val="18354E"/>
+          </a:solidFill>
+          <a:ln xmlns:a="http://schemas.openxmlformats.org/drawingml/2006/main" w="0">
+            <a:noFill/>
+            <a:prstDash val="solid"/>
+          </a:ln>
+        </p:spPr>
+        <p:txBody>
+          <a:bodyPr xmlns:a="http://schemas.openxmlformats.org/drawingml/2006/main" lIns="76200" tIns="38100" rIns="76200" bIns="38100" anchor="ctr"/>
+          <a:lstStyle xmlns:a="http://schemas.openxmlformats.org/drawingml/2006/main"/>
+          <a:p xmlns:a="http://schemas.openxmlformats.org/drawingml/2006/main">
+            <a:pPr algn="ctr">
+              <a:lnSpc>
+                <a:spcPct val="112000"/>
+              </a:lnSpc>
+              <a:buNone/>
+              <a:defRPr sz="1500" b="1">
+                <a:solidFill>
+                  <a:srgbClr val="FFFFFF"/>
+                </a:solidFill>
+              </a:defRPr>
+            </a:pPr>
+            <a:r>
+              <a:rPr sz="1500" b="1">
+                <a:solidFill>
+                  <a:srgbClr val="FFFFFF"/>
+                </a:solidFill>
+                <a:latin typeface="Arial"/>
+                <a:ea typeface="Arial"/>
+                <a:cs typeface="Arial"/>
+              </a:rPr>
+              <a:t>1</a:t>
+            </a:r>
+          </a:p>
+        </p:txBody>
+      </p:sp>
+      <p:sp>
+        <p:nvSpPr>
+          <p:cNvPr id="7" name="summary-02-heading-0">
+            <a:extLst xmlns:a="http://schemas.openxmlformats.org/drawingml/2006/main">
+              <a:ext uri="{FF2B5EF4-FFF2-40B4-BE49-F238E27FC236}">
+                <a16:creationId xmlns:a16="http://schemas.microsoft.com/office/drawing/2014/main" id="{64B330D0-0EAB-4FC2-8E03-F41E05387E1C}"/>
+              </a:ext>
+            </a:extLst>
+          </p:cNvPr>
+          <p:cNvSpPr>
+            <a:spLocks xmlns:a="http://schemas.openxmlformats.org/drawingml/2006/main" noGrp="1"/>
+          </p:cNvSpPr>
+          <p:nvPr/>
+        </p:nvSpPr>
+        <p:spPr>
+          <a:xfrm xmlns:a="http://schemas.openxmlformats.org/drawingml/2006/main">
+            <a:off x="1028700" y="1162050"/>
+            <a:ext cx="2152650" cy="590550"/>
+          </a:xfrm>
+          <a:prstGeom xmlns:a="http://schemas.openxmlformats.org/drawingml/2006/main" prst="roundRect">
+            <a:avLst>
+              <a:gd name="adj" fmla="val 12903"/>
+            </a:avLst>
           </a:prstGeom>
           <a:solidFill xmlns:a="http://schemas.openxmlformats.org/drawingml/2006/main">
             <a:srgbClr val="E8F0F6"/>
@@ -18242,9 +18461,72 @@
           <a:p xmlns:a="http://schemas.openxmlformats.org/drawingml/2006/main">
             <a:pPr algn="ctr">
               <a:lnSpc>
-                <a:spcPct val="130000"/>
+                <a:spcPct val="112000"/>
               </a:lnSpc>
               <a:buNone/>
+              <a:defRPr sz="1725" b="1">
+                <a:solidFill>
+                  <a:srgbClr val="18354E"/>
+                </a:solidFill>
+              </a:defRPr>
+            </a:pPr>
+            <a:r>
+              <a:rPr sz="1725" b="1">
+                <a:solidFill>
+                  <a:srgbClr val="18354E"/>
+                </a:solidFill>
+                <a:latin typeface="Microsoft YaHei"/>
+                <a:ea typeface="Microsoft YaHei"/>
+                <a:cs typeface="Microsoft YaHei"/>
+              </a:rPr>
+              <a:t>伦理底线</a:t>
+            </a:r>
+          </a:p>
+        </p:txBody>
+      </p:sp>
+      <p:sp>
+        <p:nvSpPr>
+          <p:cNvPr id="8" name="summary-02-detail-0">
+            <a:extLst xmlns:a="http://schemas.openxmlformats.org/drawingml/2006/main">
+              <a:ext uri="{FF2B5EF4-FFF2-40B4-BE49-F238E27FC236}">
+                <a16:creationId xmlns:a16="http://schemas.microsoft.com/office/drawing/2014/main" id="{F624E7B9-3BAE-4571-867C-FB3F55BDAEC9}"/>
+              </a:ext>
+            </a:extLst>
+          </p:cNvPr>
+          <p:cNvSpPr>
+            <a:spLocks xmlns:a="http://schemas.openxmlformats.org/drawingml/2006/main" noGrp="1"/>
+          </p:cNvSpPr>
+          <p:nvPr/>
+        </p:nvSpPr>
+        <p:spPr>
+          <a:xfrm xmlns:a="http://schemas.openxmlformats.org/drawingml/2006/main">
+            <a:off x="457200" y="2095500"/>
+            <a:ext cx="2724150" cy="1676400"/>
+          </a:xfrm>
+          <a:prstGeom xmlns:a="http://schemas.openxmlformats.org/drawingml/2006/main" prst="roundRect">
+            <a:avLst>
+              <a:gd name="adj" fmla="val 4545"/>
+            </a:avLst>
+          </a:prstGeom>
+          <a:solidFill xmlns:a="http://schemas.openxmlformats.org/drawingml/2006/main">
+            <a:srgbClr val="FFFFFF"/>
+          </a:solidFill>
+          <a:ln xmlns:a="http://schemas.openxmlformats.org/drawingml/2006/main" w="9525">
+            <a:solidFill>
+              <a:srgbClr val="D6DDE2"/>
+            </a:solidFill>
+            <a:prstDash val="solid"/>
+          </a:ln>
+        </p:spPr>
+        <p:txBody>
+          <a:bodyPr xmlns:a="http://schemas.openxmlformats.org/drawingml/2006/main" lIns="76200" tIns="38100" rIns="76200" bIns="38100" anchor="ctr"/>
+          <a:lstStyle xmlns:a="http://schemas.openxmlformats.org/drawingml/2006/main"/>
+          <a:p xmlns:a="http://schemas.openxmlformats.org/drawingml/2006/main">
+            <a:pPr algn="ctr">
+              <a:lnSpc>
+                <a:spcPct val="116000"/>
+              </a:lnSpc>
+              <a:buNone/>
               <a:defRPr sz="1500" b="1">
                 <a:solidFill>
                   <a:srgbClr val="263746"/>
@@ -18260,17 +18542,178 @@
                 <a:ea typeface="Microsoft YaHei"/>
                 <a:cs typeface="Microsoft YaHei"/>
               </a:rPr>
-              <a:t>中科院《诚信提醒》</a:t>
-            </a:r>
-          </a:p>
+              <a:t>真实性、隐私、署名与可追溯性不能被效率冲动突破</a:t>
+            </a:r>
+          </a:p>
+        </p:txBody>
+      </p:sp>
+      <p:sp>
+        <p:nvSpPr>
+          <p:cNvPr id="9" name="summary-02-number-1">
+            <a:extLst xmlns:a="http://schemas.openxmlformats.org/drawingml/2006/main">
+              <a:ext uri="{FF2B5EF4-FFF2-40B4-BE49-F238E27FC236}">
+                <a16:creationId xmlns:a16="http://schemas.microsoft.com/office/drawing/2014/main" id="{74390C0F-CB73-41CF-8CAE-5419076B39EB}"/>
+              </a:ext>
+            </a:extLst>
+          </p:cNvPr>
+          <p:cNvSpPr>
+            <a:spLocks xmlns:a="http://schemas.openxmlformats.org/drawingml/2006/main" noGrp="1"/>
+          </p:cNvSpPr>
+          <p:nvPr/>
+        </p:nvSpPr>
+        <p:spPr>
+          <a:xfrm xmlns:a="http://schemas.openxmlformats.org/drawingml/2006/main">
+            <a:off x="3371850" y="1219200"/>
+            <a:ext cx="476250" cy="476250"/>
+          </a:xfrm>
+          <a:prstGeom xmlns:a="http://schemas.openxmlformats.org/drawingml/2006/main" prst="roundRect">
+            <a:avLst>
+              <a:gd name="adj" fmla="val 16000"/>
+            </a:avLst>
+          </a:prstGeom>
+          <a:solidFill xmlns:a="http://schemas.openxmlformats.org/drawingml/2006/main">
+            <a:srgbClr val="28745A"/>
+          </a:solidFill>
+          <a:ln xmlns:a="http://schemas.openxmlformats.org/drawingml/2006/main" w="0">
+            <a:noFill/>
+            <a:prstDash val="solid"/>
+          </a:ln>
+        </p:spPr>
+        <p:txBody>
+          <a:bodyPr xmlns:a="http://schemas.openxmlformats.org/drawingml/2006/main" lIns="76200" tIns="38100" rIns="76200" bIns="38100" anchor="ctr"/>
+          <a:lstStyle xmlns:a="http://schemas.openxmlformats.org/drawingml/2006/main"/>
           <a:p xmlns:a="http://schemas.openxmlformats.org/drawingml/2006/main">
             <a:pPr algn="ctr">
               <a:lnSpc>
-                <a:spcPct val="130000"/>
+                <a:spcPct val="112000"/>
               </a:lnSpc>
               <a:buNone/>
               <a:defRPr sz="1500" b="1">
                 <a:solidFill>
+                  <a:srgbClr val="FFFFFF"/>
+                </a:solidFill>
+              </a:defRPr>
+            </a:pPr>
+            <a:r>
+              <a:rPr sz="1500" b="1">
+                <a:solidFill>
+                  <a:srgbClr val="FFFFFF"/>
+                </a:solidFill>
+                <a:latin typeface="Arial"/>
+                <a:ea typeface="Arial"/>
+                <a:cs typeface="Arial"/>
+              </a:rPr>
+              <a:t>2</a:t>
+            </a:r>
+          </a:p>
+        </p:txBody>
+      </p:sp>
+      <p:sp>
+        <p:nvSpPr>
+          <p:cNvPr id="10" name="summary-02-heading-1">
+            <a:extLst xmlns:a="http://schemas.openxmlformats.org/drawingml/2006/main">
+              <a:ext uri="{FF2B5EF4-FFF2-40B4-BE49-F238E27FC236}">
+                <a16:creationId xmlns:a16="http://schemas.microsoft.com/office/drawing/2014/main" id="{8E322B2E-B769-4B90-9297-487A71F57071}"/>
+              </a:ext>
+            </a:extLst>
+          </p:cNvPr>
+          <p:cNvSpPr>
+            <a:spLocks xmlns:a="http://schemas.openxmlformats.org/drawingml/2006/main" noGrp="1"/>
+          </p:cNvSpPr>
+          <p:nvPr/>
+        </p:nvSpPr>
+        <p:spPr>
+          <a:xfrm xmlns:a="http://schemas.openxmlformats.org/drawingml/2006/main">
+            <a:off x="3943350" y="1162050"/>
+            <a:ext cx="2152650" cy="590550"/>
+          </a:xfrm>
+          <a:prstGeom xmlns:a="http://schemas.openxmlformats.org/drawingml/2006/main" prst="roundRect">
+            <a:avLst>
+              <a:gd name="adj" fmla="val 12903"/>
+            </a:avLst>
+          </a:prstGeom>
+          <a:solidFill xmlns:a="http://schemas.openxmlformats.org/drawingml/2006/main">
+            <a:srgbClr val="E7F2ED"/>
+          </a:solidFill>
+          <a:ln xmlns:a="http://schemas.openxmlformats.org/drawingml/2006/main" w="0">
+            <a:noFill/>
+            <a:prstDash val="solid"/>
+          </a:ln>
+        </p:spPr>
+        <p:txBody>
+          <a:bodyPr xmlns:a="http://schemas.openxmlformats.org/drawingml/2006/main" lIns="76200" tIns="38100" rIns="76200" bIns="38100" anchor="ctr"/>
+          <a:lstStyle xmlns:a="http://schemas.openxmlformats.org/drawingml/2006/main"/>
+          <a:p xmlns:a="http://schemas.openxmlformats.org/drawingml/2006/main">
+            <a:pPr algn="ctr">
+              <a:lnSpc>
+                <a:spcPct val="112000"/>
+              </a:lnSpc>
+              <a:buNone/>
+              <a:defRPr sz="1725" b="1">
+                <a:solidFill>
+                  <a:srgbClr val="28745A"/>
+                </a:solidFill>
+              </a:defRPr>
+            </a:pPr>
+            <a:r>
+              <a:rPr sz="1725" b="1">
+                <a:solidFill>
+                  <a:srgbClr val="28745A"/>
+                </a:solidFill>
+                <a:latin typeface="Microsoft YaHei"/>
+                <a:ea typeface="Microsoft YaHei"/>
+                <a:cs typeface="Microsoft YaHei"/>
+              </a:rPr>
+              <a:t>权限矩阵</a:t>
+            </a:r>
+          </a:p>
+        </p:txBody>
+      </p:sp>
+      <p:sp>
+        <p:nvSpPr>
+          <p:cNvPr id="11" name="summary-02-detail-1">
+            <a:extLst xmlns:a="http://schemas.openxmlformats.org/drawingml/2006/main">
+              <a:ext uri="{FF2B5EF4-FFF2-40B4-BE49-F238E27FC236}">
+                <a16:creationId xmlns:a16="http://schemas.microsoft.com/office/drawing/2014/main" id="{7C4A9418-2D16-4D66-A948-0BCD1D5C68CF}"/>
+              </a:ext>
+            </a:extLst>
+          </p:cNvPr>
+          <p:cNvSpPr>
+            <a:spLocks xmlns:a="http://schemas.openxmlformats.org/drawingml/2006/main" noGrp="1"/>
+          </p:cNvSpPr>
+          <p:nvPr/>
+        </p:nvSpPr>
+        <p:spPr>
+          <a:xfrm xmlns:a="http://schemas.openxmlformats.org/drawingml/2006/main">
+            <a:off x="3371850" y="2095500"/>
+            <a:ext cx="2724150" cy="1676400"/>
+          </a:xfrm>
+          <a:prstGeom xmlns:a="http://schemas.openxmlformats.org/drawingml/2006/main" prst="roundRect">
+            <a:avLst>
+              <a:gd name="adj" fmla="val 4545"/>
+            </a:avLst>
+          </a:prstGeom>
+          <a:solidFill xmlns:a="http://schemas.openxmlformats.org/drawingml/2006/main">
+            <a:srgbClr val="FFFFFF"/>
+          </a:solidFill>
+          <a:ln xmlns:a="http://schemas.openxmlformats.org/drawingml/2006/main" w="9525">
+            <a:solidFill>
+              <a:srgbClr val="D6DDE2"/>
+            </a:solidFill>
+            <a:prstDash val="solid"/>
+          </a:ln>
+        </p:spPr>
+        <p:txBody>
+          <a:bodyPr xmlns:a="http://schemas.openxmlformats.org/drawingml/2006/main" lIns="76200" tIns="38100" rIns="76200" bIns="38100" anchor="ctr"/>
+          <a:lstStyle xmlns:a="http://schemas.openxmlformats.org/drawingml/2006/main"/>
+          <a:p xmlns:a="http://schemas.openxmlformats.org/drawingml/2006/main">
+            <a:pPr algn="ctr">
+              <a:lnSpc>
+                <a:spcPct val="116000"/>
+              </a:lnSpc>
+              <a:buNone/>
+              <a:defRPr sz="1500" b="1">
+                <a:solidFill>
                   <a:srgbClr val="263746"/>
                 </a:solidFill>
               </a:defRPr>
@@ -18284,85 +18727,95 @@
                 <a:ea typeface="Microsoft YaHei"/>
                 <a:cs typeface="Microsoft YaHei"/>
               </a:rPr>
-              <a:t>记录一条与本人项目相关的底线</a:t>
-            </a:r>
-          </a:p>
-        </p:txBody>
-      </p:sp>
-      <p:sp>
-        <p:nvSpPr>
-          <p:cNvPr id="8" name="p29-t-1">
-            <a:extLst xmlns:a="http://schemas.openxmlformats.org/drawingml/2006/main">
-              <a:ext uri="{FF2B5EF4-FFF2-40B4-BE49-F238E27FC236}">
-                <a16:creationId xmlns:a16="http://schemas.microsoft.com/office/drawing/2014/main" id="{8F1B5EFA-17E4-4A2E-9AAC-2513A1C884DD}"/>
-              </a:ext>
-            </a:extLst>
-          </p:cNvPr>
-          <p:cNvSpPr>
-            <a:spLocks xmlns:a="http://schemas.openxmlformats.org/drawingml/2006/main" noGrp="1"/>
-          </p:cNvSpPr>
-          <p:nvPr/>
-        </p:nvSpPr>
-        <p:spPr>
-          <a:xfrm xmlns:a="http://schemas.openxmlformats.org/drawingml/2006/main">
-            <a:off x="6267450" y="1219200"/>
-            <a:ext cx="5143500" cy="514350"/>
-          </a:xfrm>
-          <a:prstGeom xmlns:a="http://schemas.openxmlformats.org/drawingml/2006/main" prst="rect">
-            <a:avLst/>
-          </a:prstGeom>
-          <a:noFill xmlns:a="http://schemas.openxmlformats.org/drawingml/2006/main"/>
-          <a:ln xmlns:a="http://schemas.openxmlformats.org/drawingml/2006/main" w="0">
-            <a:noFill/>
-            <a:prstDash val="solid"/>
-          </a:ln>
-        </p:spPr>
-        <p:txBody>
-          <a:bodyPr xmlns:a="http://schemas.openxmlformats.org/drawingml/2006/main" lIns="76200" tIns="38100" rIns="76200" bIns="38100" anchor="ctr"/>
-          <a:lstStyle xmlns:a="http://schemas.openxmlformats.org/drawingml/2006/main"/>
-          <a:p xmlns:a="http://schemas.openxmlformats.org/drawingml/2006/main">
-            <a:pPr algn="ctr">
-              <a:defRPr sz="1650" b="1">
-                <a:solidFill>
-                  <a:srgbClr val="C8161E"/>
-                </a:solidFill>
-              </a:defRPr>
-            </a:pPr>
-            <a:r>
-              <a:rPr sz="1650" b="1">
-                <a:solidFill>
-                  <a:srgbClr val="C8161E"/>
-                </a:solidFill>
-                <a:latin typeface="Microsoft YaHei"/>
-                <a:ea typeface="Microsoft YaHei"/>
-                <a:cs typeface="Microsoft YaHei"/>
-              </a:rPr>
-              <a:t>项目更新｜约 20 分钟</a:t>
-            </a:r>
-          </a:p>
-        </p:txBody>
-      </p:sp>
-      <p:sp>
-        <p:nvSpPr>
-          <p:cNvPr id="9" name="p29-b-1">
-            <a:extLst xmlns:a="http://schemas.openxmlformats.org/drawingml/2006/main">
-              <a:ext uri="{FF2B5EF4-FFF2-40B4-BE49-F238E27FC236}">
-                <a16:creationId xmlns:a16="http://schemas.microsoft.com/office/drawing/2014/main" id="{AD439CFE-5B30-4765-800D-849EB0859598}"/>
-              </a:ext>
-            </a:extLst>
-          </p:cNvPr>
-          <p:cNvSpPr>
-            <a:spLocks xmlns:a="http://schemas.openxmlformats.org/drawingml/2006/main" noGrp="1"/>
-          </p:cNvSpPr>
-          <p:nvPr/>
-        </p:nvSpPr>
-        <p:spPr>
-          <a:xfrm xmlns:a="http://schemas.openxmlformats.org/drawingml/2006/main">
-            <a:off x="6267450" y="1809750"/>
-            <a:ext cx="5143500" cy="1009650"/>
-          </a:xfrm>
-          <a:prstGeom xmlns:a="http://schemas.openxmlformats.org/drawingml/2006/main" prst="rect">
-            <a:avLst/>
+              <a:t>只读、草稿写入、执行、正式写回与外部动作分层授权</a:t>
+            </a:r>
+          </a:p>
+        </p:txBody>
+      </p:sp>
+      <p:sp>
+        <p:nvSpPr>
+          <p:cNvPr id="12" name="summary-02-number-2">
+            <a:extLst xmlns:a="http://schemas.openxmlformats.org/drawingml/2006/main">
+              <a:ext uri="{FF2B5EF4-FFF2-40B4-BE49-F238E27FC236}">
+                <a16:creationId xmlns:a16="http://schemas.microsoft.com/office/drawing/2014/main" id="{158FE018-3D2C-4E55-B2FD-A8137C8CF8ED}"/>
+              </a:ext>
+            </a:extLst>
+          </p:cNvPr>
+          <p:cNvSpPr>
+            <a:spLocks xmlns:a="http://schemas.openxmlformats.org/drawingml/2006/main" noGrp="1"/>
+          </p:cNvSpPr>
+          <p:nvPr/>
+        </p:nvSpPr>
+        <p:spPr>
+          <a:xfrm xmlns:a="http://schemas.openxmlformats.org/drawingml/2006/main">
+            <a:off x="6286500" y="1219200"/>
+            <a:ext cx="476250" cy="476250"/>
+          </a:xfrm>
+          <a:prstGeom xmlns:a="http://schemas.openxmlformats.org/drawingml/2006/main" prst="roundRect">
+            <a:avLst>
+              <a:gd name="adj" fmla="val 16000"/>
+            </a:avLst>
+          </a:prstGeom>
+          <a:solidFill xmlns:a="http://schemas.openxmlformats.org/drawingml/2006/main">
+            <a:srgbClr val="C8161E"/>
+          </a:solidFill>
+          <a:ln xmlns:a="http://schemas.openxmlformats.org/drawingml/2006/main" w="0">
+            <a:noFill/>
+            <a:prstDash val="solid"/>
+          </a:ln>
+        </p:spPr>
+        <p:txBody>
+          <a:bodyPr xmlns:a="http://schemas.openxmlformats.org/drawingml/2006/main" lIns="76200" tIns="38100" rIns="76200" bIns="38100" anchor="ctr"/>
+          <a:lstStyle xmlns:a="http://schemas.openxmlformats.org/drawingml/2006/main"/>
+          <a:p xmlns:a="http://schemas.openxmlformats.org/drawingml/2006/main">
+            <a:pPr algn="ctr">
+              <a:lnSpc>
+                <a:spcPct val="112000"/>
+              </a:lnSpc>
+              <a:buNone/>
+              <a:defRPr sz="1500" b="1">
+                <a:solidFill>
+                  <a:srgbClr val="FFFFFF"/>
+                </a:solidFill>
+              </a:defRPr>
+            </a:pPr>
+            <a:r>
+              <a:rPr sz="1500" b="1">
+                <a:solidFill>
+                  <a:srgbClr val="FFFFFF"/>
+                </a:solidFill>
+                <a:latin typeface="Arial"/>
+                <a:ea typeface="Arial"/>
+                <a:cs typeface="Arial"/>
+              </a:rPr>
+              <a:t>3</a:t>
+            </a:r>
+          </a:p>
+        </p:txBody>
+      </p:sp>
+      <p:sp>
+        <p:nvSpPr>
+          <p:cNvPr id="13" name="summary-02-heading-2">
+            <a:extLst xmlns:a="http://schemas.openxmlformats.org/drawingml/2006/main">
+              <a:ext uri="{FF2B5EF4-FFF2-40B4-BE49-F238E27FC236}">
+                <a16:creationId xmlns:a16="http://schemas.microsoft.com/office/drawing/2014/main" id="{AD78FDF3-6A21-4308-AC65-405A7C794AD2}"/>
+              </a:ext>
+            </a:extLst>
+          </p:cNvPr>
+          <p:cNvSpPr>
+            <a:spLocks xmlns:a="http://schemas.openxmlformats.org/drawingml/2006/main" noGrp="1"/>
+          </p:cNvSpPr>
+          <p:nvPr/>
+        </p:nvSpPr>
+        <p:spPr>
+          <a:xfrm xmlns:a="http://schemas.openxmlformats.org/drawingml/2006/main">
+            <a:off x="6858000" y="1162050"/>
+            <a:ext cx="2152650" cy="590550"/>
+          </a:xfrm>
+          <a:prstGeom xmlns:a="http://schemas.openxmlformats.org/drawingml/2006/main" prst="roundRect">
+            <a:avLst>
+              <a:gd name="adj" fmla="val 12903"/>
+            </a:avLst>
           </a:prstGeom>
           <a:solidFill xmlns:a="http://schemas.openxmlformats.org/drawingml/2006/main">
             <a:srgbClr val="F8E9EA"/>
@@ -18378,9 +18831,72 @@
           <a:p xmlns:a="http://schemas.openxmlformats.org/drawingml/2006/main">
             <a:pPr algn="ctr">
               <a:lnSpc>
-                <a:spcPct val="130000"/>
+                <a:spcPct val="112000"/>
               </a:lnSpc>
               <a:buNone/>
+              <a:defRPr sz="1725" b="1">
+                <a:solidFill>
+                  <a:srgbClr val="C8161E"/>
+                </a:solidFill>
+              </a:defRPr>
+            </a:pPr>
+            <a:r>
+              <a:rPr sz="1725" b="1">
+                <a:solidFill>
+                  <a:srgbClr val="C8161E"/>
+                </a:solidFill>
+                <a:latin typeface="Microsoft YaHei"/>
+                <a:ea typeface="Microsoft YaHei"/>
+                <a:cs typeface="Microsoft YaHei"/>
+              </a:rPr>
+              <a:t>人工确认</a:t>
+            </a:r>
+          </a:p>
+        </p:txBody>
+      </p:sp>
+      <p:sp>
+        <p:nvSpPr>
+          <p:cNvPr id="14" name="summary-02-detail-2">
+            <a:extLst xmlns:a="http://schemas.openxmlformats.org/drawingml/2006/main">
+              <a:ext uri="{FF2B5EF4-FFF2-40B4-BE49-F238E27FC236}">
+                <a16:creationId xmlns:a16="http://schemas.microsoft.com/office/drawing/2014/main" id="{8CDFDB76-98D7-438F-B7F9-C92380047607}"/>
+              </a:ext>
+            </a:extLst>
+          </p:cNvPr>
+          <p:cNvSpPr>
+            <a:spLocks xmlns:a="http://schemas.openxmlformats.org/drawingml/2006/main" noGrp="1"/>
+          </p:cNvSpPr>
+          <p:nvPr/>
+        </p:nvSpPr>
+        <p:spPr>
+          <a:xfrm xmlns:a="http://schemas.openxmlformats.org/drawingml/2006/main">
+            <a:off x="6286500" y="2095500"/>
+            <a:ext cx="2724150" cy="1676400"/>
+          </a:xfrm>
+          <a:prstGeom xmlns:a="http://schemas.openxmlformats.org/drawingml/2006/main" prst="roundRect">
+            <a:avLst>
+              <a:gd name="adj" fmla="val 4545"/>
+            </a:avLst>
+          </a:prstGeom>
+          <a:solidFill xmlns:a="http://schemas.openxmlformats.org/drawingml/2006/main">
+            <a:srgbClr val="FFFFFF"/>
+          </a:solidFill>
+          <a:ln xmlns:a="http://schemas.openxmlformats.org/drawingml/2006/main" w="9525">
+            <a:solidFill>
+              <a:srgbClr val="D6DDE2"/>
+            </a:solidFill>
+            <a:prstDash val="solid"/>
+          </a:ln>
+        </p:spPr>
+        <p:txBody>
+          <a:bodyPr xmlns:a="http://schemas.openxmlformats.org/drawingml/2006/main" lIns="76200" tIns="38100" rIns="76200" bIns="38100" anchor="ctr"/>
+          <a:lstStyle xmlns:a="http://schemas.openxmlformats.org/drawingml/2006/main"/>
+          <a:p xmlns:a="http://schemas.openxmlformats.org/drawingml/2006/main">
+            <a:pPr algn="ctr">
+              <a:lnSpc>
+                <a:spcPct val="116000"/>
+              </a:lnSpc>
+              <a:buNone/>
               <a:defRPr sz="1500" b="1">
                 <a:solidFill>
                   <a:srgbClr val="263746"/>
@@ -18396,88 +18912,37 @@
                 <a:ea typeface="Microsoft YaHei"/>
                 <a:cs typeface="Microsoft YaHei"/>
               </a:rPr>
-              <a:t>权限矩阵 + 风险卡 + 四项工件追踪 + AI 使用记录</a:t>
-            </a:r>
-          </a:p>
-        </p:txBody>
-      </p:sp>
-      <p:sp>
-        <p:nvSpPr>
-          <p:cNvPr id="10" name="p29-t-2">
-            <a:extLst xmlns:a="http://schemas.openxmlformats.org/drawingml/2006/main">
-              <a:ext uri="{FF2B5EF4-FFF2-40B4-BE49-F238E27FC236}">
-                <a16:creationId xmlns:a16="http://schemas.microsoft.com/office/drawing/2014/main" id="{5DD311C0-A28B-49B9-A2E3-71F5DE9EBB23}"/>
-              </a:ext>
-            </a:extLst>
-          </p:cNvPr>
-          <p:cNvSpPr>
-            <a:spLocks xmlns:a="http://schemas.openxmlformats.org/drawingml/2006/main" noGrp="1"/>
-          </p:cNvSpPr>
-          <p:nvPr/>
-        </p:nvSpPr>
-        <p:spPr>
-          <a:xfrm xmlns:a="http://schemas.openxmlformats.org/drawingml/2006/main">
-            <a:off x="666750" y="3028950"/>
-            <a:ext cx="5143500" cy="514350"/>
-          </a:xfrm>
-          <a:prstGeom xmlns:a="http://schemas.openxmlformats.org/drawingml/2006/main" prst="rect">
-            <a:avLst/>
-          </a:prstGeom>
-          <a:noFill xmlns:a="http://schemas.openxmlformats.org/drawingml/2006/main"/>
-          <a:ln xmlns:a="http://schemas.openxmlformats.org/drawingml/2006/main" w="0">
-            <a:noFill/>
-            <a:prstDash val="solid"/>
-          </a:ln>
-        </p:spPr>
-        <p:txBody>
-          <a:bodyPr xmlns:a="http://schemas.openxmlformats.org/drawingml/2006/main" lIns="76200" tIns="38100" rIns="76200" bIns="38100" anchor="ctr"/>
-          <a:lstStyle xmlns:a="http://schemas.openxmlformats.org/drawingml/2006/main"/>
-          <a:p xmlns:a="http://schemas.openxmlformats.org/drawingml/2006/main">
-            <a:pPr algn="ctr">
-              <a:defRPr sz="1650" b="1">
-                <a:solidFill>
-                  <a:srgbClr val="28745A"/>
-                </a:solidFill>
-              </a:defRPr>
-            </a:pPr>
-            <a:r>
-              <a:rPr sz="1650" b="1">
-                <a:solidFill>
-                  <a:srgbClr val="28745A"/>
-                </a:solidFill>
-                <a:latin typeface="Microsoft YaHei"/>
-                <a:ea typeface="Microsoft YaHei"/>
-                <a:cs typeface="Microsoft YaHei"/>
-              </a:rPr>
-              <a:t>第 3 课准备｜约 10 分钟</a:t>
-            </a:r>
-          </a:p>
-        </p:txBody>
-      </p:sp>
-      <p:sp>
-        <p:nvSpPr>
-          <p:cNvPr id="11" name="p29-b-2">
-            <a:extLst xmlns:a="http://schemas.openxmlformats.org/drawingml/2006/main">
-              <a:ext uri="{FF2B5EF4-FFF2-40B4-BE49-F238E27FC236}">
-                <a16:creationId xmlns:a16="http://schemas.microsoft.com/office/drawing/2014/main" id="{879F465F-A348-4BE3-A6B9-86593F6CC70D}"/>
-              </a:ext>
-            </a:extLst>
-          </p:cNvPr>
-          <p:cNvSpPr>
-            <a:spLocks xmlns:a="http://schemas.openxmlformats.org/drawingml/2006/main" noGrp="1"/>
-          </p:cNvSpPr>
-          <p:nvPr/>
-        </p:nvSpPr>
-        <p:spPr>
-          <a:xfrm xmlns:a="http://schemas.openxmlformats.org/drawingml/2006/main">
-            <a:off x="666750" y="3619500"/>
-            <a:ext cx="5143500" cy="1009650"/>
-          </a:xfrm>
-          <a:prstGeom xmlns:a="http://schemas.openxmlformats.org/drawingml/2006/main" prst="rect">
-            <a:avLst/>
+              <a:t>越权、正式写回、外部发送与关键研究判断必须停下来确认</a:t>
+            </a:r>
+          </a:p>
+        </p:txBody>
+      </p:sp>
+      <p:sp>
+        <p:nvSpPr>
+          <p:cNvPr id="15" name="summary-02-number-3">
+            <a:extLst xmlns:a="http://schemas.openxmlformats.org/drawingml/2006/main">
+              <a:ext uri="{FF2B5EF4-FFF2-40B4-BE49-F238E27FC236}">
+                <a16:creationId xmlns:a16="http://schemas.microsoft.com/office/drawing/2014/main" id="{C16F1596-A345-442D-87FD-500CDA73F809}"/>
+              </a:ext>
+            </a:extLst>
+          </p:cNvPr>
+          <p:cNvSpPr>
+            <a:spLocks xmlns:a="http://schemas.openxmlformats.org/drawingml/2006/main" noGrp="1"/>
+          </p:cNvSpPr>
+          <p:nvPr/>
+        </p:nvSpPr>
+        <p:spPr>
+          <a:xfrm xmlns:a="http://schemas.openxmlformats.org/drawingml/2006/main">
+            <a:off x="9201150" y="1219200"/>
+            <a:ext cx="476250" cy="476250"/>
+          </a:xfrm>
+          <a:prstGeom xmlns:a="http://schemas.openxmlformats.org/drawingml/2006/main" prst="roundRect">
+            <a:avLst>
+              <a:gd name="adj" fmla="val 16000"/>
+            </a:avLst>
           </a:prstGeom>
           <a:solidFill xmlns:a="http://schemas.openxmlformats.org/drawingml/2006/main">
-            <a:srgbClr val="E7F2ED"/>
+            <a:srgbClr val="A86C12"/>
           </a:solidFill>
           <a:ln xmlns:a="http://schemas.openxmlformats.org/drawingml/2006/main" w="0">
             <a:noFill/>
@@ -18490,103 +18955,52 @@
           <a:p xmlns:a="http://schemas.openxmlformats.org/drawingml/2006/main">
             <a:pPr algn="ctr">
               <a:lnSpc>
-                <a:spcPct val="130000"/>
+                <a:spcPct val="112000"/>
               </a:lnSpc>
               <a:buNone/>
               <a:defRPr sz="1500" b="1">
                 <a:solidFill>
-                  <a:srgbClr val="263746"/>
+                  <a:srgbClr val="FFFFFF"/>
                 </a:solidFill>
               </a:defRPr>
             </a:pPr>
             <a:r>
               <a:rPr sz="1500" b="1">
                 <a:solidFill>
-                  <a:srgbClr val="263746"/>
-                </a:solidFill>
-                <a:latin typeface="Microsoft YaHei"/>
-                <a:ea typeface="Microsoft YaHei"/>
-                <a:cs typeface="Microsoft YaHei"/>
-              </a:rPr>
-              <a:t>一个公开研究问题 + 3–5 个关键词 + 一项来源 / 网络边界</a:t>
-            </a:r>
-          </a:p>
-        </p:txBody>
-      </p:sp>
-      <p:sp>
-        <p:nvSpPr>
-          <p:cNvPr id="12" name="p29-t-3">
-            <a:extLst xmlns:a="http://schemas.openxmlformats.org/drawingml/2006/main">
-              <a:ext uri="{FF2B5EF4-FFF2-40B4-BE49-F238E27FC236}">
-                <a16:creationId xmlns:a16="http://schemas.microsoft.com/office/drawing/2014/main" id="{BD825422-24D9-4B1A-8494-0E7EE3FF162B}"/>
-              </a:ext>
-            </a:extLst>
-          </p:cNvPr>
-          <p:cNvSpPr>
-            <a:spLocks xmlns:a="http://schemas.openxmlformats.org/drawingml/2006/main" noGrp="1"/>
-          </p:cNvSpPr>
-          <p:nvPr/>
-        </p:nvSpPr>
-        <p:spPr>
-          <a:xfrm xmlns:a="http://schemas.openxmlformats.org/drawingml/2006/main">
-            <a:off x="6267450" y="3028950"/>
-            <a:ext cx="5143500" cy="514350"/>
-          </a:xfrm>
-          <a:prstGeom xmlns:a="http://schemas.openxmlformats.org/drawingml/2006/main" prst="rect">
-            <a:avLst/>
-          </a:prstGeom>
-          <a:noFill xmlns:a="http://schemas.openxmlformats.org/drawingml/2006/main"/>
-          <a:ln xmlns:a="http://schemas.openxmlformats.org/drawingml/2006/main" w="0">
-            <a:noFill/>
-            <a:prstDash val="solid"/>
-          </a:ln>
-        </p:spPr>
-        <p:txBody>
-          <a:bodyPr xmlns:a="http://schemas.openxmlformats.org/drawingml/2006/main" lIns="76200" tIns="38100" rIns="76200" bIns="38100" anchor="ctr"/>
-          <a:lstStyle xmlns:a="http://schemas.openxmlformats.org/drawingml/2006/main"/>
-          <a:p xmlns:a="http://schemas.openxmlformats.org/drawingml/2006/main">
-            <a:pPr algn="ctr">
-              <a:defRPr sz="1650" b="1">
-                <a:solidFill>
-                  <a:srgbClr val="A86C12"/>
-                </a:solidFill>
-              </a:defRPr>
-            </a:pPr>
-            <a:r>
-              <a:rPr sz="1650" b="1">
-                <a:solidFill>
-                  <a:srgbClr val="A86C12"/>
-                </a:solidFill>
-                <a:latin typeface="Microsoft YaHei"/>
-                <a:ea typeface="Microsoft YaHei"/>
-                <a:cs typeface="Microsoft YaHei"/>
-              </a:rPr>
-              <a:t>任选阅读</a:t>
-            </a:r>
-          </a:p>
-        </p:txBody>
-      </p:sp>
-      <p:sp>
-        <p:nvSpPr>
-          <p:cNvPr id="13" name="p29-b-3">
-            <a:extLst xmlns:a="http://schemas.openxmlformats.org/drawingml/2006/main">
-              <a:ext uri="{FF2B5EF4-FFF2-40B4-BE49-F238E27FC236}">
-                <a16:creationId xmlns:a16="http://schemas.microsoft.com/office/drawing/2014/main" id="{1AEE394E-E563-4997-B72F-C562241B532E}"/>
-              </a:ext>
-            </a:extLst>
-          </p:cNvPr>
-          <p:cNvSpPr>
-            <a:spLocks xmlns:a="http://schemas.openxmlformats.org/drawingml/2006/main" noGrp="1"/>
-          </p:cNvSpPr>
-          <p:nvPr/>
-        </p:nvSpPr>
-        <p:spPr>
-          <a:xfrm xmlns:a="http://schemas.openxmlformats.org/drawingml/2006/main">
-            <a:off x="6267450" y="3619500"/>
-            <a:ext cx="5143500" cy="1009650"/>
-          </a:xfrm>
-          <a:prstGeom xmlns:a="http://schemas.openxmlformats.org/drawingml/2006/main" prst="rect">
-            <a:avLst/>
+                  <a:srgbClr val="FFFFFF"/>
+                </a:solidFill>
+                <a:latin typeface="Arial"/>
+                <a:ea typeface="Arial"/>
+                <a:cs typeface="Arial"/>
+              </a:rPr>
+              <a:t>4</a:t>
+            </a:r>
+          </a:p>
+        </p:txBody>
+      </p:sp>
+      <p:sp>
+        <p:nvSpPr>
+          <p:cNvPr id="16" name="summary-02-heading-3">
+            <a:extLst xmlns:a="http://schemas.openxmlformats.org/drawingml/2006/main">
+              <a:ext uri="{FF2B5EF4-FFF2-40B4-BE49-F238E27FC236}">
+                <a16:creationId xmlns:a16="http://schemas.microsoft.com/office/drawing/2014/main" id="{90861782-C0D7-4A84-8F84-B2D7DE1FAAD4}"/>
+              </a:ext>
+            </a:extLst>
+          </p:cNvPr>
+          <p:cNvSpPr>
+            <a:spLocks xmlns:a="http://schemas.openxmlformats.org/drawingml/2006/main" noGrp="1"/>
+          </p:cNvSpPr>
+          <p:nvPr/>
+        </p:nvSpPr>
+        <p:spPr>
+          <a:xfrm xmlns:a="http://schemas.openxmlformats.org/drawingml/2006/main">
+            <a:off x="9772650" y="1162050"/>
+            <a:ext cx="2152650" cy="590550"/>
+          </a:xfrm>
+          <a:prstGeom xmlns:a="http://schemas.openxmlformats.org/drawingml/2006/main" prst="roundRect">
+            <a:avLst>
+              <a:gd name="adj" fmla="val 12903"/>
+            </a:avLst>
           </a:prstGeom>
           <a:solidFill xmlns:a="http://schemas.openxmlformats.org/drawingml/2006/main">
             <a:srgbClr val="FAF0DD"/>
@@ -18602,9 +19016,72 @@
           <a:p xmlns:a="http://schemas.openxmlformats.org/drawingml/2006/main">
             <a:pPr algn="ctr">
               <a:lnSpc>
-                <a:spcPct val="130000"/>
+                <a:spcPct val="112000"/>
               </a:lnSpc>
               <a:buNone/>
+              <a:defRPr sz="1725" b="1">
+                <a:solidFill>
+                  <a:srgbClr val="A86C12"/>
+                </a:solidFill>
+              </a:defRPr>
+            </a:pPr>
+            <a:r>
+              <a:rPr sz="1725" b="1">
+                <a:solidFill>
+                  <a:srgbClr val="A86C12"/>
+                </a:solidFill>
+                <a:latin typeface="Microsoft YaHei"/>
+                <a:ea typeface="Microsoft YaHei"/>
+                <a:cs typeface="Microsoft YaHei"/>
+              </a:rPr>
+              <a:t>工件追踪</a:t>
+            </a:r>
+          </a:p>
+        </p:txBody>
+      </p:sp>
+      <p:sp>
+        <p:nvSpPr>
+          <p:cNvPr id="17" name="summary-02-detail-3">
+            <a:extLst xmlns:a="http://schemas.openxmlformats.org/drawingml/2006/main">
+              <a:ext uri="{FF2B5EF4-FFF2-40B4-BE49-F238E27FC236}">
+                <a16:creationId xmlns:a16="http://schemas.microsoft.com/office/drawing/2014/main" id="{323935AE-AC65-460A-B8A1-C3ED9BADD529}"/>
+              </a:ext>
+            </a:extLst>
+          </p:cNvPr>
+          <p:cNvSpPr>
+            <a:spLocks xmlns:a="http://schemas.openxmlformats.org/drawingml/2006/main" noGrp="1"/>
+          </p:cNvSpPr>
+          <p:nvPr/>
+        </p:nvSpPr>
+        <p:spPr>
+          <a:xfrm xmlns:a="http://schemas.openxmlformats.org/drawingml/2006/main">
+            <a:off x="9201150" y="2095500"/>
+            <a:ext cx="2724150" cy="1676400"/>
+          </a:xfrm>
+          <a:prstGeom xmlns:a="http://schemas.openxmlformats.org/drawingml/2006/main" prst="roundRect">
+            <a:avLst>
+              <a:gd name="adj" fmla="val 4545"/>
+            </a:avLst>
+          </a:prstGeom>
+          <a:solidFill xmlns:a="http://schemas.openxmlformats.org/drawingml/2006/main">
+            <a:srgbClr val="FFFFFF"/>
+          </a:solidFill>
+          <a:ln xmlns:a="http://schemas.openxmlformats.org/drawingml/2006/main" w="9525">
+            <a:solidFill>
+              <a:srgbClr val="D6DDE2"/>
+            </a:solidFill>
+            <a:prstDash val="solid"/>
+          </a:ln>
+        </p:spPr>
+        <p:txBody>
+          <a:bodyPr xmlns:a="http://schemas.openxmlformats.org/drawingml/2006/main" lIns="76200" tIns="38100" rIns="76200" bIns="38100" anchor="ctr"/>
+          <a:lstStyle xmlns:a="http://schemas.openxmlformats.org/drawingml/2006/main"/>
+          <a:p xmlns:a="http://schemas.openxmlformats.org/drawingml/2006/main">
+            <a:pPr algn="ctr">
+              <a:lnSpc>
+                <a:spcPct val="116000"/>
+              </a:lnSpc>
+              <a:buNone/>
               <a:defRPr sz="1500" b="1">
                 <a:solidFill>
                   <a:srgbClr val="263746"/>
@@ -18620,52 +19097,60 @@
                 <a:ea typeface="Microsoft YaHei"/>
                 <a:cs typeface="Microsoft YaHei"/>
               </a:rPr>
-              <a:t>NASEM Chapter 2 或 Saltzer &amp; Schroeder 权限原则选段</a:t>
-            </a:r>
-          </a:p>
-        </p:txBody>
-      </p:sp>
-      <p:sp>
-        <p:nvSpPr>
-          <p:cNvPr id="14" name="p29-bottom">
-            <a:extLst xmlns:a="http://schemas.openxmlformats.org/drawingml/2006/main">
-              <a:ext uri="{FF2B5EF4-FFF2-40B4-BE49-F238E27FC236}">
-                <a16:creationId xmlns:a16="http://schemas.microsoft.com/office/drawing/2014/main" id="{B21DCF2A-2EFD-4B0A-9166-9840237A9E71}"/>
-              </a:ext>
-            </a:extLst>
-          </p:cNvPr>
-          <p:cNvSpPr>
-            <a:spLocks xmlns:a="http://schemas.openxmlformats.org/drawingml/2006/main" noGrp="1"/>
-          </p:cNvSpPr>
-          <p:nvPr/>
-        </p:nvSpPr>
-        <p:spPr>
-          <a:xfrm xmlns:a="http://schemas.openxmlformats.org/drawingml/2006/main">
-            <a:off x="2076450" y="5124450"/>
-            <a:ext cx="8039100" cy="476250"/>
-          </a:xfrm>
-          <a:prstGeom xmlns:a="http://schemas.openxmlformats.org/drawingml/2006/main" prst="rect">
-            <a:avLst/>
-          </a:prstGeom>
-          <a:noFill xmlns:a="http://schemas.openxmlformats.org/drawingml/2006/main"/>
-          <a:ln xmlns:a="http://schemas.openxmlformats.org/drawingml/2006/main" w="0">
-            <a:noFill/>
-            <a:prstDash val="solid"/>
-          </a:ln>
-        </p:spPr>
-        <p:txBody>
-          <a:bodyPr xmlns:a="http://schemas.openxmlformats.org/drawingml/2006/main" lIns="76200" tIns="38100" rIns="76200" bIns="38100" anchor="ctr"/>
-          <a:lstStyle xmlns:a="http://schemas.openxmlformats.org/drawingml/2006/main"/>
-          <a:p xmlns:a="http://schemas.openxmlformats.org/drawingml/2006/main">
-            <a:pPr algn="ctr">
-              <a:defRPr sz="1875" b="1">
+              <a:t>把来源、diff、失败、决策与 AI 使用记录绑定到项目版本</a:t>
+            </a:r>
+          </a:p>
+        </p:txBody>
+      </p:sp>
+      <p:sp>
+        <p:nvSpPr>
+          <p:cNvPr id="18" name="summary-02-boundary">
+            <a:extLst xmlns:a="http://schemas.openxmlformats.org/drawingml/2006/main">
+              <a:ext uri="{FF2B5EF4-FFF2-40B4-BE49-F238E27FC236}">
+                <a16:creationId xmlns:a16="http://schemas.microsoft.com/office/drawing/2014/main" id="{C998A541-2873-4740-9EA3-F643010DCE88}"/>
+              </a:ext>
+            </a:extLst>
+          </p:cNvPr>
+          <p:cNvSpPr>
+            <a:spLocks xmlns:a="http://schemas.openxmlformats.org/drawingml/2006/main" noGrp="1"/>
+          </p:cNvSpPr>
+          <p:nvPr/>
+        </p:nvSpPr>
+        <p:spPr>
+          <a:xfrm xmlns:a="http://schemas.openxmlformats.org/drawingml/2006/main">
+            <a:off x="1162050" y="4400550"/>
+            <a:ext cx="9867900" cy="876300"/>
+          </a:xfrm>
+          <a:prstGeom xmlns:a="http://schemas.openxmlformats.org/drawingml/2006/main" prst="roundRect">
+            <a:avLst>
+              <a:gd name="adj" fmla="val 8696"/>
+            </a:avLst>
+          </a:prstGeom>
+          <a:solidFill xmlns:a="http://schemas.openxmlformats.org/drawingml/2006/main">
+            <a:srgbClr val="F8E9EA"/>
+          </a:solidFill>
+          <a:ln xmlns:a="http://schemas.openxmlformats.org/drawingml/2006/main" w="0">
+            <a:noFill/>
+            <a:prstDash val="solid"/>
+          </a:ln>
+        </p:spPr>
+        <p:txBody>
+          <a:bodyPr xmlns:a="http://schemas.openxmlformats.org/drawingml/2006/main" lIns="76200" tIns="38100" rIns="76200" bIns="38100" anchor="ctr"/>
+          <a:lstStyle xmlns:a="http://schemas.openxmlformats.org/drawingml/2006/main"/>
+          <a:p xmlns:a="http://schemas.openxmlformats.org/drawingml/2006/main">
+            <a:pPr algn="ctr">
+              <a:lnSpc>
+                <a:spcPct val="114000"/>
+              </a:lnSpc>
+              <a:buNone/>
+              <a:defRPr sz="1725" b="1">
                 <a:solidFill>
                   <a:srgbClr val="C8161E"/>
                 </a:solidFill>
               </a:defRPr>
             </a:pPr>
             <a:r>
-              <a:rPr sz="1875" b="1">
+              <a:rPr sz="1725" b="1">
                 <a:solidFill>
                   <a:srgbClr val="C8161E"/>
                 </a:solidFill>
@@ -18673,7 +19158,7 @@
                 <a:ea typeface="Microsoft YaHei"/>
                 <a:cs typeface="Microsoft YaHei"/>
               </a:rPr>
-              <a:t>持续回写个人项目，不单独提交、不计周作业分。</a:t>
+              <a:t>关键边界：权限不是一次性放开；动作风险改变时，必须重新确认并保留记录。</a:t>
             </a:r>
           </a:p>
         </p:txBody>
@@ -18726,7 +19211,9 @@
           <a:bodyPr xmlns:a="http://schemas.openxmlformats.org/drawingml/2006/main" lIns="76200" tIns="0" rIns="76200" bIns="0" anchor="ctr"/>
           <a:lstStyle xmlns:a="http://schemas.openxmlformats.org/drawingml/2006/main"/>
           <a:p xmlns:a="http://schemas.openxmlformats.org/drawingml/2006/main">
-            <a:pPr algn="l"/>
+            <a:pPr algn="l">
+              <a:buNone/>
+            </a:pPr>
             <a:r>
               <a:rPr sz="2250" b="1">
                 <a:solidFill>
@@ -18803,6 +19290,7 @@
           <a:lstStyle xmlns:a="http://schemas.openxmlformats.org/drawingml/2006/main"/>
           <a:p xmlns:a="http://schemas.openxmlformats.org/drawingml/2006/main">
             <a:pPr algn="l">
+              <a:buNone/>
               <a:defRPr sz="1200" b="1">
                 <a:solidFill>
                   <a:srgbClr val="667684"/>
@@ -18917,6 +19405,7 @@
           <a:lstStyle xmlns:a="http://schemas.openxmlformats.org/drawingml/2006/main"/>
           <a:p xmlns:a="http://schemas.openxmlformats.org/drawingml/2006/main">
             <a:pPr algn="ctr">
+              <a:buNone/>
               <a:defRPr sz="2100" b="1">
                 <a:solidFill>
                   <a:srgbClr val="28745A"/>
@@ -18972,6 +19461,7 @@
           <a:lstStyle xmlns:a="http://schemas.openxmlformats.org/drawingml/2006/main"/>
           <a:p xmlns:a="http://schemas.openxmlformats.org/drawingml/2006/main">
             <a:pPr algn="ctr">
+              <a:buNone/>
               <a:defRPr sz="2100" b="1">
                 <a:solidFill>
                   <a:srgbClr val="A86C12"/>
@@ -19027,6 +19517,7 @@
           <a:lstStyle xmlns:a="http://schemas.openxmlformats.org/drawingml/2006/main"/>
           <a:p xmlns:a="http://schemas.openxmlformats.org/drawingml/2006/main">
             <a:pPr algn="ctr">
+              <a:buNone/>
               <a:defRPr sz="2100" b="1">
                 <a:solidFill>
                   <a:srgbClr val="C8161E"/>
@@ -19080,6 +19571,7 @@
           <a:lstStyle xmlns:a="http://schemas.openxmlformats.org/drawingml/2006/main"/>
           <a:p xmlns:a="http://schemas.openxmlformats.org/drawingml/2006/main">
             <a:pPr algn="ctr">
+              <a:buNone/>
               <a:defRPr sz="1800" b="1">
                 <a:solidFill>
                   <a:srgbClr val="C8161E"/>
@@ -19096,6 +19588,630 @@
                 <a:cs typeface="Microsoft YaHei"/>
               </a:rPr>
               <a:t>个人投票后，两人交换一个决定性理由。</a:t>
+            </a:r>
+          </a:p>
+        </p:txBody>
+      </p:sp>
+    </p:spTree>
+    <p:extLst>
+      <p:ext uri="{BB962C8B-B14F-4D97-AF65-F5344CB8AC3E}">
+        <p14:creationId xmlns:p14="http://schemas.microsoft.com/office/powerpoint/2010/main" val="1443728403"/>
+      </p:ext>
+    </p:extLst>
+  </p:cSld>
+</p:sld>
+</file>
+
+<file path=ppt/slides/slide30.xml><?xml version="1.0" encoding="utf-8"?>
+<p:sld xmlns:p="http://schemas.openxmlformats.org/presentationml/2006/main">
+  <p:cSld>
+    <p:spTree>
+      <p:nvGrpSpPr>
+        <p:cNvPr id="1" name=""/>
+        <p:cNvGrpSpPr/>
+        <p:nvPr/>
+      </p:nvGrpSpPr>
+      <p:grpSpPr>
+        <a:xfrm xmlns:a="http://schemas.openxmlformats.org/drawingml/2006/main"/>
+      </p:grpSpPr>
+      <p:sp>
+        <p:nvSpPr>
+          <p:cNvPr id="4" name="Text Placeholder 3">
+            <a:extLst xmlns:a="http://schemas.openxmlformats.org/drawingml/2006/main">
+              <a:ext uri="{FF2B5EF4-FFF2-40B4-BE49-F238E27FC236}">
+                <a16:creationId xmlns:a16="http://schemas.microsoft.com/office/drawing/2014/main" id="{4D941B40-7A0A-534E-3563-CA11753C8E3F}"/>
+              </a:ext>
+            </a:extLst>
+          </p:cNvPr>
+          <p:cNvSpPr>
+            <a:spLocks xmlns:a="http://schemas.openxmlformats.org/drawingml/2006/main" noGrp="1"/>
+          </p:cNvSpPr>
+          <p:nvPr>
+            <p:ph type="body" idx="14"/>
+          </p:nvPr>
+        </p:nvSpPr>
+        <p:spPr>
+          <a:xfrm xmlns:a="http://schemas.openxmlformats.org/drawingml/2006/main">
+            <a:off x="1028700" y="28575"/>
+            <a:ext cx="10668000" cy="628650"/>
+          </a:xfrm>
+        </p:spPr>
+        <p:txBody>
+          <a:bodyPr xmlns:a="http://schemas.openxmlformats.org/drawingml/2006/main" lIns="76200" tIns="0" rIns="76200" bIns="0" anchor="ctr"/>
+          <a:lstStyle xmlns:a="http://schemas.openxmlformats.org/drawingml/2006/main"/>
+          <a:p xmlns:a="http://schemas.openxmlformats.org/drawingml/2006/main">
+            <a:pPr algn="l">
+              <a:buNone/>
+            </a:pPr>
+            <a:r>
+              <a:rPr sz="2250" b="1">
+                <a:solidFill>
+                  <a:srgbClr val="FFFFFF"/>
+                </a:solidFill>
+                <a:latin typeface="Microsoft YaHei"/>
+                <a:ea typeface="Microsoft YaHei"/>
+                <a:cs typeface="Microsoft YaHei"/>
+              </a:rPr>
+              <a:t>课后继续推进，第 3 课带着边界开始检索</a:t>
+            </a:r>
+            <a:endParaRPr/>
+          </a:p>
+        </p:txBody>
+      </p:sp>
+      <p:sp>
+        <p:nvSpPr>
+          <p:cNvPr id="5" name="Slide Number Placeholder 4">
+            <a:extLst xmlns:a="http://schemas.openxmlformats.org/drawingml/2006/main">
+              <a:ext uri="{FF2B5EF4-FFF2-40B4-BE49-F238E27FC236}">
+                <a16:creationId xmlns:a16="http://schemas.microsoft.com/office/drawing/2014/main" id="{EBA5909F-738E-F60C-BE8C-B3F1D94548E5}"/>
+              </a:ext>
+            </a:extLst>
+          </p:cNvPr>
+          <p:cNvSpPr>
+            <a:spLocks xmlns:a="http://schemas.openxmlformats.org/drawingml/2006/main" noGrp="1"/>
+          </p:cNvSpPr>
+          <p:nvPr>
+            <p:ph type="sldNum" idx="10"/>
+          </p:nvPr>
+        </p:nvSpPr>
+        <p:spPr/>
+        <p:txBody>
+          <a:bodyPr xmlns:a="http://schemas.openxmlformats.org/drawingml/2006/main"/>
+          <a:lstStyle xmlns:a="http://schemas.openxmlformats.org/drawingml/2006/main"/>
+          <a:p xmlns:a="http://schemas.openxmlformats.org/drawingml/2006/main">
+            <a:fld id="{5FEBBBCE-9E16-527A-0EE3-E5839422D847}" type="slidenum">
+              <a:t>30</a:t>
+            </a:fld>
+            <a:endParaRPr/>
+          </a:p>
+        </p:txBody>
+      </p:sp>
+      <p:sp>
+        <p:nvSpPr>
+          <p:cNvPr id="6" name="p29-t-0">
+            <a:extLst xmlns:a="http://schemas.openxmlformats.org/drawingml/2006/main">
+              <a:ext uri="{FF2B5EF4-FFF2-40B4-BE49-F238E27FC236}">
+                <a16:creationId xmlns:a16="http://schemas.microsoft.com/office/drawing/2014/main" id="{CB834982-0E3C-4464-AB3E-632423A72EDC}"/>
+              </a:ext>
+            </a:extLst>
+          </p:cNvPr>
+          <p:cNvSpPr>
+            <a:spLocks xmlns:a="http://schemas.openxmlformats.org/drawingml/2006/main" noGrp="1"/>
+          </p:cNvSpPr>
+          <p:nvPr/>
+        </p:nvSpPr>
+        <p:spPr>
+          <a:xfrm xmlns:a="http://schemas.openxmlformats.org/drawingml/2006/main">
+            <a:off x="666750" y="1219200"/>
+            <a:ext cx="5143500" cy="514350"/>
+          </a:xfrm>
+          <a:prstGeom xmlns:a="http://schemas.openxmlformats.org/drawingml/2006/main" prst="rect">
+            <a:avLst/>
+          </a:prstGeom>
+          <a:noFill xmlns:a="http://schemas.openxmlformats.org/drawingml/2006/main"/>
+          <a:ln xmlns:a="http://schemas.openxmlformats.org/drawingml/2006/main" w="0">
+            <a:noFill/>
+            <a:prstDash val="solid"/>
+          </a:ln>
+        </p:spPr>
+        <p:txBody>
+          <a:bodyPr xmlns:a="http://schemas.openxmlformats.org/drawingml/2006/main" lIns="76200" tIns="38100" rIns="76200" bIns="38100" anchor="ctr"/>
+          <a:lstStyle xmlns:a="http://schemas.openxmlformats.org/drawingml/2006/main"/>
+          <a:p xmlns:a="http://schemas.openxmlformats.org/drawingml/2006/main">
+            <a:pPr algn="ctr">
+              <a:buNone/>
+              <a:defRPr sz="1650" b="1">
+                <a:solidFill>
+                  <a:srgbClr val="2F638A"/>
+                </a:solidFill>
+              </a:defRPr>
+            </a:pPr>
+            <a:r>
+              <a:rPr sz="1650" b="1">
+                <a:solidFill>
+                  <a:srgbClr val="2F638A"/>
+                </a:solidFill>
+                <a:latin typeface="Microsoft YaHei"/>
+                <a:ea typeface="Microsoft YaHei"/>
+                <a:cs typeface="Microsoft YaHei"/>
+              </a:rPr>
+              <a:t>必读｜约 15 分钟</a:t>
+            </a:r>
+          </a:p>
+        </p:txBody>
+      </p:sp>
+      <p:sp>
+        <p:nvSpPr>
+          <p:cNvPr id="7" name="p29-b-0">
+            <a:extLst xmlns:a="http://schemas.openxmlformats.org/drawingml/2006/main">
+              <a:ext uri="{FF2B5EF4-FFF2-40B4-BE49-F238E27FC236}">
+                <a16:creationId xmlns:a16="http://schemas.microsoft.com/office/drawing/2014/main" id="{49F23FBB-F6B7-492D-ABD7-96FE6F834431}"/>
+              </a:ext>
+            </a:extLst>
+          </p:cNvPr>
+          <p:cNvSpPr>
+            <a:spLocks xmlns:a="http://schemas.openxmlformats.org/drawingml/2006/main" noGrp="1"/>
+          </p:cNvSpPr>
+          <p:nvPr/>
+        </p:nvSpPr>
+        <p:spPr>
+          <a:xfrm xmlns:a="http://schemas.openxmlformats.org/drawingml/2006/main">
+            <a:off x="666750" y="1809750"/>
+            <a:ext cx="5143500" cy="1009650"/>
+          </a:xfrm>
+          <a:prstGeom xmlns:a="http://schemas.openxmlformats.org/drawingml/2006/main" prst="rect">
+            <a:avLst/>
+          </a:prstGeom>
+          <a:solidFill xmlns:a="http://schemas.openxmlformats.org/drawingml/2006/main">
+            <a:srgbClr val="E8F0F6"/>
+          </a:solidFill>
+          <a:ln xmlns:a="http://schemas.openxmlformats.org/drawingml/2006/main" w="0">
+            <a:noFill/>
+            <a:prstDash val="solid"/>
+          </a:ln>
+        </p:spPr>
+        <p:txBody>
+          <a:bodyPr xmlns:a="http://schemas.openxmlformats.org/drawingml/2006/main" lIns="76200" tIns="38100" rIns="76200" bIns="38100" anchor="ctr"/>
+          <a:lstStyle xmlns:a="http://schemas.openxmlformats.org/drawingml/2006/main"/>
+          <a:p xmlns:a="http://schemas.openxmlformats.org/drawingml/2006/main">
+            <a:pPr algn="ctr">
+              <a:lnSpc>
+                <a:spcPct val="130000"/>
+              </a:lnSpc>
+              <a:buNone/>
+              <a:defRPr sz="1500" b="1">
+                <a:solidFill>
+                  <a:srgbClr val="263746"/>
+                </a:solidFill>
+              </a:defRPr>
+            </a:pPr>
+            <a:r>
+              <a:rPr sz="1500" b="1">
+                <a:solidFill>
+                  <a:srgbClr val="263746"/>
+                </a:solidFill>
+                <a:latin typeface="Microsoft YaHei"/>
+                <a:ea typeface="Microsoft YaHei"/>
+                <a:cs typeface="Microsoft YaHei"/>
+              </a:rPr>
+              <a:t>中科院《诚信提醒》</a:t>
+            </a:r>
+          </a:p>
+          <a:p xmlns:a="http://schemas.openxmlformats.org/drawingml/2006/main">
+            <a:pPr algn="ctr">
+              <a:lnSpc>
+                <a:spcPct val="130000"/>
+              </a:lnSpc>
+              <a:buNone/>
+              <a:defRPr sz="1500" b="1">
+                <a:solidFill>
+                  <a:srgbClr val="263746"/>
+                </a:solidFill>
+              </a:defRPr>
+            </a:pPr>
+            <a:r>
+              <a:rPr sz="1500" b="1">
+                <a:solidFill>
+                  <a:srgbClr val="263746"/>
+                </a:solidFill>
+                <a:latin typeface="Microsoft YaHei"/>
+                <a:ea typeface="Microsoft YaHei"/>
+                <a:cs typeface="Microsoft YaHei"/>
+              </a:rPr>
+              <a:t>记录一条与本人项目相关的底线</a:t>
+            </a:r>
+          </a:p>
+        </p:txBody>
+      </p:sp>
+      <p:sp>
+        <p:nvSpPr>
+          <p:cNvPr id="8" name="p29-t-1">
+            <a:extLst xmlns:a="http://schemas.openxmlformats.org/drawingml/2006/main">
+              <a:ext uri="{FF2B5EF4-FFF2-40B4-BE49-F238E27FC236}">
+                <a16:creationId xmlns:a16="http://schemas.microsoft.com/office/drawing/2014/main" id="{8F1B5EFA-17E4-4A2E-9AAC-2513A1C884DD}"/>
+              </a:ext>
+            </a:extLst>
+          </p:cNvPr>
+          <p:cNvSpPr>
+            <a:spLocks xmlns:a="http://schemas.openxmlformats.org/drawingml/2006/main" noGrp="1"/>
+          </p:cNvSpPr>
+          <p:nvPr/>
+        </p:nvSpPr>
+        <p:spPr>
+          <a:xfrm xmlns:a="http://schemas.openxmlformats.org/drawingml/2006/main">
+            <a:off x="6267450" y="1219200"/>
+            <a:ext cx="5143500" cy="514350"/>
+          </a:xfrm>
+          <a:prstGeom xmlns:a="http://schemas.openxmlformats.org/drawingml/2006/main" prst="rect">
+            <a:avLst/>
+          </a:prstGeom>
+          <a:noFill xmlns:a="http://schemas.openxmlformats.org/drawingml/2006/main"/>
+          <a:ln xmlns:a="http://schemas.openxmlformats.org/drawingml/2006/main" w="0">
+            <a:noFill/>
+            <a:prstDash val="solid"/>
+          </a:ln>
+        </p:spPr>
+        <p:txBody>
+          <a:bodyPr xmlns:a="http://schemas.openxmlformats.org/drawingml/2006/main" lIns="76200" tIns="38100" rIns="76200" bIns="38100" anchor="ctr"/>
+          <a:lstStyle xmlns:a="http://schemas.openxmlformats.org/drawingml/2006/main"/>
+          <a:p xmlns:a="http://schemas.openxmlformats.org/drawingml/2006/main">
+            <a:pPr algn="ctr">
+              <a:buNone/>
+              <a:defRPr sz="1650" b="1">
+                <a:solidFill>
+                  <a:srgbClr val="C8161E"/>
+                </a:solidFill>
+              </a:defRPr>
+            </a:pPr>
+            <a:r>
+              <a:rPr sz="1650" b="1">
+                <a:solidFill>
+                  <a:srgbClr val="C8161E"/>
+                </a:solidFill>
+                <a:latin typeface="Microsoft YaHei"/>
+                <a:ea typeface="Microsoft YaHei"/>
+                <a:cs typeface="Microsoft YaHei"/>
+              </a:rPr>
+              <a:t>项目更新｜约 20 分钟</a:t>
+            </a:r>
+          </a:p>
+        </p:txBody>
+      </p:sp>
+      <p:sp>
+        <p:nvSpPr>
+          <p:cNvPr id="9" name="p29-b-1">
+            <a:extLst xmlns:a="http://schemas.openxmlformats.org/drawingml/2006/main">
+              <a:ext uri="{FF2B5EF4-FFF2-40B4-BE49-F238E27FC236}">
+                <a16:creationId xmlns:a16="http://schemas.microsoft.com/office/drawing/2014/main" id="{AD439CFE-5B30-4765-800D-849EB0859598}"/>
+              </a:ext>
+            </a:extLst>
+          </p:cNvPr>
+          <p:cNvSpPr>
+            <a:spLocks xmlns:a="http://schemas.openxmlformats.org/drawingml/2006/main" noGrp="1"/>
+          </p:cNvSpPr>
+          <p:nvPr/>
+        </p:nvSpPr>
+        <p:spPr>
+          <a:xfrm xmlns:a="http://schemas.openxmlformats.org/drawingml/2006/main">
+            <a:off x="6267450" y="1809750"/>
+            <a:ext cx="5143500" cy="1009650"/>
+          </a:xfrm>
+          <a:prstGeom xmlns:a="http://schemas.openxmlformats.org/drawingml/2006/main" prst="rect">
+            <a:avLst/>
+          </a:prstGeom>
+          <a:solidFill xmlns:a="http://schemas.openxmlformats.org/drawingml/2006/main">
+            <a:srgbClr val="F8E9EA"/>
+          </a:solidFill>
+          <a:ln xmlns:a="http://schemas.openxmlformats.org/drawingml/2006/main" w="0">
+            <a:noFill/>
+            <a:prstDash val="solid"/>
+          </a:ln>
+        </p:spPr>
+        <p:txBody>
+          <a:bodyPr xmlns:a="http://schemas.openxmlformats.org/drawingml/2006/main" lIns="76200" tIns="38100" rIns="76200" bIns="38100" anchor="ctr"/>
+          <a:lstStyle xmlns:a="http://schemas.openxmlformats.org/drawingml/2006/main"/>
+          <a:p xmlns:a="http://schemas.openxmlformats.org/drawingml/2006/main">
+            <a:pPr algn="ctr">
+              <a:lnSpc>
+                <a:spcPct val="130000"/>
+              </a:lnSpc>
+              <a:buNone/>
+              <a:defRPr sz="1500" b="1">
+                <a:solidFill>
+                  <a:srgbClr val="263746"/>
+                </a:solidFill>
+              </a:defRPr>
+            </a:pPr>
+            <a:r>
+              <a:rPr sz="1500" b="1">
+                <a:solidFill>
+                  <a:srgbClr val="263746"/>
+                </a:solidFill>
+                <a:latin typeface="Microsoft YaHei"/>
+                <a:ea typeface="Microsoft YaHei"/>
+                <a:cs typeface="Microsoft YaHei"/>
+              </a:rPr>
+              <a:t>权限矩阵 + 风险卡 + 四项工件追踪 + AI 使用记录</a:t>
+            </a:r>
+          </a:p>
+        </p:txBody>
+      </p:sp>
+      <p:sp>
+        <p:nvSpPr>
+          <p:cNvPr id="10" name="p29-t-2">
+            <a:extLst xmlns:a="http://schemas.openxmlformats.org/drawingml/2006/main">
+              <a:ext uri="{FF2B5EF4-FFF2-40B4-BE49-F238E27FC236}">
+                <a16:creationId xmlns:a16="http://schemas.microsoft.com/office/drawing/2014/main" id="{5DD311C0-A28B-49B9-A2E3-71F5DE9EBB23}"/>
+              </a:ext>
+            </a:extLst>
+          </p:cNvPr>
+          <p:cNvSpPr>
+            <a:spLocks xmlns:a="http://schemas.openxmlformats.org/drawingml/2006/main" noGrp="1"/>
+          </p:cNvSpPr>
+          <p:nvPr/>
+        </p:nvSpPr>
+        <p:spPr>
+          <a:xfrm xmlns:a="http://schemas.openxmlformats.org/drawingml/2006/main">
+            <a:off x="666750" y="3028950"/>
+            <a:ext cx="5143500" cy="514350"/>
+          </a:xfrm>
+          <a:prstGeom xmlns:a="http://schemas.openxmlformats.org/drawingml/2006/main" prst="rect">
+            <a:avLst/>
+          </a:prstGeom>
+          <a:noFill xmlns:a="http://schemas.openxmlformats.org/drawingml/2006/main"/>
+          <a:ln xmlns:a="http://schemas.openxmlformats.org/drawingml/2006/main" w="0">
+            <a:noFill/>
+            <a:prstDash val="solid"/>
+          </a:ln>
+        </p:spPr>
+        <p:txBody>
+          <a:bodyPr xmlns:a="http://schemas.openxmlformats.org/drawingml/2006/main" lIns="76200" tIns="38100" rIns="76200" bIns="38100" anchor="ctr"/>
+          <a:lstStyle xmlns:a="http://schemas.openxmlformats.org/drawingml/2006/main"/>
+          <a:p xmlns:a="http://schemas.openxmlformats.org/drawingml/2006/main">
+            <a:pPr algn="ctr">
+              <a:buNone/>
+              <a:defRPr sz="1650" b="1">
+                <a:solidFill>
+                  <a:srgbClr val="28745A"/>
+                </a:solidFill>
+              </a:defRPr>
+            </a:pPr>
+            <a:r>
+              <a:rPr sz="1650" b="1">
+                <a:solidFill>
+                  <a:srgbClr val="28745A"/>
+                </a:solidFill>
+                <a:latin typeface="Microsoft YaHei"/>
+                <a:ea typeface="Microsoft YaHei"/>
+                <a:cs typeface="Microsoft YaHei"/>
+              </a:rPr>
+              <a:t>第 3 课准备｜约 10 分钟</a:t>
+            </a:r>
+          </a:p>
+        </p:txBody>
+      </p:sp>
+      <p:sp>
+        <p:nvSpPr>
+          <p:cNvPr id="11" name="p29-b-2">
+            <a:extLst xmlns:a="http://schemas.openxmlformats.org/drawingml/2006/main">
+              <a:ext uri="{FF2B5EF4-FFF2-40B4-BE49-F238E27FC236}">
+                <a16:creationId xmlns:a16="http://schemas.microsoft.com/office/drawing/2014/main" id="{879F465F-A348-4BE3-A6B9-86593F6CC70D}"/>
+              </a:ext>
+            </a:extLst>
+          </p:cNvPr>
+          <p:cNvSpPr>
+            <a:spLocks xmlns:a="http://schemas.openxmlformats.org/drawingml/2006/main" noGrp="1"/>
+          </p:cNvSpPr>
+          <p:nvPr/>
+        </p:nvSpPr>
+        <p:spPr>
+          <a:xfrm xmlns:a="http://schemas.openxmlformats.org/drawingml/2006/main">
+            <a:off x="666750" y="3619500"/>
+            <a:ext cx="5143500" cy="1009650"/>
+          </a:xfrm>
+          <a:prstGeom xmlns:a="http://schemas.openxmlformats.org/drawingml/2006/main" prst="rect">
+            <a:avLst/>
+          </a:prstGeom>
+          <a:solidFill xmlns:a="http://schemas.openxmlformats.org/drawingml/2006/main">
+            <a:srgbClr val="E7F2ED"/>
+          </a:solidFill>
+          <a:ln xmlns:a="http://schemas.openxmlformats.org/drawingml/2006/main" w="0">
+            <a:noFill/>
+            <a:prstDash val="solid"/>
+          </a:ln>
+        </p:spPr>
+        <p:txBody>
+          <a:bodyPr xmlns:a="http://schemas.openxmlformats.org/drawingml/2006/main" lIns="76200" tIns="38100" rIns="76200" bIns="38100" anchor="ctr"/>
+          <a:lstStyle xmlns:a="http://schemas.openxmlformats.org/drawingml/2006/main"/>
+          <a:p xmlns:a="http://schemas.openxmlformats.org/drawingml/2006/main">
+            <a:pPr algn="ctr">
+              <a:lnSpc>
+                <a:spcPct val="130000"/>
+              </a:lnSpc>
+              <a:buNone/>
+              <a:defRPr sz="1500" b="1">
+                <a:solidFill>
+                  <a:srgbClr val="263746"/>
+                </a:solidFill>
+              </a:defRPr>
+            </a:pPr>
+            <a:r>
+              <a:rPr sz="1500" b="1">
+                <a:solidFill>
+                  <a:srgbClr val="263746"/>
+                </a:solidFill>
+                <a:latin typeface="Microsoft YaHei"/>
+                <a:ea typeface="Microsoft YaHei"/>
+                <a:cs typeface="Microsoft YaHei"/>
+              </a:rPr>
+              <a:t>一个公开研究问题 + 3–5 个关键词 + 一项来源 / 网络边界</a:t>
+            </a:r>
+          </a:p>
+        </p:txBody>
+      </p:sp>
+      <p:sp>
+        <p:nvSpPr>
+          <p:cNvPr id="12" name="p29-t-3">
+            <a:extLst xmlns:a="http://schemas.openxmlformats.org/drawingml/2006/main">
+              <a:ext uri="{FF2B5EF4-FFF2-40B4-BE49-F238E27FC236}">
+                <a16:creationId xmlns:a16="http://schemas.microsoft.com/office/drawing/2014/main" id="{BD825422-24D9-4B1A-8494-0E7EE3FF162B}"/>
+              </a:ext>
+            </a:extLst>
+          </p:cNvPr>
+          <p:cNvSpPr>
+            <a:spLocks xmlns:a="http://schemas.openxmlformats.org/drawingml/2006/main" noGrp="1"/>
+          </p:cNvSpPr>
+          <p:nvPr/>
+        </p:nvSpPr>
+        <p:spPr>
+          <a:xfrm xmlns:a="http://schemas.openxmlformats.org/drawingml/2006/main">
+            <a:off x="6267450" y="3028950"/>
+            <a:ext cx="5143500" cy="514350"/>
+          </a:xfrm>
+          <a:prstGeom xmlns:a="http://schemas.openxmlformats.org/drawingml/2006/main" prst="rect">
+            <a:avLst/>
+          </a:prstGeom>
+          <a:noFill xmlns:a="http://schemas.openxmlformats.org/drawingml/2006/main"/>
+          <a:ln xmlns:a="http://schemas.openxmlformats.org/drawingml/2006/main" w="0">
+            <a:noFill/>
+            <a:prstDash val="solid"/>
+          </a:ln>
+        </p:spPr>
+        <p:txBody>
+          <a:bodyPr xmlns:a="http://schemas.openxmlformats.org/drawingml/2006/main" lIns="76200" tIns="38100" rIns="76200" bIns="38100" anchor="ctr"/>
+          <a:lstStyle xmlns:a="http://schemas.openxmlformats.org/drawingml/2006/main"/>
+          <a:p xmlns:a="http://schemas.openxmlformats.org/drawingml/2006/main">
+            <a:pPr algn="ctr">
+              <a:buNone/>
+              <a:defRPr sz="1650" b="1">
+                <a:solidFill>
+                  <a:srgbClr val="A86C12"/>
+                </a:solidFill>
+              </a:defRPr>
+            </a:pPr>
+            <a:r>
+              <a:rPr sz="1650" b="1">
+                <a:solidFill>
+                  <a:srgbClr val="A86C12"/>
+                </a:solidFill>
+                <a:latin typeface="Microsoft YaHei"/>
+                <a:ea typeface="Microsoft YaHei"/>
+                <a:cs typeface="Microsoft YaHei"/>
+              </a:rPr>
+              <a:t>任选阅读</a:t>
+            </a:r>
+          </a:p>
+        </p:txBody>
+      </p:sp>
+      <p:sp>
+        <p:nvSpPr>
+          <p:cNvPr id="13" name="p29-b-3">
+            <a:extLst xmlns:a="http://schemas.openxmlformats.org/drawingml/2006/main">
+              <a:ext uri="{FF2B5EF4-FFF2-40B4-BE49-F238E27FC236}">
+                <a16:creationId xmlns:a16="http://schemas.microsoft.com/office/drawing/2014/main" id="{1AEE394E-E563-4997-B72F-C562241B532E}"/>
+              </a:ext>
+            </a:extLst>
+          </p:cNvPr>
+          <p:cNvSpPr>
+            <a:spLocks xmlns:a="http://schemas.openxmlformats.org/drawingml/2006/main" noGrp="1"/>
+          </p:cNvSpPr>
+          <p:nvPr/>
+        </p:nvSpPr>
+        <p:spPr>
+          <a:xfrm xmlns:a="http://schemas.openxmlformats.org/drawingml/2006/main">
+            <a:off x="6267450" y="3619500"/>
+            <a:ext cx="5143500" cy="1009650"/>
+          </a:xfrm>
+          <a:prstGeom xmlns:a="http://schemas.openxmlformats.org/drawingml/2006/main" prst="rect">
+            <a:avLst/>
+          </a:prstGeom>
+          <a:solidFill xmlns:a="http://schemas.openxmlformats.org/drawingml/2006/main">
+            <a:srgbClr val="FAF0DD"/>
+          </a:solidFill>
+          <a:ln xmlns:a="http://schemas.openxmlformats.org/drawingml/2006/main" w="0">
+            <a:noFill/>
+            <a:prstDash val="solid"/>
+          </a:ln>
+        </p:spPr>
+        <p:txBody>
+          <a:bodyPr xmlns:a="http://schemas.openxmlformats.org/drawingml/2006/main" lIns="76200" tIns="38100" rIns="76200" bIns="38100" anchor="ctr"/>
+          <a:lstStyle xmlns:a="http://schemas.openxmlformats.org/drawingml/2006/main"/>
+          <a:p xmlns:a="http://schemas.openxmlformats.org/drawingml/2006/main">
+            <a:pPr algn="ctr">
+              <a:lnSpc>
+                <a:spcPct val="130000"/>
+              </a:lnSpc>
+              <a:buNone/>
+              <a:defRPr sz="1500" b="1">
+                <a:solidFill>
+                  <a:srgbClr val="263746"/>
+                </a:solidFill>
+              </a:defRPr>
+            </a:pPr>
+            <a:r>
+              <a:rPr sz="1500" b="1">
+                <a:solidFill>
+                  <a:srgbClr val="263746"/>
+                </a:solidFill>
+                <a:latin typeface="Microsoft YaHei"/>
+                <a:ea typeface="Microsoft YaHei"/>
+                <a:cs typeface="Microsoft YaHei"/>
+              </a:rPr>
+              <a:t>NASEM Chapter 2 或 Saltzer &amp; Schroeder 权限原则选段</a:t>
+            </a:r>
+          </a:p>
+        </p:txBody>
+      </p:sp>
+      <p:sp>
+        <p:nvSpPr>
+          <p:cNvPr id="14" name="p29-bottom">
+            <a:extLst xmlns:a="http://schemas.openxmlformats.org/drawingml/2006/main">
+              <a:ext uri="{FF2B5EF4-FFF2-40B4-BE49-F238E27FC236}">
+                <a16:creationId xmlns:a16="http://schemas.microsoft.com/office/drawing/2014/main" id="{B21DCF2A-2EFD-4B0A-9166-9840237A9E71}"/>
+              </a:ext>
+            </a:extLst>
+          </p:cNvPr>
+          <p:cNvSpPr>
+            <a:spLocks xmlns:a="http://schemas.openxmlformats.org/drawingml/2006/main" noGrp="1"/>
+          </p:cNvSpPr>
+          <p:nvPr/>
+        </p:nvSpPr>
+        <p:spPr>
+          <a:xfrm xmlns:a="http://schemas.openxmlformats.org/drawingml/2006/main">
+            <a:off x="2076450" y="5124450"/>
+            <a:ext cx="8039100" cy="476250"/>
+          </a:xfrm>
+          <a:prstGeom xmlns:a="http://schemas.openxmlformats.org/drawingml/2006/main" prst="rect">
+            <a:avLst/>
+          </a:prstGeom>
+          <a:noFill xmlns:a="http://schemas.openxmlformats.org/drawingml/2006/main"/>
+          <a:ln xmlns:a="http://schemas.openxmlformats.org/drawingml/2006/main" w="0">
+            <a:noFill/>
+            <a:prstDash val="solid"/>
+          </a:ln>
+        </p:spPr>
+        <p:txBody>
+          <a:bodyPr xmlns:a="http://schemas.openxmlformats.org/drawingml/2006/main" lIns="76200" tIns="38100" rIns="76200" bIns="38100" anchor="ctr"/>
+          <a:lstStyle xmlns:a="http://schemas.openxmlformats.org/drawingml/2006/main"/>
+          <a:p xmlns:a="http://schemas.openxmlformats.org/drawingml/2006/main">
+            <a:pPr algn="ctr">
+              <a:buNone/>
+              <a:defRPr sz="1875" b="1">
+                <a:solidFill>
+                  <a:srgbClr val="C8161E"/>
+                </a:solidFill>
+              </a:defRPr>
+            </a:pPr>
+            <a:r>
+              <a:rPr sz="1875" b="1">
+                <a:solidFill>
+                  <a:srgbClr val="C8161E"/>
+                </a:solidFill>
+                <a:latin typeface="Microsoft YaHei"/>
+                <a:ea typeface="Microsoft YaHei"/>
+                <a:cs typeface="Microsoft YaHei"/>
+              </a:rPr>
+              <a:t>持续回写个人项目，不单独提交、不计周作业分。</a:t>
             </a:r>
           </a:p>
         </p:txBody>
@@ -19148,7 +20264,9 @@
           <a:bodyPr xmlns:a="http://schemas.openxmlformats.org/drawingml/2006/main" lIns="76200" tIns="0" rIns="76200" bIns="0" anchor="ctr"/>
           <a:lstStyle xmlns:a="http://schemas.openxmlformats.org/drawingml/2006/main"/>
           <a:p xmlns:a="http://schemas.openxmlformats.org/drawingml/2006/main">
-            <a:pPr algn="l"/>
+            <a:pPr algn="l">
+              <a:buNone/>
+            </a:pPr>
             <a:r>
               <a:rPr sz="2250" b="1">
                 <a:solidFill>
@@ -19225,6 +20343,7 @@
           <a:lstStyle xmlns:a="http://schemas.openxmlformats.org/drawingml/2006/main"/>
           <a:p xmlns:a="http://schemas.openxmlformats.org/drawingml/2006/main">
             <a:pPr algn="ctr">
+              <a:buNone/>
               <a:defRPr sz="1950" b="1">
                 <a:solidFill>
                   <a:srgbClr val="18354E"/>
@@ -19278,6 +20397,7 @@
           <a:lstStyle xmlns:a="http://schemas.openxmlformats.org/drawingml/2006/main"/>
           <a:p xmlns:a="http://schemas.openxmlformats.org/drawingml/2006/main">
             <a:pPr algn="ctr">
+              <a:buNone/>
               <a:defRPr sz="1650" b="0">
                 <a:solidFill>
                   <a:srgbClr val="667684"/>
@@ -19331,6 +20451,7 @@
           <a:lstStyle xmlns:a="http://schemas.openxmlformats.org/drawingml/2006/main"/>
           <a:p xmlns:a="http://schemas.openxmlformats.org/drawingml/2006/main">
             <a:pPr algn="ctr">
+              <a:buNone/>
               <a:defRPr sz="1950" b="1">
                 <a:solidFill>
                   <a:srgbClr val="18354E"/>
@@ -19384,6 +20505,7 @@
           <a:lstStyle xmlns:a="http://schemas.openxmlformats.org/drawingml/2006/main"/>
           <a:p xmlns:a="http://schemas.openxmlformats.org/drawingml/2006/main">
             <a:pPr algn="ctr">
+              <a:buNone/>
               <a:defRPr sz="1650" b="0">
                 <a:solidFill>
                   <a:srgbClr val="667684"/>
@@ -19437,6 +20559,7 @@
           <a:lstStyle xmlns:a="http://schemas.openxmlformats.org/drawingml/2006/main"/>
           <a:p xmlns:a="http://schemas.openxmlformats.org/drawingml/2006/main">
             <a:pPr algn="ctr">
+              <a:buNone/>
               <a:defRPr sz="1950" b="1">
                 <a:solidFill>
                   <a:srgbClr val="18354E"/>
@@ -19490,6 +20613,7 @@
           <a:lstStyle xmlns:a="http://schemas.openxmlformats.org/drawingml/2006/main"/>
           <a:p xmlns:a="http://schemas.openxmlformats.org/drawingml/2006/main">
             <a:pPr algn="ctr">
+              <a:buNone/>
               <a:defRPr sz="1650" b="0">
                 <a:solidFill>
                   <a:srgbClr val="667684"/>
@@ -19543,6 +20667,7 @@
           <a:lstStyle xmlns:a="http://schemas.openxmlformats.org/drawingml/2006/main"/>
           <a:p xmlns:a="http://schemas.openxmlformats.org/drawingml/2006/main">
             <a:pPr algn="ctr">
+              <a:buNone/>
               <a:defRPr sz="1950" b="1">
                 <a:solidFill>
                   <a:srgbClr val="18354E"/>
@@ -19596,6 +20721,7 @@
           <a:lstStyle xmlns:a="http://schemas.openxmlformats.org/drawingml/2006/main"/>
           <a:p xmlns:a="http://schemas.openxmlformats.org/drawingml/2006/main">
             <a:pPr algn="ctr">
+              <a:buNone/>
               <a:defRPr sz="1650" b="0">
                 <a:solidFill>
                   <a:srgbClr val="667684"/>
@@ -19649,6 +20775,7 @@
           <a:lstStyle xmlns:a="http://schemas.openxmlformats.org/drawingml/2006/main"/>
           <a:p xmlns:a="http://schemas.openxmlformats.org/drawingml/2006/main">
             <a:pPr algn="ctr">
+              <a:buNone/>
               <a:defRPr sz="1950" b="1">
                 <a:solidFill>
                   <a:srgbClr val="C8161E"/>
@@ -19702,6 +20829,7 @@
           <a:lstStyle xmlns:a="http://schemas.openxmlformats.org/drawingml/2006/main"/>
           <a:p xmlns:a="http://schemas.openxmlformats.org/drawingml/2006/main">
             <a:pPr algn="ctr">
+              <a:buNone/>
               <a:defRPr sz="1650" b="0">
                 <a:solidFill>
                   <a:srgbClr val="667684"/>
@@ -19755,6 +20883,7 @@
           <a:lstStyle xmlns:a="http://schemas.openxmlformats.org/drawingml/2006/main"/>
           <a:p xmlns:a="http://schemas.openxmlformats.org/drawingml/2006/main">
             <a:pPr algn="ctr">
+              <a:buNone/>
               <a:defRPr sz="1950" b="1">
                 <a:solidFill>
                   <a:srgbClr val="18354E"/>
@@ -19808,6 +20937,7 @@
           <a:lstStyle xmlns:a="http://schemas.openxmlformats.org/drawingml/2006/main"/>
           <a:p xmlns:a="http://schemas.openxmlformats.org/drawingml/2006/main">
             <a:pPr algn="ctr">
+              <a:buNone/>
               <a:defRPr sz="1650" b="0">
                 <a:solidFill>
                   <a:srgbClr val="667684"/>
@@ -19861,6 +20991,7 @@
           <a:lstStyle xmlns:a="http://schemas.openxmlformats.org/drawingml/2006/main"/>
           <a:p xmlns:a="http://schemas.openxmlformats.org/drawingml/2006/main">
             <a:pPr algn="ctr">
+              <a:buNone/>
               <a:defRPr sz="2100" b="1">
                 <a:solidFill>
                   <a:srgbClr val="C8161E"/>
@@ -19929,7 +21060,9 @@
           <a:bodyPr xmlns:a="http://schemas.openxmlformats.org/drawingml/2006/main" lIns="76200" tIns="0" rIns="76200" bIns="0" anchor="ctr"/>
           <a:lstStyle xmlns:a="http://schemas.openxmlformats.org/drawingml/2006/main"/>
           <a:p xmlns:a="http://schemas.openxmlformats.org/drawingml/2006/main">
-            <a:pPr algn="l"/>
+            <a:pPr algn="l">
+              <a:buNone/>
+            </a:pPr>
             <a:r>
               <a:rPr sz="2250" b="1">
                 <a:solidFill>
@@ -20006,6 +21139,7 @@
           <a:lstStyle xmlns:a="http://schemas.openxmlformats.org/drawingml/2006/main"/>
           <a:p xmlns:a="http://schemas.openxmlformats.org/drawingml/2006/main">
             <a:pPr algn="ctr">
+              <a:buNone/>
               <a:defRPr sz="1800" b="1">
                 <a:solidFill>
                   <a:srgbClr val="2F638A"/>
@@ -20118,6 +21252,7 @@
           <a:lstStyle xmlns:a="http://schemas.openxmlformats.org/drawingml/2006/main"/>
           <a:p xmlns:a="http://schemas.openxmlformats.org/drawingml/2006/main">
             <a:pPr algn="ctr">
+              <a:buNone/>
               <a:defRPr sz="1800" b="1">
                 <a:solidFill>
                   <a:srgbClr val="A86C12"/>
@@ -20230,6 +21365,7 @@
           <a:lstStyle xmlns:a="http://schemas.openxmlformats.org/drawingml/2006/main"/>
           <a:p xmlns:a="http://schemas.openxmlformats.org/drawingml/2006/main">
             <a:pPr algn="ctr">
+              <a:buNone/>
               <a:defRPr sz="1800" b="1">
                 <a:solidFill>
                   <a:srgbClr val="C8161E"/>
@@ -20416,7 +21552,9 @@
           <a:bodyPr xmlns:a="http://schemas.openxmlformats.org/drawingml/2006/main" lIns="76200" tIns="0" rIns="76200" bIns="0" anchor="ctr"/>
           <a:lstStyle xmlns:a="http://schemas.openxmlformats.org/drawingml/2006/main"/>
           <a:p xmlns:a="http://schemas.openxmlformats.org/drawingml/2006/main">
-            <a:pPr algn="l"/>
+            <a:pPr algn="l">
+              <a:buNone/>
+            </a:pPr>
             <a:r>
               <a:rPr sz="2250" b="1">
                 <a:solidFill>
@@ -20495,6 +21633,7 @@
           <a:lstStyle xmlns:a="http://schemas.openxmlformats.org/drawingml/2006/main"/>
           <a:p xmlns:a="http://schemas.openxmlformats.org/drawingml/2006/main">
             <a:pPr algn="ctr">
+              <a:buNone/>
               <a:defRPr sz="2550" b="1">
                 <a:solidFill>
                   <a:srgbClr val="667684"/>
@@ -20579,6 +21718,7 @@
           <a:lstStyle xmlns:a="http://schemas.openxmlformats.org/drawingml/2006/main"/>
           <a:p xmlns:a="http://schemas.openxmlformats.org/drawingml/2006/main">
             <a:pPr algn="ctr">
+              <a:buNone/>
               <a:defRPr sz="1650" b="1">
                 <a:solidFill>
                   <a:srgbClr val="C8161E"/>
@@ -20730,7 +21870,9 @@
           <a:bodyPr xmlns:a="http://schemas.openxmlformats.org/drawingml/2006/main" lIns="76200" tIns="0" rIns="76200" bIns="0" anchor="ctr"/>
           <a:lstStyle xmlns:a="http://schemas.openxmlformats.org/drawingml/2006/main"/>
           <a:p xmlns:a="http://schemas.openxmlformats.org/drawingml/2006/main">
-            <a:pPr algn="l"/>
+            <a:pPr algn="l">
+              <a:buNone/>
+            </a:pPr>
             <a:r>
               <a:rPr sz="2250" b="1">
                 <a:solidFill>
@@ -20807,6 +21949,7 @@
           <a:lstStyle xmlns:a="http://schemas.openxmlformats.org/drawingml/2006/main"/>
           <a:p xmlns:a="http://schemas.openxmlformats.org/drawingml/2006/main">
             <a:pPr algn="ctr">
+              <a:buNone/>
               <a:defRPr sz="2100" b="1">
                 <a:solidFill>
                   <a:srgbClr val="667684"/>
@@ -20860,6 +22003,7 @@
           <a:lstStyle xmlns:a="http://schemas.openxmlformats.org/drawingml/2006/main"/>
           <a:p xmlns:a="http://schemas.openxmlformats.org/drawingml/2006/main">
             <a:pPr algn="ctr">
+              <a:buNone/>
               <a:defRPr sz="1725" b="1">
                 <a:solidFill>
                   <a:srgbClr val="18354E"/>
@@ -20915,6 +22059,7 @@
           <a:lstStyle xmlns:a="http://schemas.openxmlformats.org/drawingml/2006/main"/>
           <a:p xmlns:a="http://schemas.openxmlformats.org/drawingml/2006/main">
             <a:pPr algn="ctr">
+              <a:buNone/>
               <a:defRPr sz="2100" b="1">
                 <a:solidFill>
                   <a:srgbClr val="263746"/>
@@ -20968,6 +22113,7 @@
           <a:lstStyle xmlns:a="http://schemas.openxmlformats.org/drawingml/2006/main"/>
           <a:p xmlns:a="http://schemas.openxmlformats.org/drawingml/2006/main">
             <a:pPr algn="ctr">
+              <a:buNone/>
               <a:defRPr sz="2100" b="1">
                 <a:solidFill>
                   <a:srgbClr val="667684"/>
@@ -21021,6 +22167,7 @@
           <a:lstStyle xmlns:a="http://schemas.openxmlformats.org/drawingml/2006/main"/>
           <a:p xmlns:a="http://schemas.openxmlformats.org/drawingml/2006/main">
             <a:pPr algn="ctr">
+              <a:buNone/>
               <a:defRPr sz="1725" b="1">
                 <a:solidFill>
                   <a:srgbClr val="18354E"/>
@@ -21076,6 +22223,7 @@
           <a:lstStyle xmlns:a="http://schemas.openxmlformats.org/drawingml/2006/main"/>
           <a:p xmlns:a="http://schemas.openxmlformats.org/drawingml/2006/main">
             <a:pPr algn="ctr">
+              <a:buNone/>
               <a:defRPr sz="2100" b="1">
                 <a:solidFill>
                   <a:srgbClr val="263746"/>
@@ -21129,6 +22277,7 @@
           <a:lstStyle xmlns:a="http://schemas.openxmlformats.org/drawingml/2006/main"/>
           <a:p xmlns:a="http://schemas.openxmlformats.org/drawingml/2006/main">
             <a:pPr algn="ctr">
+              <a:buNone/>
               <a:defRPr sz="2100" b="1">
                 <a:solidFill>
                   <a:srgbClr val="667684"/>
@@ -21182,6 +22331,7 @@
           <a:lstStyle xmlns:a="http://schemas.openxmlformats.org/drawingml/2006/main"/>
           <a:p xmlns:a="http://schemas.openxmlformats.org/drawingml/2006/main">
             <a:pPr algn="ctr">
+              <a:buNone/>
               <a:defRPr sz="1725" b="1">
                 <a:solidFill>
                   <a:srgbClr val="18354E"/>
@@ -21237,6 +22387,7 @@
           <a:lstStyle xmlns:a="http://schemas.openxmlformats.org/drawingml/2006/main"/>
           <a:p xmlns:a="http://schemas.openxmlformats.org/drawingml/2006/main">
             <a:pPr algn="ctr">
+              <a:buNone/>
               <a:defRPr sz="2100" b="1">
                 <a:solidFill>
                   <a:srgbClr val="263746"/>
@@ -21290,6 +22441,7 @@
           <a:lstStyle xmlns:a="http://schemas.openxmlformats.org/drawingml/2006/main"/>
           <a:p xmlns:a="http://schemas.openxmlformats.org/drawingml/2006/main">
             <a:pPr algn="ctr">
+              <a:buNone/>
               <a:defRPr sz="2100" b="1">
                 <a:solidFill>
                   <a:srgbClr val="667684"/>
@@ -21343,6 +22495,7 @@
           <a:lstStyle xmlns:a="http://schemas.openxmlformats.org/drawingml/2006/main"/>
           <a:p xmlns:a="http://schemas.openxmlformats.org/drawingml/2006/main">
             <a:pPr algn="ctr">
+              <a:buNone/>
               <a:defRPr sz="1725" b="1">
                 <a:solidFill>
                   <a:srgbClr val="18354E"/>
@@ -21398,6 +22551,7 @@
           <a:lstStyle xmlns:a="http://schemas.openxmlformats.org/drawingml/2006/main"/>
           <a:p xmlns:a="http://schemas.openxmlformats.org/drawingml/2006/main">
             <a:pPr algn="ctr">
+              <a:buNone/>
               <a:defRPr sz="2100" b="1">
                 <a:solidFill>
                   <a:srgbClr val="263746"/>
@@ -21451,6 +22605,7 @@
           <a:lstStyle xmlns:a="http://schemas.openxmlformats.org/drawingml/2006/main"/>
           <a:p xmlns:a="http://schemas.openxmlformats.org/drawingml/2006/main">
             <a:pPr algn="ctr">
+              <a:buNone/>
               <a:defRPr sz="1725" b="1">
                 <a:solidFill>
                   <a:srgbClr val="C8161E"/>
@@ -21506,6 +22661,7 @@
           <a:lstStyle xmlns:a="http://schemas.openxmlformats.org/drawingml/2006/main"/>
           <a:p xmlns:a="http://schemas.openxmlformats.org/drawingml/2006/main">
             <a:pPr algn="ctr">
+              <a:buNone/>
               <a:defRPr sz="2100" b="1">
                 <a:solidFill>
                   <a:srgbClr val="C8161E"/>
@@ -21590,6 +22746,7 @@
           <a:lstStyle xmlns:a="http://schemas.openxmlformats.org/drawingml/2006/main"/>
           <a:p xmlns:a="http://schemas.openxmlformats.org/drawingml/2006/main">
             <a:pPr algn="ctr">
+              <a:buNone/>
               <a:defRPr sz="1575" b="1">
                 <a:solidFill>
                   <a:srgbClr val="C8161E"/>
@@ -21643,6 +22800,7 @@
           <a:lstStyle xmlns:a="http://schemas.openxmlformats.org/drawingml/2006/main"/>
           <a:p xmlns:a="http://schemas.openxmlformats.org/drawingml/2006/main">
             <a:pPr algn="ctr">
+              <a:buNone/>
               <a:defRPr sz="2025" b="1">
                 <a:solidFill>
                   <a:srgbClr val="C8161E"/>
@@ -21711,7 +22869,9 @@
           <a:bodyPr xmlns:a="http://schemas.openxmlformats.org/drawingml/2006/main" lIns="76200" tIns="0" rIns="76200" bIns="0" anchor="ctr"/>
           <a:lstStyle xmlns:a="http://schemas.openxmlformats.org/drawingml/2006/main"/>
           <a:p xmlns:a="http://schemas.openxmlformats.org/drawingml/2006/main">
-            <a:pPr algn="l"/>
+            <a:pPr algn="l">
+              <a:buNone/>
+            </a:pPr>
             <a:r>
               <a:rPr sz="2250" b="1">
                 <a:solidFill>
@@ -21790,6 +22950,7 @@
           <a:lstStyle xmlns:a="http://schemas.openxmlformats.org/drawingml/2006/main"/>
           <a:p xmlns:a="http://schemas.openxmlformats.org/drawingml/2006/main">
             <a:pPr algn="ctr">
+              <a:buNone/>
               <a:defRPr sz="2175" b="1">
                 <a:solidFill>
                   <a:srgbClr val="28745A"/>
@@ -21845,6 +23006,7 @@
           <a:lstStyle xmlns:a="http://schemas.openxmlformats.org/drawingml/2006/main"/>
           <a:p xmlns:a="http://schemas.openxmlformats.org/drawingml/2006/main">
             <a:pPr algn="ctr">
+              <a:buNone/>
               <a:defRPr sz="1875" b="1">
                 <a:solidFill>
                   <a:srgbClr val="263746"/>
@@ -21900,6 +23062,7 @@
           <a:lstStyle xmlns:a="http://schemas.openxmlformats.org/drawingml/2006/main"/>
           <a:p xmlns:a="http://schemas.openxmlformats.org/drawingml/2006/main">
             <a:pPr algn="ctr">
+              <a:buNone/>
               <a:defRPr sz="2175" b="1">
                 <a:solidFill>
                   <a:srgbClr val="A86C12"/>
@@ -21955,6 +23118,7 @@
           <a:lstStyle xmlns:a="http://schemas.openxmlformats.org/drawingml/2006/main"/>
           <a:p xmlns:a="http://schemas.openxmlformats.org/drawingml/2006/main">
             <a:pPr algn="ctr">
+              <a:buNone/>
               <a:defRPr sz="1875" b="1">
                 <a:solidFill>
                   <a:srgbClr val="263746"/>
@@ -22010,6 +23174,7 @@
           <a:lstStyle xmlns:a="http://schemas.openxmlformats.org/drawingml/2006/main"/>
           <a:p xmlns:a="http://schemas.openxmlformats.org/drawingml/2006/main">
             <a:pPr algn="ctr">
+              <a:buNone/>
               <a:defRPr sz="2175" b="1">
                 <a:solidFill>
                   <a:srgbClr val="C8161E"/>
@@ -22065,6 +23230,7 @@
           <a:lstStyle xmlns:a="http://schemas.openxmlformats.org/drawingml/2006/main"/>
           <a:p xmlns:a="http://schemas.openxmlformats.org/drawingml/2006/main">
             <a:pPr algn="ctr">
+              <a:buNone/>
               <a:defRPr sz="1875" b="1">
                 <a:solidFill>
                   <a:srgbClr val="263746"/>
@@ -22118,6 +23284,7 @@
           <a:lstStyle xmlns:a="http://schemas.openxmlformats.org/drawingml/2006/main"/>
           <a:p xmlns:a="http://schemas.openxmlformats.org/drawingml/2006/main">
             <a:pPr algn="ctr">
+              <a:buNone/>
               <a:defRPr sz="1575" b="1">
                 <a:solidFill>
                   <a:srgbClr val="18354E"/>
@@ -22186,7 +23353,9 @@
           <a:bodyPr xmlns:a="http://schemas.openxmlformats.org/drawingml/2006/main" lIns="76200" tIns="0" rIns="76200" bIns="0" anchor="ctr"/>
           <a:lstStyle xmlns:a="http://schemas.openxmlformats.org/drawingml/2006/main"/>
           <a:p xmlns:a="http://schemas.openxmlformats.org/drawingml/2006/main">
-            <a:pPr algn="l"/>
+            <a:pPr algn="l">
+              <a:buNone/>
+            </a:pPr>
             <a:r>
               <a:rPr sz="2250" b="1">
                 <a:solidFill>
@@ -22263,6 +23432,7 @@
           <a:lstStyle xmlns:a="http://schemas.openxmlformats.org/drawingml/2006/main"/>
           <a:p xmlns:a="http://schemas.openxmlformats.org/drawingml/2006/main">
             <a:pPr algn="ctr">
+              <a:buNone/>
               <a:defRPr sz="1950" b="1">
                 <a:solidFill>
                   <a:srgbClr val="18354E"/>
@@ -22316,6 +23486,7 @@
           <a:lstStyle xmlns:a="http://schemas.openxmlformats.org/drawingml/2006/main"/>
           <a:p xmlns:a="http://schemas.openxmlformats.org/drawingml/2006/main">
             <a:pPr algn="ctr">
+              <a:buNone/>
               <a:defRPr sz="1950" b="1">
                 <a:solidFill>
                   <a:srgbClr val="C8161E"/>
@@ -22371,6 +23542,7 @@
           <a:lstStyle xmlns:a="http://schemas.openxmlformats.org/drawingml/2006/main"/>
           <a:p xmlns:a="http://schemas.openxmlformats.org/drawingml/2006/main">
             <a:pPr algn="ctr">
+              <a:buNone/>
               <a:defRPr sz="2025" b="1">
                 <a:solidFill>
                   <a:srgbClr val="263746"/>
@@ -22391,6 +23563,7 @@
           </a:p>
           <a:p xmlns:a="http://schemas.openxmlformats.org/drawingml/2006/main">
             <a:pPr algn="ctr">
+              <a:buNone/>
               <a:defRPr sz="2025" b="1">
                 <a:solidFill>
                   <a:srgbClr val="263746"/>
@@ -22446,6 +23619,7 @@
           <a:lstStyle xmlns:a="http://schemas.openxmlformats.org/drawingml/2006/main"/>
           <a:p xmlns:a="http://schemas.openxmlformats.org/drawingml/2006/main">
             <a:pPr algn="ctr">
+              <a:buNone/>
               <a:defRPr sz="2025" b="1">
                 <a:solidFill>
                   <a:srgbClr val="C8161E"/>
@@ -22466,6 +23640,7 @@
           </a:p>
           <a:p xmlns:a="http://schemas.openxmlformats.org/drawingml/2006/main">
             <a:pPr algn="ctr">
+              <a:buNone/>
               <a:defRPr sz="2025" b="1">
                 <a:solidFill>
                   <a:srgbClr val="C8161E"/>
@@ -22521,6 +23696,7 @@
           <a:lstStyle xmlns:a="http://schemas.openxmlformats.org/drawingml/2006/main"/>
           <a:p xmlns:a="http://schemas.openxmlformats.org/drawingml/2006/main">
             <a:pPr algn="ctr">
+              <a:buNone/>
               <a:defRPr sz="1725" b="1">
                 <a:solidFill>
                   <a:srgbClr val="18354E"/>
@@ -22576,6 +23752,7 @@
           <a:lstStyle xmlns:a="http://schemas.openxmlformats.org/drawingml/2006/main"/>
           <a:p xmlns:a="http://schemas.openxmlformats.org/drawingml/2006/main">
             <a:pPr algn="ctr">
+              <a:buNone/>
               <a:defRPr sz="1650" b="1">
                 <a:solidFill>
                   <a:srgbClr val="28745A"/>

</xml_diff>